<commit_message>
feat: implement core PPTX templating engine with Z-order management and documentation support
</commit_message>
<xml_diff>
--- a/templates/sample.pptx
+++ b/templates/sample.pptx
@@ -5366,6 +5366,52 @@
       </p:grpSpPr>
       <p:sp>
         <p:nvSpPr>
+          <p:cNvPr id="3" name="Shape">
+            <a:extLst>
+              <a:ext uri="{FF2B5EF4-FFF2-40B4-BE49-F238E27FC236}">
+                <a16:creationId xmlns:a16="http://schemas.microsoft.com/office/drawing/2014/main" id="{083EB01B-1DB3-3769-731D-AB321C5367ED}"/>
+              </a:ext>
+            </a:extLst>
+          </p:cNvPr>
+          <p:cNvSpPr/>
+          <p:nvPr/>
+        </p:nvSpPr>
+        <p:spPr>
+          <a:xfrm>
+            <a:off x="694592" y="545123"/>
+            <a:ext cx="10659208" cy="5750169"/>
+          </a:xfrm>
+          <a:prstGeom prst="roundRect">
+            <a:avLst/>
+          </a:prstGeom>
+        </p:spPr>
+        <p:style>
+          <a:lnRef idx="2">
+            <a:schemeClr val="accent3">
+              <a:shade val="15000"/>
+            </a:schemeClr>
+          </a:lnRef>
+          <a:fillRef idx="1">
+            <a:schemeClr val="accent3"/>
+          </a:fillRef>
+          <a:effectRef idx="0">
+            <a:schemeClr val="accent3"/>
+          </a:effectRef>
+          <a:fontRef idx="minor">
+            <a:schemeClr val="lt1"/>
+          </a:fontRef>
+        </p:style>
+        <p:txBody>
+          <a:bodyPr rtlCol="0" anchor="ctr"/>
+          <a:lstStyle/>
+          <a:p>
+            <a:pPr algn="ctr"/>
+            <a:endParaRPr lang="en-IN"/>
+          </a:p>
+        </p:txBody>
+      </p:sp>
+      <p:sp>
+        <p:nvSpPr>
           <p:cNvPr id="2" name="Title">
             <a:extLst>
               <a:ext uri="{FF2B5EF4-FFF2-40B4-BE49-F238E27FC236}">

</xml_diff>

<commit_message>
feat: implement chart data labeling support and expand documentation ecosystem
</commit_message>
<xml_diff>
--- a/templates/sample.pptx
+++ b/templates/sample.pptx
@@ -8,6 +8,7 @@
     <p:sldId id="256" r:id="rId2"/>
     <p:sldId id="257" r:id="rId3"/>
     <p:sldId id="258" r:id="rId4"/>
+    <p:sldId id="259" r:id="rId5"/>
   </p:sldIdLst>
   <p:sldSz cx="12192000" cy="6858000"/>
   <p:notesSz cx="6858000" cy="9144000"/>
@@ -118,6 +119,7 @@
         <p14:section name="Untitled Section" id="{A3775758-1637-48C8-9754-A5DF8ED68B74}">
           <p14:sldIdLst>
             <p14:sldId id="258"/>
+            <p14:sldId id="259"/>
           </p14:sldIdLst>
         </p14:section>
       </p14:sectionLst>
@@ -204,6 +206,64 @@
             <a:effectLst/>
           </c:spPr>
           <c:invertIfNegative val="0"/>
+          <c:dLbls>
+            <c:spPr>
+              <a:noFill/>
+              <a:ln>
+                <a:noFill/>
+              </a:ln>
+              <a:effectLst/>
+            </c:spPr>
+            <c:txPr>
+              <a:bodyPr rot="0" spcFirstLastPara="1" vertOverflow="ellipsis" vert="horz" wrap="square" lIns="38100" tIns="19050" rIns="38100" bIns="19050" anchor="ctr" anchorCtr="1">
+                <a:spAutoFit/>
+              </a:bodyPr>
+              <a:lstStyle/>
+              <a:p>
+                <a:pPr>
+                  <a:defRPr sz="2400" b="0" i="0" u="none" strike="noStrike" kern="1200" baseline="0">
+                    <a:solidFill>
+                      <a:schemeClr val="tx1">
+                        <a:lumMod val="75000"/>
+                        <a:lumOff val="25000"/>
+                      </a:schemeClr>
+                    </a:solidFill>
+                    <a:latin typeface="Adobe Garamond Pro Bold" panose="02020702060506020403" pitchFamily="18" charset="0"/>
+                    <a:ea typeface="+mn-ea"/>
+                    <a:cs typeface="+mn-cs"/>
+                  </a:defRPr>
+                </a:pPr>
+                <a:endParaRPr lang="en-US"/>
+              </a:p>
+            </c:txPr>
+            <c:dLblPos val="outEnd"/>
+            <c:showLegendKey val="0"/>
+            <c:showVal val="1"/>
+            <c:showCatName val="0"/>
+            <c:showSerName val="0"/>
+            <c:showPercent val="0"/>
+            <c:showBubbleSize val="0"/>
+            <c:showLeaderLines val="0"/>
+            <c:extLst>
+              <c:ext xmlns:c15="http://schemas.microsoft.com/office/drawing/2012/chart" uri="{CE6537A1-D6FC-4f65-9D91-7224C49458BB}">
+                <c15:showLeaderLines val="1"/>
+                <c15:leaderLines>
+                  <c:spPr>
+                    <a:ln w="9525" cap="flat" cmpd="sng" algn="ctr">
+                      <a:solidFill>
+                        <a:schemeClr val="tx1">
+                          <a:lumMod val="35000"/>
+                          <a:lumOff val="65000"/>
+                        </a:schemeClr>
+                      </a:solidFill>
+                      <a:round/>
+                    </a:ln>
+                    <a:effectLst/>
+                  </c:spPr>
+                </c15:leaderLines>
+              </c:ext>
+            </c:extLst>
+          </c:dLbls>
           <c:cat>
             <c:strRef>
               <c:f>Sheet1!$A$2:$A$5</c:f>
@@ -275,6 +335,64 @@
             <a:effectLst/>
           </c:spPr>
           <c:invertIfNegative val="0"/>
+          <c:dLbls>
+            <c:spPr>
+              <a:noFill/>
+              <a:ln>
+                <a:noFill/>
+              </a:ln>
+              <a:effectLst/>
+            </c:spPr>
+            <c:txPr>
+              <a:bodyPr rot="0" spcFirstLastPara="1" vertOverflow="ellipsis" vert="horz" wrap="square" lIns="38100" tIns="19050" rIns="38100" bIns="19050" anchor="ctr" anchorCtr="1">
+                <a:spAutoFit/>
+              </a:bodyPr>
+              <a:lstStyle/>
+              <a:p>
+                <a:pPr>
+                  <a:defRPr sz="1197" b="0" i="0" u="none" strike="noStrike" kern="1200" baseline="0">
+                    <a:solidFill>
+                      <a:schemeClr val="tx1">
+                        <a:lumMod val="75000"/>
+                        <a:lumOff val="25000"/>
+                      </a:schemeClr>
+                    </a:solidFill>
+                    <a:latin typeface="+mn-lt"/>
+                    <a:ea typeface="+mn-ea"/>
+                    <a:cs typeface="+mn-cs"/>
+                  </a:defRPr>
+                </a:pPr>
+                <a:endParaRPr lang="en-US"/>
+              </a:p>
+            </c:txPr>
+            <c:dLblPos val="outEnd"/>
+            <c:showLegendKey val="0"/>
+            <c:showVal val="1"/>
+            <c:showCatName val="0"/>
+            <c:showSerName val="0"/>
+            <c:showPercent val="0"/>
+            <c:showBubbleSize val="0"/>
+            <c:showLeaderLines val="0"/>
+            <c:extLst>
+              <c:ext xmlns:c15="http://schemas.microsoft.com/office/drawing/2012/chart" uri="{CE6537A1-D6FC-4f65-9D91-7224C49458BB}">
+                <c15:showLeaderLines val="1"/>
+                <c15:leaderLines>
+                  <c:spPr>
+                    <a:ln w="9525" cap="flat" cmpd="sng" algn="ctr">
+                      <a:solidFill>
+                        <a:schemeClr val="tx1">
+                          <a:lumMod val="35000"/>
+                          <a:lumOff val="65000"/>
+                        </a:schemeClr>
+                      </a:solidFill>
+                      <a:round/>
+                    </a:ln>
+                    <a:effectLst/>
+                  </c:spPr>
+                </c15:leaderLines>
+              </c:ext>
+            </c:extLst>
+          </c:dLbls>
           <c:cat>
             <c:strRef>
               <c:f>Sheet1!$A$2:$A$5</c:f>
@@ -338,7 +456,7 @@
           </c:tx>
           <c:spPr>
             <a:solidFill>
-              <a:schemeClr val="accent3"/>
+              <a:schemeClr val="accent6"/>
             </a:solidFill>
             <a:ln>
               <a:noFill/>
@@ -346,6 +464,64 @@
             <a:effectLst/>
           </c:spPr>
           <c:invertIfNegative val="0"/>
+          <c:dLbls>
+            <c:spPr>
+              <a:noFill/>
+              <a:ln>
+                <a:noFill/>
+              </a:ln>
+              <a:effectLst/>
+            </c:spPr>
+            <c:txPr>
+              <a:bodyPr rot="0" spcFirstLastPara="1" vertOverflow="ellipsis" vert="horz" wrap="square" lIns="38100" tIns="19050" rIns="38100" bIns="19050" anchor="ctr" anchorCtr="1">
+                <a:spAutoFit/>
+              </a:bodyPr>
+              <a:lstStyle/>
+              <a:p>
+                <a:pPr>
+                  <a:defRPr sz="1197" b="0" i="0" u="none" strike="noStrike" kern="1200" baseline="0">
+                    <a:solidFill>
+                      <a:schemeClr val="tx1">
+                        <a:lumMod val="75000"/>
+                        <a:lumOff val="25000"/>
+                      </a:schemeClr>
+                    </a:solidFill>
+                    <a:latin typeface="+mn-lt"/>
+                    <a:ea typeface="+mn-ea"/>
+                    <a:cs typeface="+mn-cs"/>
+                  </a:defRPr>
+                </a:pPr>
+                <a:endParaRPr lang="en-US"/>
+              </a:p>
+            </c:txPr>
+            <c:dLblPos val="outEnd"/>
+            <c:showLegendKey val="0"/>
+            <c:showVal val="1"/>
+            <c:showCatName val="0"/>
+            <c:showSerName val="0"/>
+            <c:showPercent val="0"/>
+            <c:showBubbleSize val="0"/>
+            <c:showLeaderLines val="0"/>
+            <c:extLst>
+              <c:ext xmlns:c15="http://schemas.microsoft.com/office/drawing/2012/chart" uri="{CE6537A1-D6FC-4f65-9D91-7224C49458BB}">
+                <c15:showLeaderLines val="1"/>
+                <c15:leaderLines>
+                  <c:spPr>
+                    <a:ln w="9525" cap="flat" cmpd="sng" algn="ctr">
+                      <a:solidFill>
+                        <a:schemeClr val="tx1">
+                          <a:lumMod val="35000"/>
+                          <a:lumOff val="65000"/>
+                        </a:schemeClr>
+                      </a:solidFill>
+                      <a:round/>
+                    </a:ln>
+                    <a:effectLst/>
+                  </c:spPr>
+                </c15:leaderLines>
+              </c:ext>
+            </c:extLst>
+          </c:dLbls>
           <c:cat>
             <c:strRef>
               <c:f>Sheet1!$A$2:$A$5</c:f>
@@ -394,8 +570,9 @@
           </c:extLst>
         </c:ser>
         <c:dLbls>
+          <c:dLblPos val="outEnd"/>
           <c:showLegendKey val="0"/>
-          <c:showVal val="0"/>
+          <c:showVal val="1"/>
           <c:showCatName val="0"/>
           <c:showSerName val="0"/>
           <c:showPercent val="0"/>
@@ -1043,6 +1220,749 @@
 </c:chartSpace>
 </file>
 
+<file path=ppt/charts/chart3.xml><?xml version="1.0" encoding="utf-8"?>
+<c:chartSpace xmlns:c="http://schemas.openxmlformats.org/drawingml/2006/chart" xmlns:a="http://schemas.openxmlformats.org/drawingml/2006/main" xmlns:r="http://schemas.openxmlformats.org/officeDocument/2006/relationships" xmlns:c16r2="http://schemas.microsoft.com/office/drawing/2015/06/chart">
+  <c:date1904 val="0"/>
+  <c:lang val="en-US"/>
+  <c:roundedCorners val="0"/>
+  <mc:AlternateContent xmlns:mc="http://schemas.openxmlformats.org/markup-compatibility/2006">
+    <mc:Choice xmlns:c14="http://schemas.microsoft.com/office/drawing/2007/8/2/chart" Requires="c14">
+      <c14:style val="102"/>
+    </mc:Choice>
+    <mc:Fallback>
+      <c:style val="2"/>
+    </mc:Fallback>
+  </mc:AlternateContent>
+  <c:chart>
+    <c:autoTitleDeleted val="0"/>
+    <c:plotArea>
+      <c:layout/>
+      <c:barChart>
+        <c:barDir val="col"/>
+        <c:grouping val="stacked"/>
+        <c:varyColors val="0"/>
+        <c:ser>
+          <c:idx val="0"/>
+          <c:order val="0"/>
+          <c:tx>
+            <c:strRef>
+              <c:f>Sheet1!$B$1</c:f>
+              <c:strCache>
+                <c:ptCount val="1"/>
+                <c:pt idx="0">
+                  <c:v>Series 1</c:v>
+                </c:pt>
+              </c:strCache>
+            </c:strRef>
+          </c:tx>
+          <c:spPr>
+            <a:solidFill>
+              <a:schemeClr val="accent1"/>
+            </a:solidFill>
+            <a:ln>
+              <a:noFill/>
+            </a:ln>
+            <a:effectLst/>
+          </c:spPr>
+          <c:invertIfNegative val="0"/>
+          <c:dLbls>
+            <c:dLbl>
+              <c:idx val="0"/>
+              <c:tx>
+                <c:rich>
+                  <a:bodyPr/>
+                  <a:lstStyle/>
+                  <a:p>
+                    <a:fld id="{5724EE2C-8685-4063-B888-F16F2237B0FB}" type="CELLRANGE">
+                      <a:rPr lang="en-US"/>
+                      <a:pPr/>
+                      <a:t>[CELLRANGE]</a:t>
+                    </a:fld>
+                    <a:endParaRPr lang="en-IN"/>
+                  </a:p>
+                </c:rich>
+              </c:tx>
+              <c:dLblPos val="ctr"/>
+              <c:showLegendKey val="0"/>
+              <c:showVal val="0"/>
+              <c:showCatName val="0"/>
+              <c:showSerName val="0"/>
+              <c:showPercent val="0"/>
+              <c:showBubbleSize val="0"/>
+              <c:extLst>
+                <c:ext xmlns:c15="http://schemas.microsoft.com/office/drawing/2012/chart" uri="{CE6537A1-D6FC-4f65-9D91-7224C49458BB}">
+                  <c15:dlblFieldTable/>
+                  <c15:showDataLabelsRange val="1"/>
+                </c:ext>
+                <c:ext xmlns:c16="http://schemas.microsoft.com/office/drawing/2014/chart" uri="{C3380CC4-5D6E-409C-BE32-E72D297353CC}">
+                  <c16:uniqueId val="{00000006-9D08-4425-99DE-4E5501F36EC7}"/>
+                </c:ext>
+              </c:extLst>
+            </c:dLbl>
+            <c:spPr>
+              <a:noFill/>
+              <a:ln>
+                <a:noFill/>
+              </a:ln>
+              <a:effectLst/>
+            </c:spPr>
+            <c:txPr>
+              <a:bodyPr rot="0" spcFirstLastPara="1" vertOverflow="ellipsis" vert="horz" wrap="square" lIns="38100" tIns="19050" rIns="38100" bIns="19050" anchor="ctr" anchorCtr="1">
+                <a:spAutoFit/>
+              </a:bodyPr>
+              <a:lstStyle/>
+              <a:p>
+                <a:pPr>
+                  <a:defRPr sz="2400" b="0" i="0" u="none" strike="noStrike" kern="1200" baseline="0">
+                    <a:solidFill>
+                      <a:schemeClr val="tx1">
+                        <a:lumMod val="75000"/>
+                        <a:lumOff val="25000"/>
+                      </a:schemeClr>
+                    </a:solidFill>
+                    <a:latin typeface="+mn-lt"/>
+                    <a:ea typeface="+mn-ea"/>
+                    <a:cs typeface="+mn-cs"/>
+                  </a:defRPr>
+                </a:pPr>
+                <a:endParaRPr lang="en-US"/>
+              </a:p>
+            </c:txPr>
+            <c:dLblPos val="ctr"/>
+            <c:showLegendKey val="0"/>
+            <c:showVal val="0"/>
+            <c:showCatName val="0"/>
+            <c:showSerName val="0"/>
+            <c:showPercent val="0"/>
+            <c:showBubbleSize val="0"/>
+            <c:showLeaderLines val="0"/>
+            <c:extLst>
+              <c:ext xmlns:c15="http://schemas.microsoft.com/office/drawing/2012/chart" uri="{CE6537A1-D6FC-4f65-9D91-7224C49458BB}">
+                <c15:showDataLabelsRange val="1"/>
+                <c15:showLeaderLines val="1"/>
+                <c15:leaderLines>
+                  <c:spPr>
+                    <a:ln w="9525" cap="flat" cmpd="sng" algn="ctr">
+                      <a:solidFill>
+                        <a:schemeClr val="tx1">
+                          <a:lumMod val="35000"/>
+                          <a:lumOff val="65000"/>
+                        </a:schemeClr>
+                      </a:solidFill>
+                      <a:round/>
+                    </a:ln>
+                    <a:effectLst/>
+                  </c:spPr>
+                </c15:leaderLines>
+              </c:ext>
+            </c:extLst>
+          </c:dLbls>
+          <c:cat>
+            <c:strRef>
+              <c:f>Sheet1!$A$2</c:f>
+              <c:strCache>
+                <c:ptCount val="1"/>
+                <c:pt idx="0">
+                  <c:v>Category 1</c:v>
+                </c:pt>
+              </c:strCache>
+            </c:strRef>
+          </c:cat>
+          <c:val>
+            <c:numRef>
+              <c:f>Sheet1!$B$2</c:f>
+              <c:numCache>
+                <c:formatCode>General</c:formatCode>
+                <c:ptCount val="1"/>
+                <c:pt idx="0">
+                  <c:v>4.3</c:v>
+                </c:pt>
+              </c:numCache>
+            </c:numRef>
+          </c:val>
+          <c:extLst>
+            <c:ext xmlns:c15="http://schemas.microsoft.com/office/drawing/2012/chart" uri="{02D57815-91ED-43cb-92C2-25804820EDAC}">
+              <c15:datalabelsRange>
+                <c15:f>Sheet1!$B$3:$E$3</c15:f>
+                <c15:dlblRangeCache>
+                  <c:ptCount val="4"/>
+                  <c:pt idx="0">
+                    <c:v>4.3 (29.05%)</c:v>
+                  </c:pt>
+                  <c:pt idx="1">
+                    <c:v>2.5 (16.89%)</c:v>
+                  </c:pt>
+                  <c:pt idx="2">
+                    <c:v>3.5 (23.65%)</c:v>
+                  </c:pt>
+                  <c:pt idx="3">
+                    <c:v>4.5 (30.41%)</c:v>
+                  </c:pt>
+                </c15:dlblRangeCache>
+              </c15:datalabelsRange>
+            </c:ext>
+            <c:ext xmlns:c16="http://schemas.microsoft.com/office/drawing/2014/chart" uri="{C3380CC4-5D6E-409C-BE32-E72D297353CC}">
+              <c16:uniqueId val="{00000000-9D08-4425-99DE-4E5501F36EC7}"/>
+            </c:ext>
+          </c:extLst>
+        </c:ser>
+        <c:ser>
+          <c:idx val="1"/>
+          <c:order val="1"/>
+          <c:tx>
+            <c:strRef>
+              <c:f>Sheet1!$C$1</c:f>
+              <c:strCache>
+                <c:ptCount val="1"/>
+                <c:pt idx="0">
+                  <c:v>Series 2</c:v>
+                </c:pt>
+              </c:strCache>
+            </c:strRef>
+          </c:tx>
+          <c:spPr>
+            <a:solidFill>
+              <a:schemeClr val="accent2"/>
+            </a:solidFill>
+            <a:ln>
+              <a:noFill/>
+            </a:ln>
+            <a:effectLst/>
+          </c:spPr>
+          <c:invertIfNegative val="0"/>
+          <c:dLbls>
+            <c:dLbl>
+              <c:idx val="0"/>
+              <c:tx>
+                <c:rich>
+                  <a:bodyPr/>
+                  <a:lstStyle/>
+                  <a:p>
+                    <a:fld id="{8C0AF751-1B0F-438E-96A4-C7CFB7E52912}" type="CELLRANGE">
+                      <a:rPr lang="en-US"/>
+                      <a:pPr/>
+                      <a:t>[CELLRANGE]</a:t>
+                    </a:fld>
+                    <a:endParaRPr lang="en-IN"/>
+                  </a:p>
+                </c:rich>
+              </c:tx>
+              <c:dLblPos val="ctr"/>
+              <c:showLegendKey val="0"/>
+              <c:showVal val="0"/>
+              <c:showCatName val="0"/>
+              <c:showSerName val="0"/>
+              <c:showPercent val="0"/>
+              <c:showBubbleSize val="0"/>
+              <c:extLst>
+                <c:ext xmlns:c15="http://schemas.microsoft.com/office/drawing/2012/chart" uri="{CE6537A1-D6FC-4f65-9D91-7224C49458BB}">
+                  <c15:dlblFieldTable/>
+                  <c15:showDataLabelsRange val="1"/>
+                </c:ext>
+                <c:ext xmlns:c16="http://schemas.microsoft.com/office/drawing/2014/chart" uri="{C3380CC4-5D6E-409C-BE32-E72D297353CC}">
+                  <c16:uniqueId val="{00000007-9D08-4425-99DE-4E5501F36EC7}"/>
+                </c:ext>
+              </c:extLst>
+            </c:dLbl>
+            <c:spPr>
+              <a:noFill/>
+              <a:ln>
+                <a:noFill/>
+              </a:ln>
+              <a:effectLst/>
+            </c:spPr>
+            <c:txPr>
+              <a:bodyPr rot="0" spcFirstLastPara="1" vertOverflow="ellipsis" vert="horz" wrap="square" lIns="38100" tIns="19050" rIns="38100" bIns="19050" anchor="ctr" anchorCtr="1">
+                <a:spAutoFit/>
+              </a:bodyPr>
+              <a:lstStyle/>
+              <a:p>
+                <a:pPr>
+                  <a:defRPr sz="2400" b="0" i="0" u="none" strike="noStrike" kern="1200" baseline="0">
+                    <a:solidFill>
+                      <a:schemeClr val="tx1">
+                        <a:lumMod val="75000"/>
+                        <a:lumOff val="25000"/>
+                      </a:schemeClr>
+                    </a:solidFill>
+                    <a:latin typeface="+mn-lt"/>
+                    <a:ea typeface="+mn-ea"/>
+                    <a:cs typeface="+mn-cs"/>
+                  </a:defRPr>
+                </a:pPr>
+                <a:endParaRPr lang="en-US"/>
+              </a:p>
+            </c:txPr>
+            <c:dLblPos val="ctr"/>
+            <c:showLegendKey val="0"/>
+            <c:showVal val="0"/>
+            <c:showCatName val="0"/>
+            <c:showSerName val="0"/>
+            <c:showPercent val="0"/>
+            <c:showBubbleSize val="0"/>
+            <c:showLeaderLines val="0"/>
+            <c:extLst>
+              <c:ext xmlns:c15="http://schemas.microsoft.com/office/drawing/2012/chart" uri="{CE6537A1-D6FC-4f65-9D91-7224C49458BB}">
+                <c15:showDataLabelsRange val="1"/>
+                <c15:showLeaderLines val="1"/>
+                <c15:leaderLines>
+                  <c:spPr>
+                    <a:ln w="9525" cap="flat" cmpd="sng" algn="ctr">
+                      <a:solidFill>
+                        <a:schemeClr val="tx1">
+                          <a:lumMod val="35000"/>
+                          <a:lumOff val="65000"/>
+                        </a:schemeClr>
+                      </a:solidFill>
+                      <a:round/>
+                    </a:ln>
+                    <a:effectLst/>
+                  </c:spPr>
+                </c15:leaderLines>
+              </c:ext>
+            </c:extLst>
+          </c:dLbls>
+          <c:cat>
+            <c:strRef>
+              <c:f>Sheet1!$A$2</c:f>
+              <c:strCache>
+                <c:ptCount val="1"/>
+                <c:pt idx="0">
+                  <c:v>Category 1</c:v>
+                </c:pt>
+              </c:strCache>
+            </c:strRef>
+          </c:cat>
+          <c:val>
+            <c:numRef>
+              <c:f>Sheet1!$C$2</c:f>
+              <c:numCache>
+                <c:formatCode>General</c:formatCode>
+                <c:ptCount val="1"/>
+                <c:pt idx="0">
+                  <c:v>2.5</c:v>
+                </c:pt>
+              </c:numCache>
+            </c:numRef>
+          </c:val>
+          <c:extLst>
+            <c:ext xmlns:c15="http://schemas.microsoft.com/office/drawing/2012/chart" uri="{02D57815-91ED-43cb-92C2-25804820EDAC}">
+              <c15:datalabelsRange>
+                <c15:f>Sheet1!$C$3</c15:f>
+                <c15:dlblRangeCache>
+                  <c:ptCount val="1"/>
+                  <c:pt idx="0">
+                    <c:v>2.5 (16.89%)</c:v>
+                  </c:pt>
+                </c15:dlblRangeCache>
+              </c15:datalabelsRange>
+            </c:ext>
+            <c:ext xmlns:c16="http://schemas.microsoft.com/office/drawing/2014/chart" uri="{C3380CC4-5D6E-409C-BE32-E72D297353CC}">
+              <c16:uniqueId val="{00000003-9D08-4425-99DE-4E5501F36EC7}"/>
+            </c:ext>
+          </c:extLst>
+        </c:ser>
+        <c:ser>
+          <c:idx val="2"/>
+          <c:order val="2"/>
+          <c:tx>
+            <c:strRef>
+              <c:f>Sheet1!$D$1</c:f>
+              <c:strCache>
+                <c:ptCount val="1"/>
+                <c:pt idx="0">
+                  <c:v>Series 3</c:v>
+                </c:pt>
+              </c:strCache>
+            </c:strRef>
+          </c:tx>
+          <c:spPr>
+            <a:solidFill>
+              <a:schemeClr val="accent3"/>
+            </a:solidFill>
+            <a:ln>
+              <a:noFill/>
+            </a:ln>
+            <a:effectLst/>
+          </c:spPr>
+          <c:invertIfNegative val="0"/>
+          <c:dLbls>
+            <c:dLbl>
+              <c:idx val="0"/>
+              <c:tx>
+                <c:rich>
+                  <a:bodyPr/>
+                  <a:lstStyle/>
+                  <a:p>
+                    <a:fld id="{986BA18C-DD07-4545-91E8-F4DE33383886}" type="CELLRANGE">
+                      <a:rPr lang="en-US"/>
+                      <a:pPr/>
+                      <a:t>[CELLRANGE]</a:t>
+                    </a:fld>
+                    <a:endParaRPr lang="en-IN"/>
+                  </a:p>
+                </c:rich>
+              </c:tx>
+              <c:dLblPos val="ctr"/>
+              <c:showLegendKey val="0"/>
+              <c:showVal val="0"/>
+              <c:showCatName val="0"/>
+              <c:showSerName val="0"/>
+              <c:showPercent val="0"/>
+              <c:showBubbleSize val="0"/>
+              <c:extLst>
+                <c:ext xmlns:c15="http://schemas.microsoft.com/office/drawing/2012/chart" uri="{CE6537A1-D6FC-4f65-9D91-7224C49458BB}">
+                  <c15:dlblFieldTable/>
+                  <c15:showDataLabelsRange val="1"/>
+                </c:ext>
+                <c:ext xmlns:c16="http://schemas.microsoft.com/office/drawing/2014/chart" uri="{C3380CC4-5D6E-409C-BE32-E72D297353CC}">
+                  <c16:uniqueId val="{00000008-9D08-4425-99DE-4E5501F36EC7}"/>
+                </c:ext>
+              </c:extLst>
+            </c:dLbl>
+            <c:spPr>
+              <a:noFill/>
+              <a:ln>
+                <a:noFill/>
+              </a:ln>
+              <a:effectLst/>
+            </c:spPr>
+            <c:txPr>
+              <a:bodyPr rot="0" spcFirstLastPara="1" vertOverflow="ellipsis" vert="horz" wrap="square" lIns="38100" tIns="19050" rIns="38100" bIns="19050" anchor="ctr" anchorCtr="1">
+                <a:spAutoFit/>
+              </a:bodyPr>
+              <a:lstStyle/>
+              <a:p>
+                <a:pPr>
+                  <a:defRPr sz="2400" b="0" i="0" u="none" strike="noStrike" kern="1200" baseline="0">
+                    <a:solidFill>
+                      <a:schemeClr val="tx1">
+                        <a:lumMod val="75000"/>
+                        <a:lumOff val="25000"/>
+                      </a:schemeClr>
+                    </a:solidFill>
+                    <a:latin typeface="+mn-lt"/>
+                    <a:ea typeface="+mn-ea"/>
+                    <a:cs typeface="+mn-cs"/>
+                  </a:defRPr>
+                </a:pPr>
+                <a:endParaRPr lang="en-US"/>
+              </a:p>
+            </c:txPr>
+            <c:dLblPos val="ctr"/>
+            <c:showLegendKey val="0"/>
+            <c:showVal val="0"/>
+            <c:showCatName val="0"/>
+            <c:showSerName val="0"/>
+            <c:showPercent val="0"/>
+            <c:showBubbleSize val="0"/>
+            <c:showLeaderLines val="0"/>
+            <c:extLst>
+              <c:ext xmlns:c15="http://schemas.microsoft.com/office/drawing/2012/chart" uri="{CE6537A1-D6FC-4f65-9D91-7224C49458BB}">
+                <c15:showDataLabelsRange val="1"/>
+                <c15:showLeaderLines val="1"/>
+                <c15:leaderLines>
+                  <c:spPr>
+                    <a:ln w="9525" cap="flat" cmpd="sng" algn="ctr">
+                      <a:solidFill>
+                        <a:schemeClr val="tx1">
+                          <a:lumMod val="35000"/>
+                          <a:lumOff val="65000"/>
+                        </a:schemeClr>
+                      </a:solidFill>
+                      <a:round/>
+                    </a:ln>
+                    <a:effectLst/>
+                  </c:spPr>
+                </c15:leaderLines>
+              </c:ext>
+            </c:extLst>
+          </c:dLbls>
+          <c:cat>
+            <c:strRef>
+              <c:f>Sheet1!$A$2</c:f>
+              <c:strCache>
+                <c:ptCount val="1"/>
+                <c:pt idx="0">
+                  <c:v>Category 1</c:v>
+                </c:pt>
+              </c:strCache>
+            </c:strRef>
+          </c:cat>
+          <c:val>
+            <c:numRef>
+              <c:f>Sheet1!$D$2</c:f>
+              <c:numCache>
+                <c:formatCode>General</c:formatCode>
+                <c:ptCount val="1"/>
+                <c:pt idx="0">
+                  <c:v>3.5</c:v>
+                </c:pt>
+              </c:numCache>
+            </c:numRef>
+          </c:val>
+          <c:extLst>
+            <c:ext xmlns:c15="http://schemas.microsoft.com/office/drawing/2012/chart" uri="{02D57815-91ED-43cb-92C2-25804820EDAC}">
+              <c15:datalabelsRange>
+                <c15:f>Sheet1!$D$3</c15:f>
+                <c15:dlblRangeCache>
+                  <c:ptCount val="1"/>
+                  <c:pt idx="0">
+                    <c:v>3.5 (23.65%)</c:v>
+                  </c:pt>
+                </c15:dlblRangeCache>
+              </c15:datalabelsRange>
+            </c:ext>
+            <c:ext xmlns:c16="http://schemas.microsoft.com/office/drawing/2014/chart" uri="{C3380CC4-5D6E-409C-BE32-E72D297353CC}">
+              <c16:uniqueId val="{00000004-9D08-4425-99DE-4E5501F36EC7}"/>
+            </c:ext>
+          </c:extLst>
+        </c:ser>
+        <c:ser>
+          <c:idx val="3"/>
+          <c:order val="3"/>
+          <c:tx>
+            <c:strRef>
+              <c:f>Sheet1!$E$1</c:f>
+              <c:strCache>
+                <c:ptCount val="1"/>
+                <c:pt idx="0">
+                  <c:v>Series 4</c:v>
+                </c:pt>
+              </c:strCache>
+            </c:strRef>
+          </c:tx>
+          <c:spPr>
+            <a:solidFill>
+              <a:schemeClr val="accent4"/>
+            </a:solidFill>
+            <a:ln>
+              <a:noFill/>
+            </a:ln>
+            <a:effectLst/>
+          </c:spPr>
+          <c:invertIfNegative val="0"/>
+          <c:dLbls>
+            <c:dLbl>
+              <c:idx val="0"/>
+              <c:tx>
+                <c:rich>
+                  <a:bodyPr/>
+                  <a:lstStyle/>
+                  <a:p>
+                    <a:fld id="{E0EE13D5-2099-4391-ADAB-EECF540A82F2}" type="CELLRANGE">
+                      <a:rPr lang="en-US"/>
+                      <a:pPr/>
+                      <a:t>[CELLRANGE]</a:t>
+                    </a:fld>
+                    <a:endParaRPr lang="en-IN"/>
+                  </a:p>
+                </c:rich>
+              </c:tx>
+              <c:dLblPos val="ctr"/>
+              <c:showLegendKey val="0"/>
+              <c:showVal val="0"/>
+              <c:showCatName val="0"/>
+              <c:showSerName val="0"/>
+              <c:showPercent val="0"/>
+              <c:showBubbleSize val="0"/>
+              <c:extLst>
+                <c:ext xmlns:c15="http://schemas.microsoft.com/office/drawing/2012/chart" uri="{CE6537A1-D6FC-4f65-9D91-7224C49458BB}">
+                  <c15:dlblFieldTable/>
+                  <c15:showDataLabelsRange val="1"/>
+                </c:ext>
+                <c:ext xmlns:c16="http://schemas.microsoft.com/office/drawing/2014/chart" uri="{C3380CC4-5D6E-409C-BE32-E72D297353CC}">
+                  <c16:uniqueId val="{00000009-9D08-4425-99DE-4E5501F36EC7}"/>
+                </c:ext>
+              </c:extLst>
+            </c:dLbl>
+            <c:spPr>
+              <a:noFill/>
+              <a:ln>
+                <a:noFill/>
+              </a:ln>
+              <a:effectLst/>
+            </c:spPr>
+            <c:txPr>
+              <a:bodyPr rot="0" spcFirstLastPara="1" vertOverflow="ellipsis" vert="horz" wrap="square" lIns="38100" tIns="19050" rIns="38100" bIns="19050" anchor="ctr" anchorCtr="1">
+                <a:spAutoFit/>
+              </a:bodyPr>
+              <a:lstStyle/>
+              <a:p>
+                <a:pPr>
+                  <a:defRPr sz="2400" b="0" i="0" u="none" strike="noStrike" kern="1200" baseline="0">
+                    <a:solidFill>
+                      <a:schemeClr val="tx1">
+                        <a:lumMod val="75000"/>
+                        <a:lumOff val="25000"/>
+                      </a:schemeClr>
+                    </a:solidFill>
+                    <a:latin typeface="Adobe Garamond Pro Bold" panose="02020702060506020403" pitchFamily="18" charset="0"/>
+                    <a:ea typeface="+mn-ea"/>
+                    <a:cs typeface="+mn-cs"/>
+                  </a:defRPr>
+                </a:pPr>
+                <a:endParaRPr lang="en-US"/>
+              </a:p>
+            </c:txPr>
+            <c:dLblPos val="ctr"/>
+            <c:showLegendKey val="0"/>
+            <c:showVal val="0"/>
+            <c:showCatName val="0"/>
+            <c:showSerName val="0"/>
+            <c:showPercent val="0"/>
+            <c:showBubbleSize val="0"/>
+            <c:showLeaderLines val="0"/>
+            <c:extLst>
+              <c:ext xmlns:c15="http://schemas.microsoft.com/office/drawing/2012/chart" uri="{CE6537A1-D6FC-4f65-9D91-7224C49458BB}">
+                <c15:showDataLabelsRange val="1"/>
+                <c15:showLeaderLines val="1"/>
+                <c15:leaderLines>
+                  <c:spPr>
+                    <a:ln w="9525" cap="flat" cmpd="sng" algn="ctr">
+                      <a:solidFill>
+                        <a:schemeClr val="tx1">
+                          <a:lumMod val="35000"/>
+                          <a:lumOff val="65000"/>
+                        </a:schemeClr>
+                      </a:solidFill>
+                      <a:round/>
+                    </a:ln>
+                    <a:effectLst/>
+                  </c:spPr>
+                </c15:leaderLines>
+              </c:ext>
+            </c:extLst>
+          </c:dLbls>
+          <c:cat>
+            <c:strRef>
+              <c:f>Sheet1!$A$2</c:f>
+              <c:strCache>
+                <c:ptCount val="1"/>
+                <c:pt idx="0">
+                  <c:v>Category 1</c:v>
+                </c:pt>
+              </c:strCache>
+            </c:strRef>
+          </c:cat>
+          <c:val>
+            <c:numRef>
+              <c:f>Sheet1!$E$2</c:f>
+              <c:numCache>
+                <c:formatCode>General</c:formatCode>
+                <c:ptCount val="1"/>
+                <c:pt idx="0">
+                  <c:v>4.5</c:v>
+                </c:pt>
+              </c:numCache>
+            </c:numRef>
+          </c:val>
+          <c:extLst>
+            <c:ext xmlns:c15="http://schemas.microsoft.com/office/drawing/2012/chart" uri="{02D57815-91ED-43cb-92C2-25804820EDAC}">
+              <c15:datalabelsRange>
+                <c15:f>Sheet1!$E$3</c15:f>
+                <c15:dlblRangeCache>
+                  <c:ptCount val="1"/>
+                  <c:pt idx="0">
+                    <c:v>4.5 (30.41%)</c:v>
+                  </c:pt>
+                </c15:dlblRangeCache>
+              </c15:datalabelsRange>
+            </c:ext>
+            <c:ext xmlns:c16="http://schemas.microsoft.com/office/drawing/2014/chart" uri="{C3380CC4-5D6E-409C-BE32-E72D297353CC}">
+              <c16:uniqueId val="{00000005-9D08-4425-99DE-4E5501F36EC7}"/>
+            </c:ext>
+          </c:extLst>
+        </c:ser>
+        <c:dLbls>
+          <c:dLblPos val="ctr"/>
+          <c:showLegendKey val="0"/>
+          <c:showVal val="1"/>
+          <c:showCatName val="0"/>
+          <c:showSerName val="0"/>
+          <c:showPercent val="0"/>
+          <c:showBubbleSize val="0"/>
+        </c:dLbls>
+        <c:gapWidth val="150"/>
+        <c:overlap val="100"/>
+        <c:axId val="849142544"/>
+        <c:axId val="849167024"/>
+      </c:barChart>
+      <c:catAx>
+        <c:axId val="849142544"/>
+        <c:scaling>
+          <c:orientation val="minMax"/>
+        </c:scaling>
+        <c:delete val="1"/>
+        <c:axPos val="b"/>
+        <c:numFmt formatCode="General" sourceLinked="1"/>
+        <c:majorTickMark val="none"/>
+        <c:minorTickMark val="none"/>
+        <c:tickLblPos val="nextTo"/>
+        <c:crossAx val="849167024"/>
+        <c:crosses val="autoZero"/>
+        <c:auto val="1"/>
+        <c:lblAlgn val="ctr"/>
+        <c:lblOffset val="100"/>
+        <c:noMultiLvlLbl val="0"/>
+      </c:catAx>
+      <c:valAx>
+        <c:axId val="849167024"/>
+        <c:scaling>
+          <c:orientation val="minMax"/>
+        </c:scaling>
+        <c:delete val="1"/>
+        <c:axPos val="l"/>
+        <c:numFmt formatCode="General" sourceLinked="1"/>
+        <c:majorTickMark val="none"/>
+        <c:minorTickMark val="none"/>
+        <c:tickLblPos val="nextTo"/>
+        <c:crossAx val="849142544"/>
+        <c:crosses val="autoZero"/>
+        <c:crossBetween val="between"/>
+      </c:valAx>
+      <c:spPr>
+        <a:noFill/>
+        <a:ln>
+          <a:noFill/>
+        </a:ln>
+        <a:effectLst/>
+      </c:spPr>
+    </c:plotArea>
+    <c:plotVisOnly val="1"/>
+    <c:dispBlanksAs val="gap"/>
+    <c:showDLblsOverMax val="0"/>
+    <c:extLst>
+      <c:ext xmlns:c16r3="http://schemas.microsoft.com/office/drawing/2017/03/chart" uri="{56B9EC1D-385E-4148-901F-78D8002777C0}">
+        <c16r3:dataDisplayOptions16>
+          <c16r3:dispNaAsBlank val="1"/>
+        </c16r3:dataDisplayOptions16>
+      </c:ext>
+    </c:extLst>
+  </c:chart>
+  <c:spPr>
+    <a:noFill/>
+    <a:ln>
+      <a:noFill/>
+    </a:ln>
+    <a:effectLst/>
+  </c:spPr>
+  <c:txPr>
+    <a:bodyPr/>
+    <a:lstStyle/>
+    <a:p>
+      <a:pPr>
+        <a:defRPr/>
+      </a:pPr>
+      <a:endParaRPr lang="en-US"/>
+    </a:p>
+  </c:txPr>
+  <c:externalData r:id="rId3">
+    <c:autoUpdate val="0"/>
+  </c:externalData>
+</c:chartSpace>
+</file>
+
 <file path=ppt/charts/colors1.xml><?xml version="1.0" encoding="utf-8"?>
 <cs:colorStyle xmlns:cs="http://schemas.microsoft.com/office/drawing/2012/chartStyle" xmlns:a="http://schemas.openxmlformats.org/drawingml/2006/main" meth="cycle" id="10">
   <a:schemeClr val="accent1"/>
@@ -1123,6 +2043,46 @@
 </cs:colorStyle>
 </file>
 
+<file path=ppt/charts/colors3.xml><?xml version="1.0" encoding="utf-8"?>
+<cs:colorStyle xmlns:cs="http://schemas.microsoft.com/office/drawing/2012/chartStyle" xmlns:a="http://schemas.openxmlformats.org/drawingml/2006/main" meth="cycle" id="10">
+  <a:schemeClr val="accent1"/>
+  <a:schemeClr val="accent2"/>
+  <a:schemeClr val="accent3"/>
+  <a:schemeClr val="accent4"/>
+  <a:schemeClr val="accent5"/>
+  <a:schemeClr val="accent6"/>
+  <cs:variation/>
+  <cs:variation>
+    <a:lumMod val="60000"/>
+  </cs:variation>
+  <cs:variation>
+    <a:lumMod val="80000"/>
+    <a:lumOff val="20000"/>
+  </cs:variation>
+  <cs:variation>
+    <a:lumMod val="80000"/>
+  </cs:variation>
+  <cs:variation>
+    <a:lumMod val="60000"/>
+    <a:lumOff val="40000"/>
+  </cs:variation>
+  <cs:variation>
+    <a:lumMod val="50000"/>
+  </cs:variation>
+  <cs:variation>
+    <a:lumMod val="70000"/>
+    <a:lumOff val="30000"/>
+  </cs:variation>
+  <cs:variation>
+    <a:lumMod val="70000"/>
+  </cs:variation>
+  <cs:variation>
+    <a:lumMod val="50000"/>
+    <a:lumOff val="50000"/>
+  </cs:variation>
+</cs:colorStyle>
+</file>
+
 <file path=ppt/charts/style1.xml><?xml version="1.0" encoding="utf-8"?>
 <cs:chartStyle xmlns:cs="http://schemas.microsoft.com/office/drawing/2012/chartStyle" xmlns:a="http://schemas.openxmlformats.org/drawingml/2006/main" id="201">
   <cs:axisTitle>
@@ -2097,6 +3057,511 @@
             <a:lumOff val="85000"/>
           </a:schemeClr>
         </a:solidFill>
+      </a:ln>
+    </cs:spPr>
+  </cs:upBar>
+  <cs:valueAxis>
+    <cs:lnRef idx="0"/>
+    <cs:fillRef idx="0"/>
+    <cs:effectRef idx="0"/>
+    <cs:fontRef idx="minor">
+      <a:schemeClr val="tx1">
+        <a:lumMod val="65000"/>
+        <a:lumOff val="35000"/>
+      </a:schemeClr>
+    </cs:fontRef>
+    <cs:defRPr sz="1197" kern="1200"/>
+  </cs:valueAxis>
+  <cs:wall>
+    <cs:lnRef idx="0"/>
+    <cs:fillRef idx="0"/>
+    <cs:effectRef idx="0"/>
+    <cs:fontRef idx="minor">
+      <a:schemeClr val="tx1"/>
+    </cs:fontRef>
+    <cs:spPr>
+      <a:noFill/>
+      <a:ln>
+        <a:noFill/>
+      </a:ln>
+    </cs:spPr>
+  </cs:wall>
+</cs:chartStyle>
+</file>
+
+<file path=ppt/charts/style3.xml><?xml version="1.0" encoding="utf-8"?>
+<cs:chartStyle xmlns:cs="http://schemas.microsoft.com/office/drawing/2012/chartStyle" xmlns:a="http://schemas.openxmlformats.org/drawingml/2006/main" id="297">
+  <cs:axisTitle>
+    <cs:lnRef idx="0"/>
+    <cs:fillRef idx="0"/>
+    <cs:effectRef idx="0"/>
+    <cs:fontRef idx="minor">
+      <a:schemeClr val="tx1">
+        <a:lumMod val="65000"/>
+        <a:lumOff val="35000"/>
+      </a:schemeClr>
+    </cs:fontRef>
+    <cs:defRPr sz="1330" kern="1200"/>
+  </cs:axisTitle>
+  <cs:categoryAxis>
+    <cs:lnRef idx="0"/>
+    <cs:fillRef idx="0"/>
+    <cs:effectRef idx="0"/>
+    <cs:fontRef idx="minor">
+      <a:schemeClr val="tx1">
+        <a:lumMod val="65000"/>
+        <a:lumOff val="35000"/>
+      </a:schemeClr>
+    </cs:fontRef>
+    <cs:spPr>
+      <a:ln w="9525" cap="flat" cmpd="sng" algn="ctr">
+        <a:solidFill>
+          <a:schemeClr val="tx1">
+            <a:lumMod val="15000"/>
+            <a:lumOff val="85000"/>
+          </a:schemeClr>
+        </a:solidFill>
+        <a:round/>
+      </a:ln>
+    </cs:spPr>
+    <cs:defRPr sz="1197" kern="1200"/>
+  </cs:categoryAxis>
+  <cs:chartArea mods="allowNoFillOverride allowNoLineOverride">
+    <cs:lnRef idx="0"/>
+    <cs:fillRef idx="0"/>
+    <cs:effectRef idx="0"/>
+    <cs:fontRef idx="minor">
+      <a:schemeClr val="tx1"/>
+    </cs:fontRef>
+    <cs:spPr>
+      <a:solidFill>
+        <a:schemeClr val="bg1"/>
+      </a:solidFill>
+      <a:ln w="9525" cap="flat" cmpd="sng" algn="ctr">
+        <a:solidFill>
+          <a:schemeClr val="tx1">
+            <a:lumMod val="15000"/>
+            <a:lumOff val="85000"/>
+          </a:schemeClr>
+        </a:solidFill>
+        <a:round/>
+      </a:ln>
+    </cs:spPr>
+    <cs:defRPr sz="1330" kern="1200"/>
+  </cs:chartArea>
+  <cs:dataLabel>
+    <cs:lnRef idx="0"/>
+    <cs:fillRef idx="0"/>
+    <cs:effectRef idx="0"/>
+    <cs:fontRef idx="minor">
+      <a:schemeClr val="tx1">
+        <a:lumMod val="75000"/>
+        <a:lumOff val="25000"/>
+      </a:schemeClr>
+    </cs:fontRef>
+    <cs:defRPr sz="1197" kern="1200"/>
+  </cs:dataLabel>
+  <cs:dataLabelCallout>
+    <cs:lnRef idx="0"/>
+    <cs:fillRef idx="0"/>
+    <cs:effectRef idx="0"/>
+    <cs:fontRef idx="minor">
+      <a:schemeClr val="dk1">
+        <a:lumMod val="65000"/>
+        <a:lumOff val="35000"/>
+      </a:schemeClr>
+    </cs:fontRef>
+    <cs:spPr>
+      <a:solidFill>
+        <a:schemeClr val="lt1"/>
+      </a:solidFill>
+      <a:ln>
+        <a:solidFill>
+          <a:schemeClr val="dk1">
+            <a:lumMod val="25000"/>
+            <a:lumOff val="75000"/>
+          </a:schemeClr>
+        </a:solidFill>
+      </a:ln>
+    </cs:spPr>
+    <cs:defRPr sz="1197" kern="1200"/>
+    <cs:bodyPr rot="0" spcFirstLastPara="1" vertOverflow="clip" horzOverflow="clip" vert="horz" wrap="square" lIns="36576" tIns="18288" rIns="36576" bIns="18288" anchor="ctr" anchorCtr="1">
+      <a:spAutoFit/>
+    </cs:bodyPr>
+  </cs:dataLabelCallout>
+  <cs:dataPoint>
+    <cs:lnRef idx="0"/>
+    <cs:fillRef idx="1">
+      <cs:styleClr val="auto"/>
+    </cs:fillRef>
+    <cs:effectRef idx="0"/>
+    <cs:fontRef idx="minor">
+      <a:schemeClr val="tx1"/>
+    </cs:fontRef>
+  </cs:dataPoint>
+  <cs:dataPoint3D>
+    <cs:lnRef idx="0"/>
+    <cs:fillRef idx="1">
+      <cs:styleClr val="auto"/>
+    </cs:fillRef>
+    <cs:effectRef idx="0"/>
+    <cs:fontRef idx="minor">
+      <a:schemeClr val="tx1"/>
+    </cs:fontRef>
+  </cs:dataPoint3D>
+  <cs:dataPointLine>
+    <cs:lnRef idx="0">
+      <cs:styleClr val="auto"/>
+    </cs:lnRef>
+    <cs:fillRef idx="1"/>
+    <cs:effectRef idx="0"/>
+    <cs:fontRef idx="minor">
+      <a:schemeClr val="tx1"/>
+    </cs:fontRef>
+    <cs:spPr>
+      <a:ln w="28575" cap="rnd">
+        <a:solidFill>
+          <a:schemeClr val="phClr"/>
+        </a:solidFill>
+        <a:round/>
+      </a:ln>
+    </cs:spPr>
+  </cs:dataPointLine>
+  <cs:dataPointMarker>
+    <cs:lnRef idx="0">
+      <cs:styleClr val="auto"/>
+    </cs:lnRef>
+    <cs:fillRef idx="1">
+      <cs:styleClr val="auto"/>
+    </cs:fillRef>
+    <cs:effectRef idx="0"/>
+    <cs:fontRef idx="minor">
+      <a:schemeClr val="tx1"/>
+    </cs:fontRef>
+    <cs:spPr>
+      <a:ln w="9525">
+        <a:solidFill>
+          <a:schemeClr val="phClr"/>
+        </a:solidFill>
+      </a:ln>
+    </cs:spPr>
+  </cs:dataPointMarker>
+  <cs:dataPointMarkerLayout symbol="circle" size="5"/>
+  <cs:dataPointWireframe>
+    <cs:lnRef idx="0">
+      <cs:styleClr val="auto"/>
+    </cs:lnRef>
+    <cs:fillRef idx="1"/>
+    <cs:effectRef idx="0"/>
+    <cs:fontRef idx="minor">
+      <a:schemeClr val="tx1"/>
+    </cs:fontRef>
+    <cs:spPr>
+      <a:ln w="9525" cap="rnd">
+        <a:solidFill>
+          <a:schemeClr val="phClr"/>
+        </a:solidFill>
+        <a:round/>
+      </a:ln>
+    </cs:spPr>
+  </cs:dataPointWireframe>
+  <cs:dataTable>
+    <cs:lnRef idx="0"/>
+    <cs:fillRef idx="0"/>
+    <cs:effectRef idx="0"/>
+    <cs:fontRef idx="minor">
+      <a:schemeClr val="tx1">
+        <a:lumMod val="65000"/>
+        <a:lumOff val="35000"/>
+      </a:schemeClr>
+    </cs:fontRef>
+    <cs:spPr>
+      <a:noFill/>
+      <a:ln w="9525" cap="flat" cmpd="sng" algn="ctr">
+        <a:solidFill>
+          <a:schemeClr val="tx1">
+            <a:lumMod val="15000"/>
+            <a:lumOff val="85000"/>
+          </a:schemeClr>
+        </a:solidFill>
+        <a:round/>
+      </a:ln>
+    </cs:spPr>
+    <cs:defRPr sz="1197" kern="1200"/>
+  </cs:dataTable>
+  <cs:downBar>
+    <cs:lnRef idx="0"/>
+    <cs:fillRef idx="0"/>
+    <cs:effectRef idx="0"/>
+    <cs:fontRef idx="minor">
+      <a:schemeClr val="tx1"/>
+    </cs:fontRef>
+    <cs:spPr>
+      <a:solidFill>
+        <a:schemeClr val="dk1">
+          <a:lumMod val="75000"/>
+          <a:lumOff val="25000"/>
+        </a:schemeClr>
+      </a:solidFill>
+      <a:ln w="9525" cap="flat" cmpd="sng" algn="ctr">
+        <a:solidFill>
+          <a:schemeClr val="tx1">
+            <a:lumMod val="65000"/>
+            <a:lumOff val="35000"/>
+          </a:schemeClr>
+        </a:solidFill>
+        <a:round/>
+      </a:ln>
+    </cs:spPr>
+  </cs:downBar>
+  <cs:dropLine>
+    <cs:lnRef idx="0"/>
+    <cs:fillRef idx="0"/>
+    <cs:effectRef idx="0"/>
+    <cs:fontRef idx="minor">
+      <a:schemeClr val="tx1"/>
+    </cs:fontRef>
+    <cs:spPr>
+      <a:ln w="9525" cap="flat" cmpd="sng" algn="ctr">
+        <a:solidFill>
+          <a:schemeClr val="tx1">
+            <a:lumMod val="35000"/>
+            <a:lumOff val="65000"/>
+          </a:schemeClr>
+        </a:solidFill>
+        <a:round/>
+      </a:ln>
+    </cs:spPr>
+  </cs:dropLine>
+  <cs:errorBar>
+    <cs:lnRef idx="0"/>
+    <cs:fillRef idx="0"/>
+    <cs:effectRef idx="0"/>
+    <cs:fontRef idx="minor">
+      <a:schemeClr val="tx1"/>
+    </cs:fontRef>
+    <cs:spPr>
+      <a:ln w="9525" cap="flat" cmpd="sng" algn="ctr">
+        <a:solidFill>
+          <a:schemeClr val="tx1">
+            <a:lumMod val="65000"/>
+            <a:lumOff val="35000"/>
+          </a:schemeClr>
+        </a:solidFill>
+        <a:round/>
+      </a:ln>
+    </cs:spPr>
+  </cs:errorBar>
+  <cs:floor>
+    <cs:lnRef idx="0"/>
+    <cs:fillRef idx="0"/>
+    <cs:effectRef idx="0"/>
+    <cs:fontRef idx="minor">
+      <a:schemeClr val="tx1"/>
+    </cs:fontRef>
+    <cs:spPr>
+      <a:noFill/>
+      <a:ln>
+        <a:noFill/>
+      </a:ln>
+    </cs:spPr>
+  </cs:floor>
+  <cs:gridlineMajor>
+    <cs:lnRef idx="0"/>
+    <cs:fillRef idx="0"/>
+    <cs:effectRef idx="0"/>
+    <cs:fontRef idx="minor">
+      <a:schemeClr val="tx1"/>
+    </cs:fontRef>
+    <cs:spPr>
+      <a:ln w="9525" cap="flat" cmpd="sng" algn="ctr">
+        <a:solidFill>
+          <a:schemeClr val="tx1">
+            <a:lumMod val="15000"/>
+            <a:lumOff val="85000"/>
+          </a:schemeClr>
+        </a:solidFill>
+        <a:round/>
+      </a:ln>
+    </cs:spPr>
+  </cs:gridlineMajor>
+  <cs:gridlineMinor>
+    <cs:lnRef idx="0"/>
+    <cs:fillRef idx="0"/>
+    <cs:effectRef idx="0"/>
+    <cs:fontRef idx="minor">
+      <a:schemeClr val="tx1"/>
+    </cs:fontRef>
+    <cs:spPr>
+      <a:ln w="9525" cap="flat" cmpd="sng" algn="ctr">
+        <a:solidFill>
+          <a:schemeClr val="tx1">
+            <a:lumMod val="5000"/>
+            <a:lumOff val="95000"/>
+          </a:schemeClr>
+        </a:solidFill>
+        <a:round/>
+      </a:ln>
+    </cs:spPr>
+  </cs:gridlineMinor>
+  <cs:hiLoLine>
+    <cs:lnRef idx="0"/>
+    <cs:fillRef idx="0"/>
+    <cs:effectRef idx="0"/>
+    <cs:fontRef idx="minor">
+      <a:schemeClr val="tx1"/>
+    </cs:fontRef>
+    <cs:spPr>
+      <a:ln w="9525" cap="flat" cmpd="sng" algn="ctr">
+        <a:solidFill>
+          <a:schemeClr val="tx1">
+            <a:lumMod val="50000"/>
+            <a:lumOff val="50000"/>
+          </a:schemeClr>
+        </a:solidFill>
+        <a:round/>
+      </a:ln>
+    </cs:spPr>
+  </cs:hiLoLine>
+  <cs:leaderLine>
+    <cs:lnRef idx="0"/>
+    <cs:fillRef idx="0"/>
+    <cs:effectRef idx="0"/>
+    <cs:fontRef idx="minor">
+      <a:schemeClr val="tx1"/>
+    </cs:fontRef>
+    <cs:spPr>
+      <a:ln w="9525" cap="flat" cmpd="sng" algn="ctr">
+        <a:solidFill>
+          <a:schemeClr val="tx1">
+            <a:lumMod val="35000"/>
+            <a:lumOff val="65000"/>
+          </a:schemeClr>
+        </a:solidFill>
+        <a:round/>
+      </a:ln>
+    </cs:spPr>
+  </cs:leaderLine>
+  <cs:legend>
+    <cs:lnRef idx="0"/>
+    <cs:fillRef idx="0"/>
+    <cs:effectRef idx="0"/>
+    <cs:fontRef idx="minor">
+      <a:schemeClr val="tx1">
+        <a:lumMod val="65000"/>
+        <a:lumOff val="35000"/>
+      </a:schemeClr>
+    </cs:fontRef>
+    <cs:defRPr sz="1197" kern="1200"/>
+  </cs:legend>
+  <cs:plotArea mods="allowNoFillOverride allowNoLineOverride">
+    <cs:lnRef idx="0"/>
+    <cs:fillRef idx="0"/>
+    <cs:effectRef idx="0"/>
+    <cs:fontRef idx="minor">
+      <a:schemeClr val="tx1"/>
+    </cs:fontRef>
+  </cs:plotArea>
+  <cs:plotArea3D mods="allowNoFillOverride allowNoLineOverride">
+    <cs:lnRef idx="0"/>
+    <cs:fillRef idx="0"/>
+    <cs:effectRef idx="0"/>
+    <cs:fontRef idx="minor">
+      <a:schemeClr val="tx1"/>
+    </cs:fontRef>
+  </cs:plotArea3D>
+  <cs:seriesAxis>
+    <cs:lnRef idx="0"/>
+    <cs:fillRef idx="0"/>
+    <cs:effectRef idx="0"/>
+    <cs:fontRef idx="minor">
+      <a:schemeClr val="tx1">
+        <a:lumMod val="65000"/>
+        <a:lumOff val="35000"/>
+      </a:schemeClr>
+    </cs:fontRef>
+    <cs:defRPr sz="1197" kern="1200"/>
+  </cs:seriesAxis>
+  <cs:seriesLine>
+    <cs:lnRef idx="0"/>
+    <cs:fillRef idx="0"/>
+    <cs:effectRef idx="0"/>
+    <cs:fontRef idx="minor">
+      <a:schemeClr val="tx1"/>
+    </cs:fontRef>
+    <cs:spPr>
+      <a:ln w="9525" cap="flat" cmpd="sng" algn="ctr">
+        <a:solidFill>
+          <a:schemeClr val="tx1">
+            <a:lumMod val="35000"/>
+            <a:lumOff val="65000"/>
+          </a:schemeClr>
+        </a:solidFill>
+        <a:round/>
+      </a:ln>
+    </cs:spPr>
+  </cs:seriesLine>
+  <cs:title>
+    <cs:lnRef idx="0"/>
+    <cs:fillRef idx="0"/>
+    <cs:effectRef idx="0"/>
+    <cs:fontRef idx="minor">
+      <a:schemeClr val="tx1">
+        <a:lumMod val="65000"/>
+        <a:lumOff val="35000"/>
+      </a:schemeClr>
+    </cs:fontRef>
+    <cs:defRPr sz="1862" b="0" kern="1200" spc="0" baseline="0"/>
+  </cs:title>
+  <cs:trendline>
+    <cs:lnRef idx="0">
+      <cs:styleClr val="auto"/>
+    </cs:lnRef>
+    <cs:fillRef idx="0"/>
+    <cs:effectRef idx="0"/>
+    <cs:fontRef idx="minor">
+      <a:schemeClr val="tx1"/>
+    </cs:fontRef>
+    <cs:spPr>
+      <a:ln w="19050" cap="rnd">
+        <a:solidFill>
+          <a:schemeClr val="phClr"/>
+        </a:solidFill>
+        <a:prstDash val="sysDot"/>
+      </a:ln>
+    </cs:spPr>
+  </cs:trendline>
+  <cs:trendlineLabel>
+    <cs:lnRef idx="0"/>
+    <cs:fillRef idx="0"/>
+    <cs:effectRef idx="0"/>
+    <cs:fontRef idx="minor">
+      <a:schemeClr val="tx1">
+        <a:lumMod val="65000"/>
+        <a:lumOff val="35000"/>
+      </a:schemeClr>
+    </cs:fontRef>
+    <cs:defRPr sz="1197" kern="1200"/>
+  </cs:trendlineLabel>
+  <cs:upBar>
+    <cs:lnRef idx="0"/>
+    <cs:fillRef idx="0"/>
+    <cs:effectRef idx="0"/>
+    <cs:fontRef idx="minor">
+      <a:schemeClr val="tx1"/>
+    </cs:fontRef>
+    <cs:spPr>
+      <a:solidFill>
+        <a:schemeClr val="lt1"/>
+      </a:solidFill>
+      <a:ln w="9525" cap="flat" cmpd="sng" algn="ctr">
+        <a:solidFill>
+          <a:schemeClr val="tx1">
+            <a:lumMod val="65000"/>
+            <a:lumOff val="35000"/>
+          </a:schemeClr>
+        </a:solidFill>
+        <a:round/>
       </a:ln>
     </cs:spPr>
   </cs:upBar>
@@ -2278,7 +3743,7 @@
           <a:p>
             <a:fld id="{0490EA95-AFA9-47FA-B067-612933D1D62E}" type="datetimeFigureOut">
               <a:rPr lang="en-IN" smtClean="0"/>
-              <a:t>02-06-2026</a:t>
+              <a:t>04-06-2026</a:t>
             </a:fld>
             <a:endParaRPr lang="en-IN"/>
           </a:p>
@@ -2478,7 +3943,7 @@
           <a:p>
             <a:fld id="{0490EA95-AFA9-47FA-B067-612933D1D62E}" type="datetimeFigureOut">
               <a:rPr lang="en-IN" smtClean="0"/>
-              <a:t>02-06-2026</a:t>
+              <a:t>04-06-2026</a:t>
             </a:fld>
             <a:endParaRPr lang="en-IN"/>
           </a:p>
@@ -2688,7 +4153,7 @@
           <a:p>
             <a:fld id="{0490EA95-AFA9-47FA-B067-612933D1D62E}" type="datetimeFigureOut">
               <a:rPr lang="en-IN" smtClean="0"/>
-              <a:t>02-06-2026</a:t>
+              <a:t>04-06-2026</a:t>
             </a:fld>
             <a:endParaRPr lang="en-IN"/>
           </a:p>
@@ -2888,7 +4353,7 @@
           <a:p>
             <a:fld id="{0490EA95-AFA9-47FA-B067-612933D1D62E}" type="datetimeFigureOut">
               <a:rPr lang="en-IN" smtClean="0"/>
-              <a:t>02-06-2026</a:t>
+              <a:t>04-06-2026</a:t>
             </a:fld>
             <a:endParaRPr lang="en-IN"/>
           </a:p>
@@ -3164,7 +4629,7 @@
           <a:p>
             <a:fld id="{0490EA95-AFA9-47FA-B067-612933D1D62E}" type="datetimeFigureOut">
               <a:rPr lang="en-IN" smtClean="0"/>
-              <a:t>02-06-2026</a:t>
+              <a:t>04-06-2026</a:t>
             </a:fld>
             <a:endParaRPr lang="en-IN"/>
           </a:p>
@@ -3432,7 +4897,7 @@
           <a:p>
             <a:fld id="{0490EA95-AFA9-47FA-B067-612933D1D62E}" type="datetimeFigureOut">
               <a:rPr lang="en-IN" smtClean="0"/>
-              <a:t>02-06-2026</a:t>
+              <a:t>04-06-2026</a:t>
             </a:fld>
             <a:endParaRPr lang="en-IN"/>
           </a:p>
@@ -3847,7 +5312,7 @@
           <a:p>
             <a:fld id="{0490EA95-AFA9-47FA-B067-612933D1D62E}" type="datetimeFigureOut">
               <a:rPr lang="en-IN" smtClean="0"/>
-              <a:t>02-06-2026</a:t>
+              <a:t>04-06-2026</a:t>
             </a:fld>
             <a:endParaRPr lang="en-IN"/>
           </a:p>
@@ -3989,7 +5454,7 @@
           <a:p>
             <a:fld id="{0490EA95-AFA9-47FA-B067-612933D1D62E}" type="datetimeFigureOut">
               <a:rPr lang="en-IN" smtClean="0"/>
-              <a:t>02-06-2026</a:t>
+              <a:t>04-06-2026</a:t>
             </a:fld>
             <a:endParaRPr lang="en-IN"/>
           </a:p>
@@ -4102,7 +5567,7 @@
           <a:p>
             <a:fld id="{0490EA95-AFA9-47FA-B067-612933D1D62E}" type="datetimeFigureOut">
               <a:rPr lang="en-IN" smtClean="0"/>
-              <a:t>02-06-2026</a:t>
+              <a:t>04-06-2026</a:t>
             </a:fld>
             <a:endParaRPr lang="en-IN"/>
           </a:p>
@@ -4415,7 +5880,7 @@
           <a:p>
             <a:fld id="{0490EA95-AFA9-47FA-B067-612933D1D62E}" type="datetimeFigureOut">
               <a:rPr lang="en-IN" smtClean="0"/>
-              <a:t>02-06-2026</a:t>
+              <a:t>04-06-2026</a:t>
             </a:fld>
             <a:endParaRPr lang="en-IN"/>
           </a:p>
@@ -4704,7 +6169,7 @@
           <a:p>
             <a:fld id="{0490EA95-AFA9-47FA-B067-612933D1D62E}" type="datetimeFigureOut">
               <a:rPr lang="en-IN" smtClean="0"/>
-              <a:t>02-06-2026</a:t>
+              <a:t>04-06-2026</a:t>
             </a:fld>
             <a:endParaRPr lang="en-IN"/>
           </a:p>
@@ -4947,7 +6412,7 @@
           <a:p>
             <a:fld id="{0490EA95-AFA9-47FA-B067-612933D1D62E}" type="datetimeFigureOut">
               <a:rPr lang="en-IN" smtClean="0"/>
-              <a:t>02-06-2026</a:t>
+              <a:t>04-06-2026</a:t>
             </a:fld>
             <a:endParaRPr lang="en-IN"/>
           </a:p>
@@ -5455,7 +6920,7 @@
             <p:ph idx="1"/>
             <p:extLst>
               <p:ext uri="{D42A27DB-BD31-4B8C-83A1-F6EECF244321}">
-                <p14:modId xmlns:p14="http://schemas.microsoft.com/office/powerpoint/2010/main" val="1557177176"/>
+                <p14:modId xmlns:p14="http://schemas.microsoft.com/office/powerpoint/2010/main" val="1306359762"/>
               </p:ext>
             </p:extLst>
           </p:nvPr>
@@ -6173,6 +7638,73 @@
     <p:extLst>
       <p:ext uri="{BB962C8B-B14F-4D97-AF65-F5344CB8AC3E}">
         <p14:creationId xmlns:p14="http://schemas.microsoft.com/office/powerpoint/2010/main" val="3046703408"/>
+      </p:ext>
+    </p:extLst>
+  </p:cSld>
+  <p:clrMapOvr>
+    <a:masterClrMapping/>
+  </p:clrMapOvr>
+</p:sld>
+</file>
+
+<file path=ppt/slides/slide4.xml><?xml version="1.0" encoding="utf-8"?>
+<p:sld xmlns:a="http://schemas.openxmlformats.org/drawingml/2006/main" xmlns:r="http://schemas.openxmlformats.org/officeDocument/2006/relationships" xmlns:p="http://schemas.openxmlformats.org/presentationml/2006/main">
+  <p:cSld>
+    <p:spTree>
+      <p:nvGrpSpPr>
+        <p:cNvPr id="1" name="">
+          <a:extLst>
+            <a:ext uri="{FF2B5EF4-FFF2-40B4-BE49-F238E27FC236}">
+              <a16:creationId xmlns:a16="http://schemas.microsoft.com/office/drawing/2014/main" id="{F312459A-1B0A-6E6F-F276-54D5C518EC17}"/>
+            </a:ext>
+          </a:extLst>
+        </p:cNvPr>
+        <p:cNvGrpSpPr/>
+        <p:nvPr/>
+      </p:nvGrpSpPr>
+      <p:grpSpPr>
+        <a:xfrm>
+          <a:off x="0" y="0"/>
+          <a:ext cx="0" cy="0"/>
+          <a:chOff x="0" y="0"/>
+          <a:chExt cx="0" cy="0"/>
+        </a:xfrm>
+      </p:grpSpPr>
+      <p:graphicFrame>
+        <p:nvGraphicFramePr>
+          <p:cNvPr id="12" name="Label Chart">
+            <a:extLst>
+              <a:ext uri="{FF2B5EF4-FFF2-40B4-BE49-F238E27FC236}">
+                <a16:creationId xmlns:a16="http://schemas.microsoft.com/office/drawing/2014/main" id="{5C45F2CF-DBD3-6DBD-9D94-4A468569840F}"/>
+              </a:ext>
+            </a:extLst>
+          </p:cNvPr>
+          <p:cNvGraphicFramePr>
+            <a:graphicFrameLocks noGrp="1"/>
+          </p:cNvGraphicFramePr>
+          <p:nvPr>
+            <p:ph idx="1"/>
+            <p:extLst>
+              <p:ext uri="{D42A27DB-BD31-4B8C-83A1-F6EECF244321}">
+                <p14:modId xmlns:p14="http://schemas.microsoft.com/office/powerpoint/2010/main" val="408003751"/>
+              </p:ext>
+            </p:extLst>
+          </p:nvPr>
+        </p:nvGraphicFramePr>
+        <p:xfrm>
+          <a:off x="838200" y="428626"/>
+          <a:ext cx="10515600" cy="5829300"/>
+        </p:xfrm>
+        <a:graphic>
+          <a:graphicData uri="http://schemas.openxmlformats.org/drawingml/2006/chart">
+            <c:chart xmlns:c="http://schemas.openxmlformats.org/drawingml/2006/chart" xmlns:r="http://schemas.openxmlformats.org/officeDocument/2006/relationships" r:id="rId2"/>
+          </a:graphicData>
+        </a:graphic>
+      </p:graphicFrame>
+    </p:spTree>
+    <p:extLst>
+      <p:ext uri="{BB962C8B-B14F-4D97-AF65-F5344CB8AC3E}">
+        <p14:creationId xmlns:p14="http://schemas.microsoft.com/office/powerpoint/2010/main" val="2812630168"/>
       </p:ext>
     </p:extLst>
   </p:cSld>

</xml_diff>

<commit_message>
feat: implement chart workbook management and generate SEO-optimized documentation pages
</commit_message>
<xml_diff>
--- a/templates/sample.pptx
+++ b/templates/sample.pptx
@@ -9,6 +9,7 @@
     <p:sldId id="257" r:id="rId3"/>
     <p:sldId id="258" r:id="rId4"/>
     <p:sldId id="259" r:id="rId5"/>
+    <p:sldId id="260" r:id="rId6"/>
   </p:sldIdLst>
   <p:sldSz cx="12192000" cy="6858000"/>
   <p:notesSz cx="6858000" cy="9144000"/>
@@ -120,6 +121,7 @@
           <p14:sldIdLst>
             <p14:sldId id="258"/>
             <p14:sldId id="259"/>
+            <p14:sldId id="260"/>
           </p14:sldIdLst>
         </p14:section>
       </p14:sectionLst>
@@ -1268,57 +1270,45 @@
           <c:dLbls>
             <c:dLbl>
               <c:idx val="0"/>
-              <c:tx>
-                <c:rich>
-                  <a:bodyPr/>
-                  <a:lstStyle/>
-                  <a:p>
-                    <a:fld id="{5724EE2C-8685-4063-B888-F16F2237B0FB}" type="CELLRANGE">
-                      <a:rPr lang="en-US"/>
-                      <a:pPr/>
-                      <a:t>[CELLRANGE]</a:t>
-                    </a:fld>
-                    <a:endParaRPr lang="en-IN"/>
-                  </a:p>
-                </c:rich>
-              </c:tx>
+              <c:layout>
+                <c:manualLayout>
+                  <c:x val="0.19927536231884058"/>
+                  <c:y val="0"/>
+                </c:manualLayout>
+              </c:layout>
               <c:dLblPos val="ctr"/>
               <c:showLegendKey val="0"/>
-              <c:showVal val="0"/>
+              <c:showVal val="1"/>
               <c:showCatName val="0"/>
               <c:showSerName val="0"/>
               <c:showPercent val="0"/>
               <c:showBubbleSize val="0"/>
               <c:extLst>
-                <c:ext xmlns:c15="http://schemas.microsoft.com/office/drawing/2012/chart" uri="{CE6537A1-D6FC-4f65-9D91-7224C49458BB}">
-                  <c15:dlblFieldTable/>
-                  <c15:showDataLabelsRange val="1"/>
-                </c:ext>
+                <c:ext xmlns:c15="http://schemas.microsoft.com/office/drawing/2012/chart" uri="{CE6537A1-D6FC-4f65-9D91-7224C49458BB}"/>
                 <c:ext xmlns:c16="http://schemas.microsoft.com/office/drawing/2014/chart" uri="{C3380CC4-5D6E-409C-BE32-E72D297353CC}">
-                  <c16:uniqueId val="{00000006-9D08-4425-99DE-4E5501F36EC7}"/>
+                  <c16:uniqueId val="{00000001-4D89-4FC3-BEAD-7878BEFDFFA6}"/>
                 </c:ext>
               </c:extLst>
             </c:dLbl>
             <c:spPr>
-              <a:noFill/>
+              <a:solidFill>
+                <a:schemeClr val="tx1"/>
+              </a:solidFill>
               <a:ln>
                 <a:noFill/>
               </a:ln>
               <a:effectLst/>
             </c:spPr>
             <c:txPr>
-              <a:bodyPr rot="0" spcFirstLastPara="1" vertOverflow="ellipsis" vert="horz" wrap="square" lIns="38100" tIns="19050" rIns="38100" bIns="19050" anchor="ctr" anchorCtr="1">
+              <a:bodyPr rot="0" spcFirstLastPara="1" vertOverflow="ellipsis" vert="horz" wrap="square" lIns="38100" tIns="19050" rIns="38100" bIns="19050" anchor="ctr" anchorCtr="0">
                 <a:spAutoFit/>
               </a:bodyPr>
               <a:lstStyle/>
               <a:p>
-                <a:pPr>
-                  <a:defRPr sz="2400" b="0" i="0" u="none" strike="noStrike" kern="1200" baseline="0">
+                <a:pPr algn="ctr">
+                  <a:defRPr lang="en-US" sz="8000" b="0" i="0" u="none" strike="noStrike" kern="1200" baseline="0">
                     <a:solidFill>
-                      <a:schemeClr val="tx1">
-                        <a:lumMod val="75000"/>
-                        <a:lumOff val="25000"/>
-                      </a:schemeClr>
+                      <a:schemeClr val="bg1"/>
                     </a:solidFill>
                     <a:latin typeface="+mn-lt"/>
                     <a:ea typeface="+mn-ea"/>
@@ -1330,7 +1320,7 @@
             </c:txPr>
             <c:dLblPos val="ctr"/>
             <c:showLegendKey val="0"/>
-            <c:showVal val="0"/>
+            <c:showVal val="1"/>
             <c:showCatName val="0"/>
             <c:showSerName val="0"/>
             <c:showPercent val="0"/>
@@ -1338,7 +1328,6 @@
             <c:showLeaderLines val="0"/>
             <c:extLst>
               <c:ext xmlns:c15="http://schemas.microsoft.com/office/drawing/2012/chart" uri="{CE6537A1-D6FC-4f65-9D91-7224C49458BB}">
-                <c15:showDataLabelsRange val="1"/>
                 <c15:showLeaderLines val="1"/>
                 <c15:leaderLines>
                   <c:spPr>
@@ -1381,26 +1370,6 @@
             </c:numRef>
           </c:val>
           <c:extLst>
-            <c:ext xmlns:c15="http://schemas.microsoft.com/office/drawing/2012/chart" uri="{02D57815-91ED-43cb-92C2-25804820EDAC}">
-              <c15:datalabelsRange>
-                <c15:f>Sheet1!$B$3:$E$3</c15:f>
-                <c15:dlblRangeCache>
-                  <c:ptCount val="4"/>
-                  <c:pt idx="0">
-                    <c:v>4.3 (29.05%)</c:v>
-                  </c:pt>
-                  <c:pt idx="1">
-                    <c:v>2.5 (16.89%)</c:v>
-                  </c:pt>
-                  <c:pt idx="2">
-                    <c:v>3.5 (23.65%)</c:v>
-                  </c:pt>
-                  <c:pt idx="3">
-                    <c:v>4.5 (30.41%)</c:v>
-                  </c:pt>
-                </c15:dlblRangeCache>
-              </c15:datalabelsRange>
-            </c:ext>
             <c:ext xmlns:c16="http://schemas.microsoft.com/office/drawing/2014/chart" uri="{C3380CC4-5D6E-409C-BE32-E72D297353CC}">
               <c16:uniqueId val="{00000000-9D08-4425-99DE-4E5501F36EC7}"/>
             </c:ext>
@@ -1433,34 +1402,51 @@
           <c:dLbls>
             <c:dLbl>
               <c:idx val="0"/>
-              <c:tx>
-                <c:rich>
-                  <a:bodyPr/>
-                  <a:lstStyle/>
-                  <a:p>
-                    <a:fld id="{8C0AF751-1B0F-438E-96A4-C7CFB7E52912}" type="CELLRANGE">
-                      <a:rPr lang="en-US"/>
-                      <a:pPr/>
-                      <a:t>[CELLRANGE]</a:t>
-                    </a:fld>
-                    <a:endParaRPr lang="en-IN"/>
-                  </a:p>
-                </c:rich>
-              </c:tx>
+              <c:layout>
+                <c:manualLayout>
+                  <c:x val="0.1859903381642512"/>
+                  <c:y val="-2.1786492374728469E-3"/>
+                </c:manualLayout>
+              </c:layout>
+              <c:spPr>
+                <a:solidFill>
+                  <a:schemeClr val="tx1"/>
+                </a:solidFill>
+                <a:ln>
+                  <a:noFill/>
+                </a:ln>
+                <a:effectLst/>
+              </c:spPr>
+              <c:txPr>
+                <a:bodyPr rot="0" spcFirstLastPara="1" vertOverflow="ellipsis" vert="horz" wrap="square" lIns="38100" tIns="19050" rIns="38100" bIns="19050" anchor="ctr" anchorCtr="0">
+                  <a:spAutoFit/>
+                </a:bodyPr>
+                <a:lstStyle/>
+                <a:p>
+                  <a:pPr algn="ctr">
+                    <a:defRPr lang="en-US" sz="8000" b="0" i="0" u="none" strike="noStrike" kern="1200" baseline="0">
+                      <a:solidFill>
+                        <a:schemeClr val="bg1"/>
+                      </a:solidFill>
+                      <a:latin typeface="+mn-lt"/>
+                      <a:ea typeface="+mn-ea"/>
+                      <a:cs typeface="+mn-cs"/>
+                    </a:defRPr>
+                  </a:pPr>
+                  <a:endParaRPr lang="en-US"/>
+                </a:p>
+              </c:txPr>
               <c:dLblPos val="ctr"/>
               <c:showLegendKey val="0"/>
-              <c:showVal val="0"/>
+              <c:showVal val="1"/>
               <c:showCatName val="0"/>
               <c:showSerName val="0"/>
               <c:showPercent val="0"/>
               <c:showBubbleSize val="0"/>
               <c:extLst>
-                <c:ext xmlns:c15="http://schemas.microsoft.com/office/drawing/2012/chart" uri="{CE6537A1-D6FC-4f65-9D91-7224C49458BB}">
-                  <c15:dlblFieldTable/>
-                  <c15:showDataLabelsRange val="1"/>
-                </c:ext>
+                <c:ext xmlns:c15="http://schemas.microsoft.com/office/drawing/2012/chart" uri="{CE6537A1-D6FC-4f65-9D91-7224C49458BB}"/>
                 <c:ext xmlns:c16="http://schemas.microsoft.com/office/drawing/2014/chart" uri="{C3380CC4-5D6E-409C-BE32-E72D297353CC}">
-                  <c16:uniqueId val="{00000007-9D08-4425-99DE-4E5501F36EC7}"/>
+                  <c16:uniqueId val="{00000002-4D89-4FC3-BEAD-7878BEFDFFA6}"/>
                 </c:ext>
               </c:extLst>
             </c:dLbl>
@@ -1472,13 +1458,13 @@
               <a:effectLst/>
             </c:spPr>
             <c:txPr>
-              <a:bodyPr rot="0" spcFirstLastPara="1" vertOverflow="ellipsis" vert="horz" wrap="square" lIns="38100" tIns="19050" rIns="38100" bIns="19050" anchor="ctr" anchorCtr="1">
+              <a:bodyPr rot="0" spcFirstLastPara="1" vertOverflow="ellipsis" vert="horz" wrap="square" lIns="38100" tIns="19050" rIns="38100" bIns="19050" anchor="ctr" anchorCtr="0">
                 <a:spAutoFit/>
               </a:bodyPr>
               <a:lstStyle/>
               <a:p>
-                <a:pPr>
-                  <a:defRPr sz="2400" b="0" i="0" u="none" strike="noStrike" kern="1200" baseline="0">
+                <a:pPr algn="ctr">
+                  <a:defRPr lang="en-US" sz="8000" b="0" i="0" u="none" strike="noStrike" kern="1200" baseline="0">
                     <a:solidFill>
                       <a:schemeClr val="tx1">
                         <a:lumMod val="75000"/>
@@ -1495,7 +1481,7 @@
             </c:txPr>
             <c:dLblPos val="ctr"/>
             <c:showLegendKey val="0"/>
-            <c:showVal val="0"/>
+            <c:showVal val="1"/>
             <c:showCatName val="0"/>
             <c:showSerName val="0"/>
             <c:showPercent val="0"/>
@@ -1503,7 +1489,6 @@
             <c:showLeaderLines val="0"/>
             <c:extLst>
               <c:ext xmlns:c15="http://schemas.microsoft.com/office/drawing/2012/chart" uri="{CE6537A1-D6FC-4f65-9D91-7224C49458BB}">
-                <c15:showDataLabelsRange val="1"/>
                 <c15:showLeaderLines val="1"/>
                 <c15:leaderLines>
                   <c:spPr>
@@ -1546,17 +1531,6 @@
             </c:numRef>
           </c:val>
           <c:extLst>
-            <c:ext xmlns:c15="http://schemas.microsoft.com/office/drawing/2012/chart" uri="{02D57815-91ED-43cb-92C2-25804820EDAC}">
-              <c15:datalabelsRange>
-                <c15:f>Sheet1!$C$3</c15:f>
-                <c15:dlblRangeCache>
-                  <c:ptCount val="1"/>
-                  <c:pt idx="0">
-                    <c:v>2.5 (16.89%)</c:v>
-                  </c:pt>
-                </c15:dlblRangeCache>
-              </c15:datalabelsRange>
-            </c:ext>
             <c:ext xmlns:c16="http://schemas.microsoft.com/office/drawing/2014/chart" uri="{C3380CC4-5D6E-409C-BE32-E72D297353CC}">
               <c16:uniqueId val="{00000003-9D08-4425-99DE-4E5501F36EC7}"/>
             </c:ext>
@@ -1589,34 +1563,51 @@
           <c:dLbls>
             <c:dLbl>
               <c:idx val="0"/>
-              <c:tx>
-                <c:rich>
-                  <a:bodyPr/>
-                  <a:lstStyle/>
-                  <a:p>
-                    <a:fld id="{986BA18C-DD07-4545-91E8-F4DE33383886}" type="CELLRANGE">
-                      <a:rPr lang="en-US"/>
-                      <a:pPr/>
-                      <a:t>[CELLRANGE]</a:t>
-                    </a:fld>
-                    <a:endParaRPr lang="en-IN"/>
-                  </a:p>
-                </c:rich>
-              </c:tx>
+              <c:layout>
+                <c:manualLayout>
+                  <c:x val="0.18719806763285024"/>
+                  <c:y val="-1.0893246187363915E-2"/>
+                </c:manualLayout>
+              </c:layout>
+              <c:spPr>
+                <a:solidFill>
+                  <a:schemeClr val="tx1"/>
+                </a:solidFill>
+                <a:ln>
+                  <a:noFill/>
+                </a:ln>
+                <a:effectLst/>
+              </c:spPr>
+              <c:txPr>
+                <a:bodyPr rot="0" spcFirstLastPara="1" vertOverflow="ellipsis" vert="horz" wrap="square" lIns="38100" tIns="19050" rIns="38100" bIns="19050" anchor="ctr" anchorCtr="0">
+                  <a:spAutoFit/>
+                </a:bodyPr>
+                <a:lstStyle/>
+                <a:p>
+                  <a:pPr algn="ctr">
+                    <a:defRPr lang="en-US" sz="8000" b="0" i="0" u="none" strike="noStrike" kern="1200" baseline="0">
+                      <a:solidFill>
+                        <a:schemeClr val="bg1"/>
+                      </a:solidFill>
+                      <a:latin typeface="+mn-lt"/>
+                      <a:ea typeface="+mn-ea"/>
+                      <a:cs typeface="+mn-cs"/>
+                    </a:defRPr>
+                  </a:pPr>
+                  <a:endParaRPr lang="en-US"/>
+                </a:p>
+              </c:txPr>
               <c:dLblPos val="ctr"/>
               <c:showLegendKey val="0"/>
-              <c:showVal val="0"/>
+              <c:showVal val="1"/>
               <c:showCatName val="0"/>
               <c:showSerName val="0"/>
               <c:showPercent val="0"/>
               <c:showBubbleSize val="0"/>
               <c:extLst>
-                <c:ext xmlns:c15="http://schemas.microsoft.com/office/drawing/2012/chart" uri="{CE6537A1-D6FC-4f65-9D91-7224C49458BB}">
-                  <c15:dlblFieldTable/>
-                  <c15:showDataLabelsRange val="1"/>
-                </c:ext>
+                <c:ext xmlns:c15="http://schemas.microsoft.com/office/drawing/2012/chart" uri="{CE6537A1-D6FC-4f65-9D91-7224C49458BB}"/>
                 <c:ext xmlns:c16="http://schemas.microsoft.com/office/drawing/2014/chart" uri="{C3380CC4-5D6E-409C-BE32-E72D297353CC}">
-                  <c16:uniqueId val="{00000008-9D08-4425-99DE-4E5501F36EC7}"/>
+                  <c16:uniqueId val="{00000003-4D89-4FC3-BEAD-7878BEFDFFA6}"/>
                 </c:ext>
               </c:extLst>
             </c:dLbl>
@@ -1628,13 +1619,13 @@
               <a:effectLst/>
             </c:spPr>
             <c:txPr>
-              <a:bodyPr rot="0" spcFirstLastPara="1" vertOverflow="ellipsis" vert="horz" wrap="square" lIns="38100" tIns="19050" rIns="38100" bIns="19050" anchor="ctr" anchorCtr="1">
+              <a:bodyPr rot="0" spcFirstLastPara="1" vertOverflow="ellipsis" vert="horz" wrap="square" lIns="38100" tIns="19050" rIns="38100" bIns="19050" anchor="ctr" anchorCtr="0">
                 <a:spAutoFit/>
               </a:bodyPr>
               <a:lstStyle/>
               <a:p>
-                <a:pPr>
-                  <a:defRPr sz="2400" b="0" i="0" u="none" strike="noStrike" kern="1200" baseline="0">
+                <a:pPr algn="ctr">
+                  <a:defRPr lang="en-US" sz="8000" b="0" i="0" u="none" strike="noStrike" kern="1200" baseline="0">
                     <a:solidFill>
                       <a:schemeClr val="tx1">
                         <a:lumMod val="75000"/>
@@ -1651,7 +1642,7 @@
             </c:txPr>
             <c:dLblPos val="ctr"/>
             <c:showLegendKey val="0"/>
-            <c:showVal val="0"/>
+            <c:showVal val="1"/>
             <c:showCatName val="0"/>
             <c:showSerName val="0"/>
             <c:showPercent val="0"/>
@@ -1659,7 +1650,6 @@
             <c:showLeaderLines val="0"/>
             <c:extLst>
               <c:ext xmlns:c15="http://schemas.microsoft.com/office/drawing/2012/chart" uri="{CE6537A1-D6FC-4f65-9D91-7224C49458BB}">
-                <c15:showDataLabelsRange val="1"/>
                 <c15:showLeaderLines val="1"/>
                 <c15:leaderLines>
                   <c:spPr>
@@ -1702,17 +1692,6 @@
             </c:numRef>
           </c:val>
           <c:extLst>
-            <c:ext xmlns:c15="http://schemas.microsoft.com/office/drawing/2012/chart" uri="{02D57815-91ED-43cb-92C2-25804820EDAC}">
-              <c15:datalabelsRange>
-                <c15:f>Sheet1!$D$3</c15:f>
-                <c15:dlblRangeCache>
-                  <c:ptCount val="1"/>
-                  <c:pt idx="0">
-                    <c:v>3.5 (23.65%)</c:v>
-                  </c:pt>
-                </c15:dlblRangeCache>
-              </c15:datalabelsRange>
-            </c:ext>
             <c:ext xmlns:c16="http://schemas.microsoft.com/office/drawing/2014/chart" uri="{C3380CC4-5D6E-409C-BE32-E72D297353CC}">
               <c16:uniqueId val="{00000004-9D08-4425-99DE-4E5501F36EC7}"/>
             </c:ext>
@@ -1745,39 +1724,30 @@
           <c:dLbls>
             <c:dLbl>
               <c:idx val="0"/>
-              <c:tx>
-                <c:rich>
-                  <a:bodyPr/>
-                  <a:lstStyle/>
-                  <a:p>
-                    <a:fld id="{E0EE13D5-2099-4391-ADAB-EECF540A82F2}" type="CELLRANGE">
-                      <a:rPr lang="en-US"/>
-                      <a:pPr/>
-                      <a:t>[CELLRANGE]</a:t>
-                    </a:fld>
-                    <a:endParaRPr lang="en-IN"/>
-                  </a:p>
-                </c:rich>
-              </c:tx>
+              <c:layout>
+                <c:manualLayout>
+                  <c:x val="0.19444444444444445"/>
+                  <c:y val="-1.997072064003136E-17"/>
+                </c:manualLayout>
+              </c:layout>
               <c:dLblPos val="ctr"/>
               <c:showLegendKey val="0"/>
-              <c:showVal val="0"/>
+              <c:showVal val="1"/>
               <c:showCatName val="0"/>
               <c:showSerName val="0"/>
               <c:showPercent val="0"/>
               <c:showBubbleSize val="0"/>
               <c:extLst>
-                <c:ext xmlns:c15="http://schemas.microsoft.com/office/drawing/2012/chart" uri="{CE6537A1-D6FC-4f65-9D91-7224C49458BB}">
-                  <c15:dlblFieldTable/>
-                  <c15:showDataLabelsRange val="1"/>
-                </c:ext>
+                <c:ext xmlns:c15="http://schemas.microsoft.com/office/drawing/2012/chart" uri="{CE6537A1-D6FC-4f65-9D91-7224C49458BB}"/>
                 <c:ext xmlns:c16="http://schemas.microsoft.com/office/drawing/2014/chart" uri="{C3380CC4-5D6E-409C-BE32-E72D297353CC}">
-                  <c16:uniqueId val="{00000009-9D08-4425-99DE-4E5501F36EC7}"/>
+                  <c16:uniqueId val="{00000000-4D89-4FC3-BEAD-7878BEFDFFA6}"/>
                 </c:ext>
               </c:extLst>
             </c:dLbl>
             <c:spPr>
-              <a:noFill/>
+              <a:solidFill>
+                <a:schemeClr val="tx1"/>
+              </a:solidFill>
               <a:ln>
                 <a:noFill/>
               </a:ln>
@@ -1790,14 +1760,11 @@
               <a:lstStyle/>
               <a:p>
                 <a:pPr>
-                  <a:defRPr sz="2400" b="0" i="0" u="none" strike="noStrike" kern="1200" baseline="0">
+                  <a:defRPr sz="8000" b="0" i="0" u="none" strike="noStrike" kern="1200" baseline="0">
                     <a:solidFill>
-                      <a:schemeClr val="tx1">
-                        <a:lumMod val="75000"/>
-                        <a:lumOff val="25000"/>
-                      </a:schemeClr>
+                      <a:schemeClr val="bg1"/>
                     </a:solidFill>
-                    <a:latin typeface="Adobe Garamond Pro Bold" panose="02020702060506020403" pitchFamily="18" charset="0"/>
+                    <a:latin typeface="+mn-lt"/>
                     <a:ea typeface="+mn-ea"/>
                     <a:cs typeface="+mn-cs"/>
                   </a:defRPr>
@@ -1807,7 +1774,7 @@
             </c:txPr>
             <c:dLblPos val="ctr"/>
             <c:showLegendKey val="0"/>
-            <c:showVal val="0"/>
+            <c:showVal val="1"/>
             <c:showCatName val="0"/>
             <c:showSerName val="0"/>
             <c:showPercent val="0"/>
@@ -1815,7 +1782,6 @@
             <c:showLeaderLines val="0"/>
             <c:extLst>
               <c:ext xmlns:c15="http://schemas.microsoft.com/office/drawing/2012/chart" uri="{CE6537A1-D6FC-4f65-9D91-7224C49458BB}">
-                <c15:showDataLabelsRange val="1"/>
                 <c15:showLeaderLines val="1"/>
                 <c15:leaderLines>
                   <c:spPr>
@@ -1858,17 +1824,6 @@
             </c:numRef>
           </c:val>
           <c:extLst>
-            <c:ext xmlns:c15="http://schemas.microsoft.com/office/drawing/2012/chart" uri="{02D57815-91ED-43cb-92C2-25804820EDAC}">
-              <c15:datalabelsRange>
-                <c15:f>Sheet1!$E$3</c15:f>
-                <c15:dlblRangeCache>
-                  <c:ptCount val="1"/>
-                  <c:pt idx="0">
-                    <c:v>4.5 (30.41%)</c:v>
-                  </c:pt>
-                </c15:dlblRangeCache>
-              </c15:datalabelsRange>
-            </c:ext>
             <c:ext xmlns:c16="http://schemas.microsoft.com/office/drawing/2014/chart" uri="{C3380CC4-5D6E-409C-BE32-E72D297353CC}">
               <c16:uniqueId val="{00000005-9D08-4425-99DE-4E5501F36EC7}"/>
             </c:ext>
@@ -7686,13 +7641,13 @@
             <p:ph idx="1"/>
             <p:extLst>
               <p:ext uri="{D42A27DB-BD31-4B8C-83A1-F6EECF244321}">
-                <p14:modId xmlns:p14="http://schemas.microsoft.com/office/powerpoint/2010/main" val="408003751"/>
+                <p14:modId xmlns:p14="http://schemas.microsoft.com/office/powerpoint/2010/main" val="3756334538"/>
               </p:ext>
             </p:extLst>
           </p:nvPr>
         </p:nvGraphicFramePr>
         <p:xfrm>
-          <a:off x="838200" y="428626"/>
+          <a:off x="767862" y="323118"/>
           <a:ext cx="10515600" cy="5829300"/>
         </p:xfrm>
         <a:graphic>
@@ -7705,6 +7660,122 @@
     <p:extLst>
       <p:ext uri="{BB962C8B-B14F-4D97-AF65-F5344CB8AC3E}">
         <p14:creationId xmlns:p14="http://schemas.microsoft.com/office/powerpoint/2010/main" val="2812630168"/>
+      </p:ext>
+    </p:extLst>
+  </p:cSld>
+  <p:clrMapOvr>
+    <a:masterClrMapping/>
+  </p:clrMapOvr>
+</p:sld>
+</file>
+
+<file path=ppt/slides/slide5.xml><?xml version="1.0" encoding="utf-8"?>
+<p:sld xmlns:a="http://schemas.openxmlformats.org/drawingml/2006/main" xmlns:r="http://schemas.openxmlformats.org/officeDocument/2006/relationships" xmlns:p="http://schemas.openxmlformats.org/presentationml/2006/main">
+  <p:cSld>
+    <p:spTree>
+      <p:nvGrpSpPr>
+        <p:cNvPr id="1" name="">
+          <a:extLst>
+            <a:ext uri="{FF2B5EF4-FFF2-40B4-BE49-F238E27FC236}">
+              <a16:creationId xmlns:a16="http://schemas.microsoft.com/office/drawing/2014/main" id="{7E88BBC3-FCFB-D908-8621-21B4D06A1C4C}"/>
+            </a:ext>
+          </a:extLst>
+        </p:cNvPr>
+        <p:cNvGrpSpPr/>
+        <p:nvPr/>
+      </p:nvGrpSpPr>
+      <p:grpSpPr>
+        <a:xfrm>
+          <a:off x="0" y="0"/>
+          <a:ext cx="0" cy="0"/>
+          <a:chOff x="0" y="0"/>
+          <a:chExt cx="0" cy="0"/>
+        </a:xfrm>
+      </p:grpSpPr>
+      <p:sp>
+        <p:nvSpPr>
+          <p:cNvPr id="3" name="List">
+            <a:extLst>
+              <a:ext uri="{FF2B5EF4-FFF2-40B4-BE49-F238E27FC236}">
+                <a16:creationId xmlns:a16="http://schemas.microsoft.com/office/drawing/2014/main" id="{60020E62-F94D-048C-41EB-CD6F496590D6}"/>
+              </a:ext>
+            </a:extLst>
+          </p:cNvPr>
+          <p:cNvSpPr>
+            <a:spLocks noGrp="1"/>
+          </p:cNvSpPr>
+          <p:nvPr>
+            <p:ph idx="1"/>
+          </p:nvPr>
+        </p:nvSpPr>
+        <p:spPr/>
+        <p:txBody>
+          <a:bodyPr/>
+          <a:lstStyle/>
+          <a:p>
+            <a:r>
+              <a:rPr lang="en-US" dirty="0">
+                <a:latin typeface="Adobe Fan Heiti Std B" panose="020B0700000000000000" pitchFamily="34" charset="-128"/>
+                <a:ea typeface="Adobe Fan Heiti Std B" panose="020B0700000000000000" pitchFamily="34" charset="-128"/>
+              </a:rPr>
+              <a:t>1</a:t>
+            </a:r>
+            <a:r>
+              <a:rPr lang="en-US" baseline="30000" dirty="0">
+                <a:latin typeface="Adobe Fan Heiti Std B" panose="020B0700000000000000" pitchFamily="34" charset="-128"/>
+                <a:ea typeface="Adobe Fan Heiti Std B" panose="020B0700000000000000" pitchFamily="34" charset="-128"/>
+              </a:rPr>
+              <a:t>st</a:t>
+            </a:r>
+            <a:r>
+              <a:rPr lang="en-US" dirty="0">
+                <a:latin typeface="Adobe Fan Heiti Std B" panose="020B0700000000000000" pitchFamily="34" charset="-128"/>
+                <a:ea typeface="Adobe Fan Heiti Std B" panose="020B0700000000000000" pitchFamily="34" charset="-128"/>
+              </a:rPr>
+              <a:t> item</a:t>
+            </a:r>
+          </a:p>
+          <a:p>
+            <a:r>
+              <a:rPr lang="en-US" dirty="0">
+                <a:latin typeface="Adobe Garamond Pro Bold" panose="02020702060506020403" pitchFamily="18" charset="0"/>
+              </a:rPr>
+              <a:t>2</a:t>
+            </a:r>
+            <a:r>
+              <a:rPr lang="en-US" baseline="30000" dirty="0">
+                <a:latin typeface="Adobe Garamond Pro Bold" panose="02020702060506020403" pitchFamily="18" charset="0"/>
+              </a:rPr>
+              <a:t>nd</a:t>
+            </a:r>
+            <a:r>
+              <a:rPr lang="en-US" dirty="0">
+                <a:latin typeface="Adobe Garamond Pro Bold" panose="02020702060506020403" pitchFamily="18" charset="0"/>
+              </a:rPr>
+              <a:t> item</a:t>
+            </a:r>
+          </a:p>
+          <a:p>
+            <a:r>
+              <a:rPr lang="en-US" sz="1600" dirty="0"/>
+              <a:t>3</a:t>
+            </a:r>
+            <a:r>
+              <a:rPr lang="en-US" sz="1600" baseline="30000" dirty="0"/>
+              <a:t>rd</a:t>
+            </a:r>
+            <a:r>
+              <a:rPr lang="en-US" sz="1600" dirty="0"/>
+              <a:t> item</a:t>
+            </a:r>
+            <a:endParaRPr lang="en-IN" sz="1600" dirty="0"/>
+          </a:p>
+        </p:txBody>
+      </p:sp>
+    </p:spTree>
+    <p:extLst>
+      <p:ext uri="{BB962C8B-B14F-4D97-AF65-F5344CB8AC3E}">
+        <p14:creationId xmlns:p14="http://schemas.microsoft.com/office/powerpoint/2010/main" val="4113158550"/>
       </p:ext>
     </p:extLst>
   </p:cSld>

</xml_diff>

<commit_message>
feat: add support for dynamic chart title updates and provide a comprehensive basic usage example.
</commit_message>
<xml_diff>
--- a/templates/sample.pptx
+++ b/templates/sample.pptx
@@ -161,14 +161,14 @@
         <a:lstStyle/>
         <a:p>
           <a:pPr>
-            <a:defRPr sz="1862" b="0" i="0" u="none" strike="noStrike" kern="1200" spc="0" baseline="0">
+            <a:defRPr sz="5400" b="0" i="0" u="none" strike="noStrike" kern="1200" spc="0" baseline="0">
               <a:solidFill>
                 <a:schemeClr val="tx1">
                   <a:lumMod val="65000"/>
                   <a:lumOff val="35000"/>
                 </a:schemeClr>
               </a:solidFill>
-              <a:latin typeface="+mn-lt"/>
+              <a:latin typeface="Adobe Garamond Pro Bold" panose="02020702060506020403" pitchFamily="18" charset="0"/>
               <a:ea typeface="+mn-ea"/>
               <a:cs typeface="+mn-cs"/>
             </a:defRPr>
@@ -6875,7 +6875,7 @@
             <p:ph idx="1"/>
             <p:extLst>
               <p:ext uri="{D42A27DB-BD31-4B8C-83A1-F6EECF244321}">
-                <p14:modId xmlns:p14="http://schemas.microsoft.com/office/powerpoint/2010/main" val="1306359762"/>
+                <p14:modId xmlns:p14="http://schemas.microsoft.com/office/powerpoint/2010/main" val="735461178"/>
               </p:ext>
             </p:extLst>
           </p:nvPr>

</xml_diff>

<commit_message>
feat: add chart cache generator and basic usage example for PPTX template manipulation
</commit_message>
<xml_diff>
--- a/templates/sample.pptx
+++ b/templates/sample.pptx
@@ -148,6 +148,46 @@
   </mc:AlternateContent>
   <c:chart>
     <c:title>
+      <c:tx>
+        <c:rich>
+          <a:bodyPr rot="0" spcFirstLastPara="1" vertOverflow="ellipsis" vert="horz" wrap="square" anchor="ctr" anchorCtr="1"/>
+          <a:lstStyle/>
+          <a:p>
+            <a:pPr algn="r">
+              <a:defRPr sz="3200" b="0" i="0" u="none" strike="noStrike" kern="1200" spc="0" baseline="0">
+                <a:solidFill>
+                  <a:schemeClr val="tx1">
+                    <a:lumMod val="65000"/>
+                    <a:lumOff val="35000"/>
+                  </a:schemeClr>
+                </a:solidFill>
+                <a:latin typeface="Algerian" panose="04020705040A02060702" pitchFamily="82" charset="0"/>
+                <a:ea typeface="+mn-ea"/>
+                <a:cs typeface="+mn-cs"/>
+              </a:defRPr>
+            </a:pPr>
+            <a:r>
+              <a:rPr lang="en-IN" sz="3200" b="0" dirty="0">
+                <a:latin typeface="Algerian" panose="04020705040A02060702" pitchFamily="82" charset="0"/>
+              </a:rPr>
+              <a:t>Chart</a:t>
+            </a:r>
+          </a:p>
+          <a:p>
+            <a:pPr algn="r">
+              <a:defRPr sz="3200">
+                <a:latin typeface="Algerian" panose="04020705040A02060702" pitchFamily="82" charset="0"/>
+              </a:defRPr>
+            </a:pPr>
+            <a:r>
+              <a:rPr lang="en-IN" sz="1800" b="1" dirty="0">
+                <a:latin typeface="Agency FB" panose="020B0503020202020204" pitchFamily="34" charset="0"/>
+              </a:rPr>
+              <a:t>Title</a:t>
+            </a:r>
+          </a:p>
+        </c:rich>
+      </c:tx>
       <c:overlay val="0"/>
       <c:spPr>
         <a:noFill/>
@@ -160,15 +200,15 @@
         <a:bodyPr rot="0" spcFirstLastPara="1" vertOverflow="ellipsis" vert="horz" wrap="square" anchor="ctr" anchorCtr="1"/>
         <a:lstStyle/>
         <a:p>
-          <a:pPr>
-            <a:defRPr sz="5400" b="0" i="0" u="none" strike="noStrike" kern="1200" spc="0" baseline="0">
+          <a:pPr algn="r">
+            <a:defRPr sz="3200" b="0" i="0" u="none" strike="noStrike" kern="1200" spc="0" baseline="0">
               <a:solidFill>
                 <a:schemeClr val="tx1">
                   <a:lumMod val="65000"/>
                   <a:lumOff val="35000"/>
                 </a:schemeClr>
               </a:solidFill>
-              <a:latin typeface="Adobe Garamond Pro Bold" panose="02020702060506020403" pitchFamily="18" charset="0"/>
+              <a:latin typeface="Algerian" panose="04020705040A02060702" pitchFamily="82" charset="0"/>
               <a:ea typeface="+mn-ea"/>
               <a:cs typeface="+mn-cs"/>
             </a:defRPr>
@@ -6875,7 +6915,7 @@
             <p:ph idx="1"/>
             <p:extLst>
               <p:ext uri="{D42A27DB-BD31-4B8C-83A1-F6EECF244321}">
-                <p14:modId xmlns:p14="http://schemas.microsoft.com/office/powerpoint/2010/main" val="735461178"/>
+                <p14:modId xmlns:p14="http://schemas.microsoft.com/office/powerpoint/2010/main" val="1442623926"/>
               </p:ext>
             </p:extLst>
           </p:nvPr>

</xml_diff>

<commit_message>
feat: implement core charting, layout, and validation engines with comprehensive documentation and integration tests
</commit_message>
<xml_diff>
--- a/templates/sample.pptx
+++ b/templates/sample.pptx
@@ -1278,7 +1278,17 @@
   <c:chart>
     <c:autoTitleDeleted val="0"/>
     <c:plotArea>
-      <c:layout/>
+      <c:layout>
+        <c:manualLayout>
+          <c:layoutTarget val="inner"/>
+          <c:xMode val="edge"/>
+          <c:yMode val="edge"/>
+          <c:x val="1.2077294685990338E-2"/>
+          <c:y val="4.793028322440087E-2"/>
+          <c:w val="0.97342995169082125"/>
+          <c:h val="0.95206971677559915"/>
+        </c:manualLayout>
+      </c:layout>
       <c:barChart>
         <c:barDir val="col"/>
         <c:grouping val="stacked"/>
@@ -1312,10 +1322,38 @@
               <c:idx val="0"/>
               <c:layout>
                 <c:manualLayout>
-                  <c:x val="0.19927536231884058"/>
-                  <c:y val="0"/>
+                  <c:x val="0.19082125603864733"/>
+                  <c:y val="-0.12636165577342057"/>
                 </c:manualLayout>
               </c:layout>
+              <c:spPr>
+                <a:solidFill>
+                  <a:srgbClr val="4472C4"/>
+                </a:solidFill>
+                <a:ln>
+                  <a:noFill/>
+                </a:ln>
+                <a:effectLst/>
+              </c:spPr>
+              <c:txPr>
+                <a:bodyPr rot="0" spcFirstLastPara="1" vertOverflow="ellipsis" vert="horz" wrap="square" lIns="38100" tIns="19050" rIns="38100" bIns="19050" anchor="ctr" anchorCtr="0">
+                  <a:noAutofit/>
+                </a:bodyPr>
+                <a:lstStyle/>
+                <a:p>
+                  <a:pPr algn="ctr">
+                    <a:defRPr lang="en-US" sz="1800" b="0" i="0" u="none" strike="noStrike" kern="1200" baseline="0">
+                      <a:solidFill>
+                        <a:schemeClr val="bg1"/>
+                      </a:solidFill>
+                      <a:latin typeface="+mn-lt"/>
+                      <a:ea typeface="+mn-ea"/>
+                      <a:cs typeface="+mn-cs"/>
+                    </a:defRPr>
+                  </a:pPr>
+                  <a:endParaRPr lang="en-US"/>
+                </a:p>
+              </c:txPr>
               <c:dLblPos val="ctr"/>
               <c:showLegendKey val="0"/>
               <c:showVal val="1"/>
@@ -1324,15 +1362,22 @@
               <c:showPercent val="0"/>
               <c:showBubbleSize val="0"/>
               <c:extLst>
-                <c:ext xmlns:c15="http://schemas.microsoft.com/office/drawing/2012/chart" uri="{CE6537A1-D6FC-4f65-9D91-7224C49458BB}"/>
+                <c:ext xmlns:c15="http://schemas.microsoft.com/office/drawing/2012/chart" uri="{CE6537A1-D6FC-4f65-9D91-7224C49458BB}">
+                  <c15:layout>
+                    <c:manualLayout>
+                      <c:w val="6.6177583780288332E-2"/>
+                      <c:h val="8.4912939804093132E-2"/>
+                    </c:manualLayout>
+                  </c15:layout>
+                </c:ext>
                 <c:ext xmlns:c16="http://schemas.microsoft.com/office/drawing/2014/chart" uri="{C3380CC4-5D6E-409C-BE32-E72D297353CC}">
-                  <c16:uniqueId val="{00000001-4D89-4FC3-BEAD-7878BEFDFFA6}"/>
+                  <c16:uniqueId val="{00000001-C41C-4F54-805C-4E5E94C272C8}"/>
                 </c:ext>
               </c:extLst>
             </c:dLbl>
             <c:spPr>
               <a:solidFill>
-                <a:schemeClr val="tx1"/>
+                <a:srgbClr val="4472C4"/>
               </a:solidFill>
               <a:ln>
                 <a:noFill/>
@@ -1444,13 +1489,13 @@
               <c:idx val="0"/>
               <c:layout>
                 <c:manualLayout>
-                  <c:x val="0.1859903381642512"/>
-                  <c:y val="-2.1786492374728469E-3"/>
+                  <c:x val="0.19444444444444445"/>
+                  <c:y val="-5.4466230936819175E-2"/>
                 </c:manualLayout>
               </c:layout>
               <c:spPr>
                 <a:solidFill>
-                  <a:schemeClr val="tx1"/>
+                  <a:srgbClr val="ED7D31"/>
                 </a:solidFill>
                 <a:ln>
                   <a:noFill/>
@@ -1459,12 +1504,12 @@
               </c:spPr>
               <c:txPr>
                 <a:bodyPr rot="0" spcFirstLastPara="1" vertOverflow="ellipsis" vert="horz" wrap="square" lIns="38100" tIns="19050" rIns="38100" bIns="19050" anchor="ctr" anchorCtr="0">
-                  <a:spAutoFit/>
+                  <a:noAutofit/>
                 </a:bodyPr>
                 <a:lstStyle/>
                 <a:p>
                   <a:pPr algn="ctr">
-                    <a:defRPr lang="en-US" sz="8000" b="0" i="0" u="none" strike="noStrike" kern="1200" baseline="0">
+                    <a:defRPr lang="en-US" sz="1800" b="0" i="0" u="none" strike="noStrike" kern="1200" baseline="0">
                       <a:solidFill>
                         <a:schemeClr val="bg1"/>
                       </a:solidFill>
@@ -1484,14 +1529,23 @@
               <c:showPercent val="0"/>
               <c:showBubbleSize val="0"/>
               <c:extLst>
-                <c:ext xmlns:c15="http://schemas.microsoft.com/office/drawing/2012/chart" uri="{CE6537A1-D6FC-4f65-9D91-7224C49458BB}"/>
+                <c:ext xmlns:c15="http://schemas.microsoft.com/office/drawing/2012/chart" uri="{CE6537A1-D6FC-4f65-9D91-7224C49458BB}">
+                  <c15:layout>
+                    <c:manualLayout>
+                      <c:w val="7.7047148997679643E-2"/>
+                      <c:h val="9.7984835228929715E-2"/>
+                    </c:manualLayout>
+                  </c15:layout>
+                </c:ext>
                 <c:ext xmlns:c16="http://schemas.microsoft.com/office/drawing/2014/chart" uri="{C3380CC4-5D6E-409C-BE32-E72D297353CC}">
                   <c16:uniqueId val="{00000002-4D89-4FC3-BEAD-7878BEFDFFA6}"/>
                 </c:ext>
               </c:extLst>
             </c:dLbl>
             <c:spPr>
-              <a:noFill/>
+              <a:solidFill>
+                <a:srgbClr val="ED7D31"/>
+              </a:solidFill>
               <a:ln>
                 <a:noFill/>
               </a:ln>
@@ -1605,13 +1659,13 @@
               <c:idx val="0"/>
               <c:layout>
                 <c:manualLayout>
-                  <c:x val="0.18719806763285024"/>
-                  <c:y val="-1.0893246187363915E-2"/>
+                  <c:x val="0.1968599033816425"/>
+                  <c:y val="-0.10675381263616562"/>
                 </c:manualLayout>
               </c:layout>
               <c:spPr>
                 <a:solidFill>
-                  <a:schemeClr val="tx1"/>
+                  <a:srgbClr val="A5A5A5"/>
                 </a:solidFill>
                 <a:ln>
                   <a:noFill/>
@@ -1620,12 +1674,12 @@
               </c:spPr>
               <c:txPr>
                 <a:bodyPr rot="0" spcFirstLastPara="1" vertOverflow="ellipsis" vert="horz" wrap="square" lIns="38100" tIns="19050" rIns="38100" bIns="19050" anchor="ctr" anchorCtr="0">
-                  <a:spAutoFit/>
+                  <a:noAutofit/>
                 </a:bodyPr>
                 <a:lstStyle/>
                 <a:p>
                   <a:pPr algn="ctr">
-                    <a:defRPr lang="en-US" sz="8000" b="0" i="0" u="none" strike="noStrike" kern="1200" baseline="0">
+                    <a:defRPr lang="en-US" sz="1800" b="0" i="0" u="none" strike="noStrike" kern="1200" baseline="0">
                       <a:solidFill>
                         <a:schemeClr val="bg1"/>
                       </a:solidFill>
@@ -1645,14 +1699,23 @@
               <c:showPercent val="0"/>
               <c:showBubbleSize val="0"/>
               <c:extLst>
-                <c:ext xmlns:c15="http://schemas.microsoft.com/office/drawing/2012/chart" uri="{CE6537A1-D6FC-4f65-9D91-7224C49458BB}"/>
+                <c:ext xmlns:c15="http://schemas.microsoft.com/office/drawing/2012/chart" uri="{CE6537A1-D6FC-4f65-9D91-7224C49458BB}">
+                  <c15:layout>
+                    <c:manualLayout>
+                      <c:w val="7.22162311232835E-2"/>
+                      <c:h val="0.10452078294134802"/>
+                    </c:manualLayout>
+                  </c15:layout>
+                </c:ext>
                 <c:ext xmlns:c16="http://schemas.microsoft.com/office/drawing/2014/chart" uri="{C3380CC4-5D6E-409C-BE32-E72D297353CC}">
                   <c16:uniqueId val="{00000003-4D89-4FC3-BEAD-7878BEFDFFA6}"/>
                 </c:ext>
               </c:extLst>
             </c:dLbl>
             <c:spPr>
-              <a:noFill/>
+              <a:solidFill>
+                <a:srgbClr val="A5A5A5"/>
+              </a:solidFill>
               <a:ln>
                 <a:noFill/>
               </a:ln>
@@ -1766,10 +1829,38 @@
               <c:idx val="0"/>
               <c:layout>
                 <c:manualLayout>
-                  <c:x val="0.19444444444444445"/>
-                  <c:y val="-1.997072064003136E-17"/>
+                  <c:x val="0.18961357411845259"/>
+                  <c:y val="-0.11764705882352941"/>
                 </c:manualLayout>
               </c:layout>
+              <c:spPr>
+                <a:solidFill>
+                  <a:srgbClr val="FFC000"/>
+                </a:solidFill>
+                <a:ln>
+                  <a:noFill/>
+                </a:ln>
+                <a:effectLst/>
+              </c:spPr>
+              <c:txPr>
+                <a:bodyPr rot="0" spcFirstLastPara="1" vertOverflow="ellipsis" vert="horz" wrap="square" lIns="38100" tIns="19050" rIns="38100" bIns="19050" anchor="ctr" anchorCtr="1">
+                  <a:noAutofit/>
+                </a:bodyPr>
+                <a:lstStyle/>
+                <a:p>
+                  <a:pPr>
+                    <a:defRPr sz="1800" b="0" i="0" u="none" strike="noStrike" kern="1200" baseline="0">
+                      <a:solidFill>
+                        <a:schemeClr val="bg1"/>
+                      </a:solidFill>
+                      <a:latin typeface="+mn-lt"/>
+                      <a:ea typeface="+mn-ea"/>
+                      <a:cs typeface="+mn-cs"/>
+                    </a:defRPr>
+                  </a:pPr>
+                  <a:endParaRPr lang="en-US"/>
+                </a:p>
+              </c:txPr>
               <c:dLblPos val="ctr"/>
               <c:showLegendKey val="0"/>
               <c:showVal val="1"/>
@@ -1778,15 +1869,22 @@
               <c:showPercent val="0"/>
               <c:showBubbleSize val="0"/>
               <c:extLst>
-                <c:ext xmlns:c15="http://schemas.microsoft.com/office/drawing/2012/chart" uri="{CE6537A1-D6FC-4f65-9D91-7224C49458BB}"/>
+                <c:ext xmlns:c15="http://schemas.microsoft.com/office/drawing/2012/chart" uri="{CE6537A1-D6FC-4f65-9D91-7224C49458BB}">
+                  <c15:layout>
+                    <c:manualLayout>
+                      <c:w val="6.4969854311689293E-2"/>
+                      <c:h val="7.8376992091674813E-2"/>
+                    </c:manualLayout>
+                  </c15:layout>
+                </c:ext>
                 <c:ext xmlns:c16="http://schemas.microsoft.com/office/drawing/2014/chart" uri="{C3380CC4-5D6E-409C-BE32-E72D297353CC}">
-                  <c16:uniqueId val="{00000000-4D89-4FC3-BEAD-7878BEFDFFA6}"/>
+                  <c16:uniqueId val="{00000000-C41C-4F54-805C-4E5E94C272C8}"/>
                 </c:ext>
               </c:extLst>
             </c:dLbl>
             <c:spPr>
               <a:solidFill>
-                <a:schemeClr val="tx1"/>
+                <a:srgbClr val="FFC000"/>
               </a:solidFill>
               <a:ln>
                 <a:noFill/>
@@ -3738,7 +3836,7 @@
           <a:p>
             <a:fld id="{0490EA95-AFA9-47FA-B067-612933D1D62E}" type="datetimeFigureOut">
               <a:rPr lang="en-IN" smtClean="0"/>
-              <a:t>04-06-2026</a:t>
+              <a:t>05-06-2026</a:t>
             </a:fld>
             <a:endParaRPr lang="en-IN"/>
           </a:p>
@@ -3938,7 +4036,7 @@
           <a:p>
             <a:fld id="{0490EA95-AFA9-47FA-B067-612933D1D62E}" type="datetimeFigureOut">
               <a:rPr lang="en-IN" smtClean="0"/>
-              <a:t>04-06-2026</a:t>
+              <a:t>05-06-2026</a:t>
             </a:fld>
             <a:endParaRPr lang="en-IN"/>
           </a:p>
@@ -4148,7 +4246,7 @@
           <a:p>
             <a:fld id="{0490EA95-AFA9-47FA-B067-612933D1D62E}" type="datetimeFigureOut">
               <a:rPr lang="en-IN" smtClean="0"/>
-              <a:t>04-06-2026</a:t>
+              <a:t>05-06-2026</a:t>
             </a:fld>
             <a:endParaRPr lang="en-IN"/>
           </a:p>
@@ -4348,7 +4446,7 @@
           <a:p>
             <a:fld id="{0490EA95-AFA9-47FA-B067-612933D1D62E}" type="datetimeFigureOut">
               <a:rPr lang="en-IN" smtClean="0"/>
-              <a:t>04-06-2026</a:t>
+              <a:t>05-06-2026</a:t>
             </a:fld>
             <a:endParaRPr lang="en-IN"/>
           </a:p>
@@ -4624,7 +4722,7 @@
           <a:p>
             <a:fld id="{0490EA95-AFA9-47FA-B067-612933D1D62E}" type="datetimeFigureOut">
               <a:rPr lang="en-IN" smtClean="0"/>
-              <a:t>04-06-2026</a:t>
+              <a:t>05-06-2026</a:t>
             </a:fld>
             <a:endParaRPr lang="en-IN"/>
           </a:p>
@@ -4892,7 +4990,7 @@
           <a:p>
             <a:fld id="{0490EA95-AFA9-47FA-B067-612933D1D62E}" type="datetimeFigureOut">
               <a:rPr lang="en-IN" smtClean="0"/>
-              <a:t>04-06-2026</a:t>
+              <a:t>05-06-2026</a:t>
             </a:fld>
             <a:endParaRPr lang="en-IN"/>
           </a:p>
@@ -5307,7 +5405,7 @@
           <a:p>
             <a:fld id="{0490EA95-AFA9-47FA-B067-612933D1D62E}" type="datetimeFigureOut">
               <a:rPr lang="en-IN" smtClean="0"/>
-              <a:t>04-06-2026</a:t>
+              <a:t>05-06-2026</a:t>
             </a:fld>
             <a:endParaRPr lang="en-IN"/>
           </a:p>
@@ -5449,7 +5547,7 @@
           <a:p>
             <a:fld id="{0490EA95-AFA9-47FA-B067-612933D1D62E}" type="datetimeFigureOut">
               <a:rPr lang="en-IN" smtClean="0"/>
-              <a:t>04-06-2026</a:t>
+              <a:t>05-06-2026</a:t>
             </a:fld>
             <a:endParaRPr lang="en-IN"/>
           </a:p>
@@ -5562,7 +5660,7 @@
           <a:p>
             <a:fld id="{0490EA95-AFA9-47FA-B067-612933D1D62E}" type="datetimeFigureOut">
               <a:rPr lang="en-IN" smtClean="0"/>
-              <a:t>04-06-2026</a:t>
+              <a:t>05-06-2026</a:t>
             </a:fld>
             <a:endParaRPr lang="en-IN"/>
           </a:p>
@@ -5875,7 +5973,7 @@
           <a:p>
             <a:fld id="{0490EA95-AFA9-47FA-B067-612933D1D62E}" type="datetimeFigureOut">
               <a:rPr lang="en-IN" smtClean="0"/>
-              <a:t>04-06-2026</a:t>
+              <a:t>05-06-2026</a:t>
             </a:fld>
             <a:endParaRPr lang="en-IN"/>
           </a:p>
@@ -6164,7 +6262,7 @@
           <a:p>
             <a:fld id="{0490EA95-AFA9-47FA-B067-612933D1D62E}" type="datetimeFigureOut">
               <a:rPr lang="en-IN" smtClean="0"/>
-              <a:t>04-06-2026</a:t>
+              <a:t>05-06-2026</a:t>
             </a:fld>
             <a:endParaRPr lang="en-IN"/>
           </a:p>
@@ -6407,7 +6505,7 @@
           <a:p>
             <a:fld id="{0490EA95-AFA9-47FA-B067-612933D1D62E}" type="datetimeFigureOut">
               <a:rPr lang="en-IN" smtClean="0"/>
-              <a:t>04-06-2026</a:t>
+              <a:t>05-06-2026</a:t>
             </a:fld>
             <a:endParaRPr lang="en-IN"/>
           </a:p>
@@ -7681,7 +7779,7 @@
             <p:ph idx="1"/>
             <p:extLst>
               <p:ext uri="{D42A27DB-BD31-4B8C-83A1-F6EECF244321}">
-                <p14:modId xmlns:p14="http://schemas.microsoft.com/office/powerpoint/2010/main" val="3756334538"/>
+                <p14:modId xmlns:p14="http://schemas.microsoft.com/office/powerpoint/2010/main" val="2804675917"/>
               </p:ext>
             </p:extLst>
           </p:nvPr>
@@ -7696,6 +7794,152 @@
           </a:graphicData>
         </a:graphic>
       </p:graphicFrame>
+      <p:sp>
+        <p:nvSpPr>
+          <p:cNvPr id="2" name="Series 1">
+            <a:extLst>
+              <a:ext uri="{FF2B5EF4-FFF2-40B4-BE49-F238E27FC236}">
+                <a16:creationId xmlns:a16="http://schemas.microsoft.com/office/drawing/2014/main" id="{528C6C22-A610-78C4-A2AD-7D0567240895}"/>
+              </a:ext>
+            </a:extLst>
+          </p:cNvPr>
+          <p:cNvSpPr txBox="1"/>
+          <p:nvPr/>
+        </p:nvSpPr>
+        <p:spPr>
+          <a:xfrm>
+            <a:off x="451521" y="323118"/>
+            <a:ext cx="914033" cy="369332"/>
+          </a:xfrm>
+          <a:prstGeom prst="rect">
+            <a:avLst/>
+          </a:prstGeom>
+          <a:noFill/>
+        </p:spPr>
+        <p:txBody>
+          <a:bodyPr wrap="none" rtlCol="0">
+            <a:spAutoFit/>
+          </a:bodyPr>
+          <a:lstStyle/>
+          <a:p>
+            <a:r>
+              <a:rPr lang="en-US" dirty="0">
+                <a:latin typeface="Adobe Garamond Pro Bold" panose="02020702060506020403" pitchFamily="18" charset="0"/>
+              </a:rPr>
+              <a:t>Series 1</a:t>
+            </a:r>
+          </a:p>
+        </p:txBody>
+      </p:sp>
+      <p:sp>
+        <p:nvSpPr>
+          <p:cNvPr id="3" name="Series 2">
+            <a:extLst>
+              <a:ext uri="{FF2B5EF4-FFF2-40B4-BE49-F238E27FC236}">
+                <a16:creationId xmlns:a16="http://schemas.microsoft.com/office/drawing/2014/main" id="{69A49453-F4CD-A2C1-CCB9-8F43FA8E4533}"/>
+              </a:ext>
+            </a:extLst>
+          </p:cNvPr>
+          <p:cNvSpPr txBox="1"/>
+          <p:nvPr/>
+        </p:nvSpPr>
+        <p:spPr>
+          <a:xfrm>
+            <a:off x="2233246" y="215396"/>
+            <a:ext cx="1479892" cy="584775"/>
+          </a:xfrm>
+          <a:prstGeom prst="rect">
+            <a:avLst/>
+          </a:prstGeom>
+          <a:noFill/>
+        </p:spPr>
+        <p:txBody>
+          <a:bodyPr wrap="none" rtlCol="0">
+            <a:spAutoFit/>
+          </a:bodyPr>
+          <a:lstStyle/>
+          <a:p>
+            <a:r>
+              <a:rPr lang="en-US" sz="3200" dirty="0"/>
+              <a:t>Series 2</a:t>
+            </a:r>
+          </a:p>
+        </p:txBody>
+      </p:sp>
+      <p:sp>
+        <p:nvSpPr>
+          <p:cNvPr id="4" name="Series 3">
+            <a:extLst>
+              <a:ext uri="{FF2B5EF4-FFF2-40B4-BE49-F238E27FC236}">
+                <a16:creationId xmlns:a16="http://schemas.microsoft.com/office/drawing/2014/main" id="{2A05536A-4FFD-8E7E-9399-0D60836393AF}"/>
+              </a:ext>
+            </a:extLst>
+          </p:cNvPr>
+          <p:cNvSpPr txBox="1"/>
+          <p:nvPr/>
+        </p:nvSpPr>
+        <p:spPr>
+          <a:xfrm>
+            <a:off x="4029479" y="323117"/>
+            <a:ext cx="914033" cy="369332"/>
+          </a:xfrm>
+          <a:prstGeom prst="rect">
+            <a:avLst/>
+          </a:prstGeom>
+          <a:noFill/>
+        </p:spPr>
+        <p:txBody>
+          <a:bodyPr wrap="none" rtlCol="0">
+            <a:spAutoFit/>
+          </a:bodyPr>
+          <a:lstStyle/>
+          <a:p>
+            <a:r>
+              <a:rPr lang="en-US" dirty="0"/>
+              <a:t>Series 3</a:t>
+            </a:r>
+          </a:p>
+        </p:txBody>
+      </p:sp>
+      <p:sp>
+        <p:nvSpPr>
+          <p:cNvPr id="5" name="Series 4">
+            <a:extLst>
+              <a:ext uri="{FF2B5EF4-FFF2-40B4-BE49-F238E27FC236}">
+                <a16:creationId xmlns:a16="http://schemas.microsoft.com/office/drawing/2014/main" id="{7DC1B613-8D39-9EBB-3EDF-AB17022F34BA}"/>
+              </a:ext>
+            </a:extLst>
+          </p:cNvPr>
+          <p:cNvSpPr txBox="1"/>
+          <p:nvPr/>
+        </p:nvSpPr>
+        <p:spPr>
+          <a:xfrm>
+            <a:off x="5547945" y="430839"/>
+            <a:ext cx="696024" cy="369332"/>
+          </a:xfrm>
+          <a:prstGeom prst="rect">
+            <a:avLst/>
+          </a:prstGeom>
+          <a:noFill/>
+        </p:spPr>
+        <p:txBody>
+          <a:bodyPr wrap="none" rtlCol="0">
+            <a:spAutoFit/>
+          </a:bodyPr>
+          <a:lstStyle/>
+          <a:p>
+            <a:r>
+              <a:rPr lang="en-US" sz="1100" dirty="0"/>
+              <a:t>Series</a:t>
+            </a:r>
+            <a:r>
+              <a:rPr lang="en-US" dirty="0"/>
+              <a:t> 4</a:t>
+            </a:r>
+          </a:p>
+        </p:txBody>
+      </p:sp>
     </p:spTree>
     <p:extLst>
       <p:ext uri="{BB962C8B-B14F-4D97-AF65-F5344CB8AC3E}">

</xml_diff>

<commit_message>
feat: add shape management logic, chart caching, integration tests, and documentation site maps
</commit_message>
<xml_diff>
--- a/templates/sample.pptx
+++ b/templates/sample.pptx
@@ -1659,8 +1659,8 @@
               <c:idx val="0"/>
               <c:layout>
                 <c:manualLayout>
-                  <c:x val="0.1968599033816425"/>
-                  <c:y val="-0.10675381263616562"/>
+                  <c:x val="0.27777777777777779"/>
+                  <c:y val="-7.6252723311546866E-2"/>
                 </c:manualLayout>
               </c:layout>
               <c:spPr>
@@ -1702,8 +1702,8 @@
                 <c:ext xmlns:c15="http://schemas.microsoft.com/office/drawing/2012/chart" uri="{CE6537A1-D6FC-4f65-9D91-7224C49458BB}">
                   <c15:layout>
                     <c:manualLayout>
-                      <c:w val="7.22162311232835E-2"/>
-                      <c:h val="0.10452078294134802"/>
+                      <c:w val="0.23405197991555404"/>
+                      <c:h val="0.16552296159058552"/>
                     </c:manualLayout>
                   </c15:layout>
                 </c:ext>
@@ -7779,7 +7779,7 @@
             <p:ph idx="1"/>
             <p:extLst>
               <p:ext uri="{D42A27DB-BD31-4B8C-83A1-F6EECF244321}">
-                <p14:modId xmlns:p14="http://schemas.microsoft.com/office/powerpoint/2010/main" val="2804675917"/>
+                <p14:modId xmlns:p14="http://schemas.microsoft.com/office/powerpoint/2010/main" val="1630066042"/>
               </p:ext>
             </p:extLst>
           </p:nvPr>

</xml_diff>

<commit_message>
feat: implement cell merging and row addition logic with validation tools and documentation
</commit_message>
<xml_diff>
--- a/templates/sample.pptx
+++ b/templates/sample.pptx
@@ -3836,7 +3836,7 @@
           <a:p>
             <a:fld id="{0490EA95-AFA9-47FA-B067-612933D1D62E}" type="datetimeFigureOut">
               <a:rPr lang="en-IN" smtClean="0"/>
-              <a:t>05-06-2026</a:t>
+              <a:t>12-06-2026</a:t>
             </a:fld>
             <a:endParaRPr lang="en-IN"/>
           </a:p>
@@ -4036,7 +4036,7 @@
           <a:p>
             <a:fld id="{0490EA95-AFA9-47FA-B067-612933D1D62E}" type="datetimeFigureOut">
               <a:rPr lang="en-IN" smtClean="0"/>
-              <a:t>05-06-2026</a:t>
+              <a:t>12-06-2026</a:t>
             </a:fld>
             <a:endParaRPr lang="en-IN"/>
           </a:p>
@@ -4246,7 +4246,7 @@
           <a:p>
             <a:fld id="{0490EA95-AFA9-47FA-B067-612933D1D62E}" type="datetimeFigureOut">
               <a:rPr lang="en-IN" smtClean="0"/>
-              <a:t>05-06-2026</a:t>
+              <a:t>12-06-2026</a:t>
             </a:fld>
             <a:endParaRPr lang="en-IN"/>
           </a:p>
@@ -4446,7 +4446,7 @@
           <a:p>
             <a:fld id="{0490EA95-AFA9-47FA-B067-612933D1D62E}" type="datetimeFigureOut">
               <a:rPr lang="en-IN" smtClean="0"/>
-              <a:t>05-06-2026</a:t>
+              <a:t>12-06-2026</a:t>
             </a:fld>
             <a:endParaRPr lang="en-IN"/>
           </a:p>
@@ -4722,7 +4722,7 @@
           <a:p>
             <a:fld id="{0490EA95-AFA9-47FA-B067-612933D1D62E}" type="datetimeFigureOut">
               <a:rPr lang="en-IN" smtClean="0"/>
-              <a:t>05-06-2026</a:t>
+              <a:t>12-06-2026</a:t>
             </a:fld>
             <a:endParaRPr lang="en-IN"/>
           </a:p>
@@ -4990,7 +4990,7 @@
           <a:p>
             <a:fld id="{0490EA95-AFA9-47FA-B067-612933D1D62E}" type="datetimeFigureOut">
               <a:rPr lang="en-IN" smtClean="0"/>
-              <a:t>05-06-2026</a:t>
+              <a:t>12-06-2026</a:t>
             </a:fld>
             <a:endParaRPr lang="en-IN"/>
           </a:p>
@@ -5405,7 +5405,7 @@
           <a:p>
             <a:fld id="{0490EA95-AFA9-47FA-B067-612933D1D62E}" type="datetimeFigureOut">
               <a:rPr lang="en-IN" smtClean="0"/>
-              <a:t>05-06-2026</a:t>
+              <a:t>12-06-2026</a:t>
             </a:fld>
             <a:endParaRPr lang="en-IN"/>
           </a:p>
@@ -5547,7 +5547,7 @@
           <a:p>
             <a:fld id="{0490EA95-AFA9-47FA-B067-612933D1D62E}" type="datetimeFigureOut">
               <a:rPr lang="en-IN" smtClean="0"/>
-              <a:t>05-06-2026</a:t>
+              <a:t>12-06-2026</a:t>
             </a:fld>
             <a:endParaRPr lang="en-IN"/>
           </a:p>
@@ -5660,7 +5660,7 @@
           <a:p>
             <a:fld id="{0490EA95-AFA9-47FA-B067-612933D1D62E}" type="datetimeFigureOut">
               <a:rPr lang="en-IN" smtClean="0"/>
-              <a:t>05-06-2026</a:t>
+              <a:t>12-06-2026</a:t>
             </a:fld>
             <a:endParaRPr lang="en-IN"/>
           </a:p>
@@ -5973,7 +5973,7 @@
           <a:p>
             <a:fld id="{0490EA95-AFA9-47FA-B067-612933D1D62E}" type="datetimeFigureOut">
               <a:rPr lang="en-IN" smtClean="0"/>
-              <a:t>05-06-2026</a:t>
+              <a:t>12-06-2026</a:t>
             </a:fld>
             <a:endParaRPr lang="en-IN"/>
           </a:p>
@@ -6262,7 +6262,7 @@
           <a:p>
             <a:fld id="{0490EA95-AFA9-47FA-B067-612933D1D62E}" type="datetimeFigureOut">
               <a:rPr lang="en-IN" smtClean="0"/>
-              <a:t>05-06-2026</a:t>
+              <a:t>12-06-2026</a:t>
             </a:fld>
             <a:endParaRPr lang="en-IN"/>
           </a:p>
@@ -6505,7 +6505,7 @@
           <a:p>
             <a:fld id="{0490EA95-AFA9-47FA-B067-612933D1D62E}" type="datetimeFigureOut">
               <a:rPr lang="en-IN" smtClean="0"/>
-              <a:t>05-06-2026</a:t>
+              <a:t>12-06-2026</a:t>
             </a:fld>
             <a:endParaRPr lang="en-IN"/>
           </a:p>
@@ -7176,16 +7176,23 @@
             <p:ph type="title"/>
           </p:nvPr>
         </p:nvSpPr>
-        <p:spPr/>
+        <p:spPr>
+          <a:xfrm>
+            <a:off x="838200" y="365125"/>
+            <a:ext cx="10515600" cy="369333"/>
+          </a:xfrm>
+        </p:spPr>
         <p:txBody>
-          <a:bodyPr/>
+          <a:bodyPr>
+            <a:normAutofit fontScale="90000"/>
+          </a:bodyPr>
           <a:lstStyle/>
           <a:p>
             <a:r>
-              <a:rPr lang="en-US" dirty="0"/>
+              <a:rPr lang="en-US" sz="2800" dirty="0"/>
               <a:t>Hello {{title}}</a:t>
             </a:r>
-            <a:endParaRPr lang="en-IN" dirty="0"/>
+            <a:endParaRPr lang="en-IN" sz="2800" dirty="0"/>
           </a:p>
         </p:txBody>
       </p:sp>
@@ -7205,13 +7212,13 @@
             <p:ph idx="1"/>
             <p:extLst>
               <p:ext uri="{D42A27DB-BD31-4B8C-83A1-F6EECF244321}">
-                <p14:modId xmlns:p14="http://schemas.microsoft.com/office/powerpoint/2010/main" val="143244436"/>
+                <p14:modId xmlns:p14="http://schemas.microsoft.com/office/powerpoint/2010/main" val="1376998038"/>
               </p:ext>
             </p:extLst>
           </p:nvPr>
         </p:nvGraphicFramePr>
         <p:xfrm>
-          <a:off x="838200" y="1825625"/>
+          <a:off x="838200" y="732950"/>
           <a:ext cx="10515600" cy="741680"/>
         </p:xfrm>
         <a:graphic>
@@ -7419,7 +7426,7 @@
         </p:nvSpPr>
         <p:spPr>
           <a:xfrm>
-            <a:off x="2121408" y="3931920"/>
+            <a:off x="838200" y="-4207"/>
             <a:ext cx="3621024" cy="369332"/>
           </a:xfrm>
           <a:prstGeom prst="rect">
@@ -7455,13 +7462,13 @@
           <p:nvPr>
             <p:extLst>
               <p:ext uri="{D42A27DB-BD31-4B8C-83A1-F6EECF244321}">
-                <p14:modId xmlns:p14="http://schemas.microsoft.com/office/powerpoint/2010/main" val="3135479140"/>
+                <p14:modId xmlns:p14="http://schemas.microsoft.com/office/powerpoint/2010/main" val="2384673608"/>
               </p:ext>
             </p:extLst>
           </p:nvPr>
         </p:nvGraphicFramePr>
         <p:xfrm>
-          <a:off x="838200" y="5028956"/>
+          <a:off x="838200" y="5745480"/>
           <a:ext cx="10515600" cy="1112520"/>
         </p:xfrm>
         <a:graphic>
@@ -7690,6 +7697,10 @@
                     <a:lstStyle/>
                     <a:p>
                       <a:pPr algn="ctr"/>
+                      <a:r>
+                        <a:rPr lang="en-US" dirty="0" err="1"/>
+                        <a:t>qqqwet</a:t>
+                      </a:r>
                       <a:endParaRPr lang="en-IN" dirty="0"/>
                     </a:p>
                   </a:txBody>

</xml_diff>

<commit_message>
feat: add alignShapeToCell method for positioning shapes within table cells
</commit_message>
<xml_diff>
--- a/templates/sample.pptx
+++ b/templates/sample.pptx
@@ -126,11 +126,17 @@
         </p14:section>
       </p14:sectionLst>
     </p:ext>
-    <p:ext uri="{EFAFB233-063F-42B5-8137-9DF3F51BA10A}">
-      <p15:sldGuideLst xmlns:p15="http://schemas.microsoft.com/office/powerpoint/2012/main"/>
-    </p:ext>
   </p:extLst>
 </p:presentation>
+</file>
+
+<file path=ppt/revisionInfo.xml><?xml version="1.0" encoding="utf-8"?>
+<p1510:revInfo xmlns:a="http://schemas.openxmlformats.org/drawingml/2006/main" xmlns:r="http://schemas.openxmlformats.org/officeDocument/2006/relationships" xmlns:p1510="http://schemas.microsoft.com/office/powerpoint/2015/10/main">
+  <p1510:revLst>
+    <p1510:client id="{00C3C471-C754-871F-AF6C-A200F7425B03}" v="122" dt="2026-06-18T11:32:04.302"/>
+    <p1510:client id="{2796ABAA-F5FB-42ED-8CAB-0587183265E4}" v="9" dt="2026-06-18T08:43:12.964"/>
+  </p1510:revLst>
+</p1510:revInfo>
 </file>
 
 <file path=ppt/charts/chart1.xml><?xml version="1.0" encoding="utf-8"?>
@@ -167,7 +173,7 @@
               </a:defRPr>
             </a:pPr>
             <a:r>
-              <a:rPr lang="en-IN" sz="3200" b="0" dirty="0">
+              <a:rPr lang="en-IN" sz="3200" b="0">
                 <a:latin typeface="Algerian" panose="04020705040A02060702" pitchFamily="82" charset="0"/>
               </a:rPr>
               <a:t>Chart</a:t>
@@ -180,7 +186,7 @@
               </a:defRPr>
             </a:pPr>
             <a:r>
-              <a:rPr lang="en-IN" sz="1800" b="1" dirty="0">
+              <a:rPr lang="en-IN" sz="1800" b="1">
                 <a:latin typeface="Agency FB" panose="020B0503020202020204" pitchFamily="34" charset="0"/>
               </a:rPr>
               <a:t>Title</a:t>
@@ -3836,7 +3842,7 @@
           <a:p>
             <a:fld id="{0490EA95-AFA9-47FA-B067-612933D1D62E}" type="datetimeFigureOut">
               <a:rPr lang="en-IN" smtClean="0"/>
-              <a:t>12-06-2026</a:t>
+              <a:t>18-06-2026</a:t>
             </a:fld>
             <a:endParaRPr lang="en-IN"/>
           </a:p>
@@ -4036,7 +4042,7 @@
           <a:p>
             <a:fld id="{0490EA95-AFA9-47FA-B067-612933D1D62E}" type="datetimeFigureOut">
               <a:rPr lang="en-IN" smtClean="0"/>
-              <a:t>12-06-2026</a:t>
+              <a:t>18-06-2026</a:t>
             </a:fld>
             <a:endParaRPr lang="en-IN"/>
           </a:p>
@@ -4246,7 +4252,7 @@
           <a:p>
             <a:fld id="{0490EA95-AFA9-47FA-B067-612933D1D62E}" type="datetimeFigureOut">
               <a:rPr lang="en-IN" smtClean="0"/>
-              <a:t>12-06-2026</a:t>
+              <a:t>18-06-2026</a:t>
             </a:fld>
             <a:endParaRPr lang="en-IN"/>
           </a:p>
@@ -4446,7 +4452,7 @@
           <a:p>
             <a:fld id="{0490EA95-AFA9-47FA-B067-612933D1D62E}" type="datetimeFigureOut">
               <a:rPr lang="en-IN" smtClean="0"/>
-              <a:t>12-06-2026</a:t>
+              <a:t>18-06-2026</a:t>
             </a:fld>
             <a:endParaRPr lang="en-IN"/>
           </a:p>
@@ -4722,7 +4728,7 @@
           <a:p>
             <a:fld id="{0490EA95-AFA9-47FA-B067-612933D1D62E}" type="datetimeFigureOut">
               <a:rPr lang="en-IN" smtClean="0"/>
-              <a:t>12-06-2026</a:t>
+              <a:t>18-06-2026</a:t>
             </a:fld>
             <a:endParaRPr lang="en-IN"/>
           </a:p>
@@ -4990,7 +4996,7 @@
           <a:p>
             <a:fld id="{0490EA95-AFA9-47FA-B067-612933D1D62E}" type="datetimeFigureOut">
               <a:rPr lang="en-IN" smtClean="0"/>
-              <a:t>12-06-2026</a:t>
+              <a:t>18-06-2026</a:t>
             </a:fld>
             <a:endParaRPr lang="en-IN"/>
           </a:p>
@@ -5405,7 +5411,7 @@
           <a:p>
             <a:fld id="{0490EA95-AFA9-47FA-B067-612933D1D62E}" type="datetimeFigureOut">
               <a:rPr lang="en-IN" smtClean="0"/>
-              <a:t>12-06-2026</a:t>
+              <a:t>18-06-2026</a:t>
             </a:fld>
             <a:endParaRPr lang="en-IN"/>
           </a:p>
@@ -5547,7 +5553,7 @@
           <a:p>
             <a:fld id="{0490EA95-AFA9-47FA-B067-612933D1D62E}" type="datetimeFigureOut">
               <a:rPr lang="en-IN" smtClean="0"/>
-              <a:t>12-06-2026</a:t>
+              <a:t>18-06-2026</a:t>
             </a:fld>
             <a:endParaRPr lang="en-IN"/>
           </a:p>
@@ -5660,7 +5666,7 @@
           <a:p>
             <a:fld id="{0490EA95-AFA9-47FA-B067-612933D1D62E}" type="datetimeFigureOut">
               <a:rPr lang="en-IN" smtClean="0"/>
-              <a:t>12-06-2026</a:t>
+              <a:t>18-06-2026</a:t>
             </a:fld>
             <a:endParaRPr lang="en-IN"/>
           </a:p>
@@ -5973,7 +5979,7 @@
           <a:p>
             <a:fld id="{0490EA95-AFA9-47FA-B067-612933D1D62E}" type="datetimeFigureOut">
               <a:rPr lang="en-IN" smtClean="0"/>
-              <a:t>12-06-2026</a:t>
+              <a:t>18-06-2026</a:t>
             </a:fld>
             <a:endParaRPr lang="en-IN"/>
           </a:p>
@@ -6262,7 +6268,7 @@
           <a:p>
             <a:fld id="{0490EA95-AFA9-47FA-B067-612933D1D62E}" type="datetimeFigureOut">
               <a:rPr lang="en-IN" smtClean="0"/>
-              <a:t>12-06-2026</a:t>
+              <a:t>18-06-2026</a:t>
             </a:fld>
             <a:endParaRPr lang="en-IN"/>
           </a:p>
@@ -6505,7 +6511,7 @@
           <a:p>
             <a:fld id="{0490EA95-AFA9-47FA-B067-612933D1D62E}" type="datetimeFigureOut">
               <a:rPr lang="en-IN" smtClean="0"/>
-              <a:t>12-06-2026</a:t>
+              <a:t>18-06-2026</a:t>
             </a:fld>
             <a:endParaRPr lang="en-IN"/>
           </a:p>
@@ -6990,10 +6996,10 @@
           <a:lstStyle/>
           <a:p>
             <a:r>
-              <a:rPr lang="en-US" dirty="0"/>
+              <a:rPr lang="en-US"/>
               <a:t>Hello {{title}}</a:t>
             </a:r>
-            <a:endParaRPr lang="en-IN" dirty="0"/>
+            <a:endParaRPr lang="en-IN"/>
           </a:p>
         </p:txBody>
       </p:sp>
@@ -7013,7 +7019,7 @@
             <p:ph idx="1"/>
             <p:extLst>
               <p:ext uri="{D42A27DB-BD31-4B8C-83A1-F6EECF244321}">
-                <p14:modId xmlns:p14="http://schemas.microsoft.com/office/powerpoint/2010/main" val="1442623926"/>
+                <p14:modId xmlns:p14="http://schemas.microsoft.com/office/powerpoint/2010/main" val="1651760440"/>
               </p:ext>
             </p:extLst>
           </p:nvPr>
@@ -7086,10 +7092,10 @@
           <a:lstStyle/>
           <a:p>
             <a:r>
-              <a:rPr lang="en-US" dirty="0"/>
+              <a:rPr lang="en-US"/>
               <a:t>Hello {{title2}}</a:t>
             </a:r>
-            <a:endParaRPr lang="en-IN" dirty="0"/>
+            <a:endParaRPr lang="en-IN"/>
           </a:p>
         </p:txBody>
       </p:sp>
@@ -7189,10 +7195,10 @@
           <a:lstStyle/>
           <a:p>
             <a:r>
-              <a:rPr lang="en-US" sz="2800" dirty="0"/>
+              <a:rPr lang="en-US" sz="2800"/>
               <a:t>Hello {{title}}</a:t>
             </a:r>
-            <a:endParaRPr lang="en-IN" sz="2800" dirty="0"/>
+            <a:endParaRPr lang="en-IN" sz="2800"/>
           </a:p>
         </p:txBody>
       </p:sp>
@@ -7212,14 +7218,14 @@
             <p:ph idx="1"/>
             <p:extLst>
               <p:ext uri="{D42A27DB-BD31-4B8C-83A1-F6EECF244321}">
-                <p14:modId xmlns:p14="http://schemas.microsoft.com/office/powerpoint/2010/main" val="1376998038"/>
+                <p14:modId xmlns:p14="http://schemas.microsoft.com/office/powerpoint/2010/main" val="2181067659"/>
               </p:ext>
             </p:extLst>
           </p:nvPr>
         </p:nvGraphicFramePr>
         <p:xfrm>
           <a:off x="838200" y="732950"/>
-          <a:ext cx="10515600" cy="741680"/>
+          <a:ext cx="10515600" cy="2343688"/>
         </p:xfrm>
         <a:graphic>
           <a:graphicData uri="http://schemas.openxmlformats.org/drawingml/2006/table">
@@ -7228,38 +7234,45 @@
                 <a:tableStyleId>{5C22544A-7EE6-4342-B048-85BDC9FD1C3A}</a:tableStyleId>
               </a:tblPr>
               <a:tblGrid>
-                <a:gridCol w="2103120">
+                <a:gridCol w="1752600">
                   <a:extLst>
                     <a:ext uri="{9D8B030D-6E8A-4147-A177-3AD203B41FA5}">
                       <a16:colId xmlns:a16="http://schemas.microsoft.com/office/drawing/2014/main" val="1526623959"/>
                     </a:ext>
                   </a:extLst>
                 </a:gridCol>
-                <a:gridCol w="2103120">
+                <a:gridCol w="1752600">
                   <a:extLst>
                     <a:ext uri="{9D8B030D-6E8A-4147-A177-3AD203B41FA5}">
                       <a16:colId xmlns:a16="http://schemas.microsoft.com/office/drawing/2014/main" val="2988579106"/>
                     </a:ext>
                   </a:extLst>
                 </a:gridCol>
-                <a:gridCol w="2103120">
+                <a:gridCol w="1752600">
                   <a:extLst>
                     <a:ext uri="{9D8B030D-6E8A-4147-A177-3AD203B41FA5}">
                       <a16:colId xmlns:a16="http://schemas.microsoft.com/office/drawing/2014/main" val="1994860425"/>
                     </a:ext>
                   </a:extLst>
                 </a:gridCol>
-                <a:gridCol w="2103120">
+                <a:gridCol w="1752600">
                   <a:extLst>
                     <a:ext uri="{9D8B030D-6E8A-4147-A177-3AD203B41FA5}">
                       <a16:colId xmlns:a16="http://schemas.microsoft.com/office/drawing/2014/main" val="3533840823"/>
                     </a:ext>
                   </a:extLst>
                 </a:gridCol>
-                <a:gridCol w="2103120">
+                <a:gridCol w="1752600">
                   <a:extLst>
                     <a:ext uri="{9D8B030D-6E8A-4147-A177-3AD203B41FA5}">
                       <a16:colId xmlns:a16="http://schemas.microsoft.com/office/drawing/2014/main" val="1604916882"/>
+                    </a:ext>
+                  </a:extLst>
+                </a:gridCol>
+                <a:gridCol w="1752600">
+                  <a:extLst>
+                    <a:ext uri="{9D8B030D-6E8A-4147-A177-3AD203B41FA5}">
+                      <a16:colId xmlns:a16="http://schemas.microsoft.com/office/drawing/2014/main" val="2482243882"/>
                     </a:ext>
                   </a:extLst>
                 </a:gridCol>
@@ -7270,65 +7283,85 @@
                     <a:bodyPr/>
                     <a:lstStyle/>
                     <a:p>
+                      <a:pPr algn="ctr"/>
                       <a:r>
-                        <a:rPr lang="en-IN" dirty="0"/>
+                        <a:rPr lang="en-IN"/>
                         <a:t>A</a:t>
                       </a:r>
                     </a:p>
                   </a:txBody>
-                  <a:tcPr/>
+                  <a:tcPr anchor="ctr"/>
                 </a:tc>
                 <a:tc>
                   <a:txBody>
                     <a:bodyPr/>
                     <a:lstStyle/>
                     <a:p>
+                      <a:pPr algn="ctr"/>
                       <a:r>
-                        <a:rPr lang="en-IN" dirty="0"/>
+                        <a:rPr lang="en-IN"/>
                         <a:t>V</a:t>
                       </a:r>
                     </a:p>
                   </a:txBody>
-                  <a:tcPr/>
+                  <a:tcPr anchor="ctr"/>
                 </a:tc>
                 <a:tc>
                   <a:txBody>
                     <a:bodyPr/>
                     <a:lstStyle/>
                     <a:p>
+                      <a:pPr algn="ctr"/>
                       <a:r>
-                        <a:rPr lang="en-IN" dirty="0"/>
+                        <a:rPr lang="en-IN"/>
                         <a:t>B</a:t>
                       </a:r>
                     </a:p>
                   </a:txBody>
-                  <a:tcPr/>
+                  <a:tcPr anchor="ctr"/>
                 </a:tc>
                 <a:tc>
                   <a:txBody>
                     <a:bodyPr/>
                     <a:lstStyle/>
                     <a:p>
+                      <a:pPr algn="ctr"/>
                       <a:r>
-                        <a:rPr lang="en-IN" dirty="0"/>
+                        <a:rPr lang="en-IN"/>
                         <a:t>C</a:t>
                       </a:r>
                     </a:p>
                   </a:txBody>
-                  <a:tcPr/>
+                  <a:tcPr anchor="ctr"/>
                 </a:tc>
                 <a:tc>
                   <a:txBody>
                     <a:bodyPr/>
                     <a:lstStyle/>
                     <a:p>
+                      <a:pPr algn="ctr"/>
                       <a:r>
-                        <a:rPr lang="en-IN" dirty="0"/>
+                        <a:rPr lang="en-IN"/>
                         <a:t>D</a:t>
                       </a:r>
                     </a:p>
                   </a:txBody>
-                  <a:tcPr/>
+                  <a:tcPr anchor="ctr"/>
+                </a:tc>
+                <a:tc>
+                  <a:txBody>
+                    <a:bodyPr/>
+                    <a:lstStyle/>
+                    <a:p>
+                      <a:pPr algn="ctr"/>
+                      <a:r>
+                        <a:rPr lang="en-US"/>
+                        <a:t>STATUS</a:t>
+                      </a:r>
+                      <a:endParaRPr lang="en-IN"/>
+                    </a:p>
+                  </a:txBody>
+                  <a:tcPr anchor="ctr"/>
                 </a:tc>
                 <a:extLst>
                   <a:ext uri="{0D108BD9-81ED-4DB2-BD59-A6C34878D82A}">
@@ -7336,71 +7369,279 @@
                   </a:ext>
                 </a:extLst>
               </a:tr>
-              <a:tr h="370840">
+              <a:tr h="657616">
                 <a:tc>
                   <a:txBody>
                     <a:bodyPr/>
                     <a:lstStyle/>
                     <a:p>
+                      <a:pPr algn="ctr"/>
                       <a:r>
-                        <a:rPr lang="en-IN" dirty="0"/>
+                        <a:rPr lang="en-IN"/>
                         <a:t>100</a:t>
                       </a:r>
                     </a:p>
                   </a:txBody>
-                  <a:tcPr/>
+                  <a:tcPr anchor="ctr"/>
                 </a:tc>
                 <a:tc>
                   <a:txBody>
                     <a:bodyPr/>
                     <a:lstStyle/>
                     <a:p>
+                      <a:pPr algn="ctr"/>
                       <a:r>
-                        <a:rPr lang="en-IN" dirty="0"/>
+                        <a:rPr lang="en-IN"/>
                         <a:t>23</a:t>
                       </a:r>
                     </a:p>
                   </a:txBody>
-                  <a:tcPr/>
+                  <a:tcPr anchor="ctr"/>
                 </a:tc>
                 <a:tc>
                   <a:txBody>
                     <a:bodyPr/>
                     <a:lstStyle/>
                     <a:p>
+                      <a:pPr algn="ctr"/>
                       <a:r>
-                        <a:rPr lang="en-IN" dirty="0"/>
+                        <a:rPr lang="en-IN"/>
                         <a:t>24</a:t>
                       </a:r>
                     </a:p>
                   </a:txBody>
-                  <a:tcPr/>
+                  <a:tcPr anchor="ctr"/>
                 </a:tc>
                 <a:tc>
                   <a:txBody>
                     <a:bodyPr/>
                     <a:lstStyle/>
                     <a:p>
+                      <a:pPr algn="ctr"/>
                       <a:r>
-                        <a:rPr lang="en-IN" dirty="0"/>
+                        <a:rPr lang="en-IN"/>
                         <a:t>34</a:t>
                       </a:r>
                     </a:p>
                   </a:txBody>
-                  <a:tcPr/>
+                  <a:tcPr anchor="ctr"/>
                 </a:tc>
                 <a:tc>
                   <a:txBody>
                     <a:bodyPr/>
                     <a:lstStyle/>
                     <a:p>
+                      <a:pPr algn="ctr"/>
                       <a:r>
-                        <a:rPr lang="en-IN" dirty="0"/>
-                        <a:t>53</a:t>
+                        <a:rPr lang="en-IN"/>
+                        <a:t>30</a:t>
                       </a:r>
                     </a:p>
                   </a:txBody>
-                  <a:tcPr/>
+                  <a:tcPr anchor="ctr"/>
+                </a:tc>
+                <a:tc>
+                  <a:txBody>
+                    <a:bodyPr/>
+                    <a:lstStyle/>
+                    <a:p>
+                      <a:pPr algn="ctr"/>
+                      <a:r>
+                        <a:rPr lang="en-US"/>
+                        <a:t>S</a:t>
+                      </a:r>
+                      <a:endParaRPr lang="en-IN"/>
+                    </a:p>
+                  </a:txBody>
+                  <a:tcPr anchor="ctr"/>
+                </a:tc>
+                <a:extLst>
+                  <a:ext uri="{0D108BD9-81ED-4DB2-BD59-A6C34878D82A}">
+                    <a16:rowId xmlns:a16="http://schemas.microsoft.com/office/drawing/2014/main" val="2255589700"/>
+                  </a:ext>
+                </a:extLst>
+              </a:tr>
+              <a:tr h="626301">
+                <a:tc>
+                  <a:txBody>
+                    <a:bodyPr/>
+                    <a:lstStyle/>
+                    <a:p>
+                      <a:pPr algn="ctr"/>
+                      <a:r>
+                        <a:rPr lang="en-IN"/>
+                        <a:t>100</a:t>
+                      </a:r>
+                    </a:p>
+                  </a:txBody>
+                  <a:tcPr anchor="ctr"/>
+                </a:tc>
+                <a:tc>
+                  <a:txBody>
+                    <a:bodyPr/>
+                    <a:lstStyle/>
+                    <a:p>
+                      <a:pPr algn="ctr"/>
+                      <a:r>
+                        <a:rPr lang="en-IN"/>
+                        <a:t>23</a:t>
+                      </a:r>
+                    </a:p>
+                  </a:txBody>
+                  <a:tcPr anchor="ctr"/>
+                </a:tc>
+                <a:tc>
+                  <a:txBody>
+                    <a:bodyPr/>
+                    <a:lstStyle/>
+                    <a:p>
+                      <a:pPr algn="ctr"/>
+                      <a:r>
+                        <a:rPr lang="en-IN"/>
+                        <a:t>24</a:t>
+                      </a:r>
+                    </a:p>
+                  </a:txBody>
+                  <a:tcPr anchor="ctr"/>
+                </a:tc>
+                <a:tc>
+                  <a:txBody>
+                    <a:bodyPr/>
+                    <a:lstStyle/>
+                    <a:p>
+                      <a:pPr algn="ctr"/>
+                      <a:r>
+                        <a:rPr lang="en-IN"/>
+                        <a:t>34</a:t>
+                      </a:r>
+                    </a:p>
+                  </a:txBody>
+                  <a:tcPr anchor="ctr"/>
+                </a:tc>
+                <a:tc>
+                  <a:txBody>
+                    <a:bodyPr/>
+                    <a:lstStyle/>
+                    <a:p>
+                      <a:pPr algn="ctr"/>
+                      <a:r>
+                        <a:rPr lang="en-US"/>
+                        <a:t>5</a:t>
+                      </a:r>
+                      <a:r>
+                        <a:rPr lang="en-IN"/>
+                        <a:t>0</a:t>
+                      </a:r>
+                    </a:p>
+                  </a:txBody>
+                  <a:tcPr anchor="ctr"/>
+                </a:tc>
+                <a:tc>
+                  <a:txBody>
+                    <a:bodyPr/>
+                    <a:lstStyle/>
+                    <a:p>
+                      <a:pPr algn="ctr"/>
+                      <a:r>
+                        <a:rPr lang="en-US"/>
+                        <a:t>F</a:t>
+                      </a:r>
+                      <a:endParaRPr lang="en-IN"/>
+                    </a:p>
+                  </a:txBody>
+                  <a:tcPr anchor="ctr"/>
+                </a:tc>
+                <a:extLst>
+                  <a:ext uri="{0D108BD9-81ED-4DB2-BD59-A6C34878D82A}">
+                    <a16:rowId xmlns:a16="http://schemas.microsoft.com/office/drawing/2014/main" val="3331277678"/>
+                  </a:ext>
+                </a:extLst>
+              </a:tr>
+              <a:tr h="688931">
+                <a:tc>
+                  <a:txBody>
+                    <a:bodyPr/>
+                    <a:lstStyle/>
+                    <a:p>
+                      <a:pPr algn="ctr"/>
+                      <a:r>
+                        <a:rPr lang="en-IN"/>
+                        <a:t>100</a:t>
+                      </a:r>
+                    </a:p>
+                  </a:txBody>
+                  <a:tcPr anchor="ctr"/>
+                </a:tc>
+                <a:tc>
+                  <a:txBody>
+                    <a:bodyPr/>
+                    <a:lstStyle/>
+                    <a:p>
+                      <a:pPr algn="ctr"/>
+                      <a:r>
+                        <a:rPr lang="en-IN"/>
+                        <a:t>23</a:t>
+                      </a:r>
+                    </a:p>
+                  </a:txBody>
+                  <a:tcPr anchor="ctr"/>
+                </a:tc>
+                <a:tc>
+                  <a:txBody>
+                    <a:bodyPr/>
+                    <a:lstStyle/>
+                    <a:p>
+                      <a:pPr algn="ctr"/>
+                      <a:r>
+                        <a:rPr lang="en-IN"/>
+                        <a:t>24</a:t>
+                      </a:r>
+                    </a:p>
+                  </a:txBody>
+                  <a:tcPr anchor="ctr"/>
+                </a:tc>
+                <a:tc>
+                  <a:txBody>
+                    <a:bodyPr/>
+                    <a:lstStyle/>
+                    <a:p>
+                      <a:pPr algn="ctr"/>
+                      <a:r>
+                        <a:rPr lang="en-IN"/>
+                        <a:t>34</a:t>
+                      </a:r>
+                    </a:p>
+                  </a:txBody>
+                  <a:tcPr anchor="ctr"/>
+                </a:tc>
+                <a:tc>
+                  <a:txBody>
+                    <a:bodyPr/>
+                    <a:lstStyle/>
+                    <a:p>
+                      <a:pPr algn="ctr"/>
+                      <a:r>
+                        <a:rPr lang="en-IN"/>
+                        <a:t>80</a:t>
+                      </a:r>
+                    </a:p>
+                  </a:txBody>
+                  <a:tcPr anchor="ctr"/>
+                </a:tc>
+                <a:tc>
+                  <a:txBody>
+                    <a:bodyPr/>
+                    <a:lstStyle/>
+                    <a:p>
+                      <a:pPr algn="ctr"/>
+                      <a:r>
+                        <a:rPr lang="en-US"/>
+                        <a:t>S</a:t>
+                      </a:r>
+                      <a:endParaRPr lang="en-IN"/>
+                    </a:p>
+                  </a:txBody>
+                  <a:tcPr anchor="ctr"/>
                 </a:tc>
                 <a:extLst>
                   <a:ext uri="{0D108BD9-81ED-4DB2-BD59-A6C34878D82A}">
@@ -7441,7 +7682,7 @@
           <a:lstStyle/>
           <a:p>
             <a:r>
-              <a:rPr lang="en-IN" dirty="0"/>
+              <a:rPr lang="en-IN"/>
               <a:t>Google</a:t>
             </a:r>
           </a:p>
@@ -7522,7 +7763,7 @@
                     <a:p>
                       <a:pPr algn="ctr"/>
                       <a:r>
-                        <a:rPr lang="en-IN" dirty="0"/>
+                        <a:rPr lang="en-IN"/>
                         <a:t>test</a:t>
                       </a:r>
                     </a:p>
@@ -7546,7 +7787,7 @@
                     <a:p>
                       <a:pPr algn="ctr"/>
                       <a:r>
-                        <a:rPr lang="en-IN" dirty="0"/>
+                        <a:rPr lang="en-IN"/>
                         <a:t>B</a:t>
                       </a:r>
                     </a:p>
@@ -7560,7 +7801,7 @@
                     <a:p>
                       <a:pPr algn="ctr"/>
                       <a:r>
-                        <a:rPr lang="en-IN" dirty="0"/>
+                        <a:rPr lang="en-IN"/>
                         <a:t>C</a:t>
                       </a:r>
                     </a:p>
@@ -7574,7 +7815,7 @@
                     <a:p>
                       <a:pPr algn="ctr"/>
                       <a:r>
-                        <a:rPr lang="en-IN" dirty="0"/>
+                        <a:rPr lang="en-IN"/>
                         <a:t>D</a:t>
                       </a:r>
                     </a:p>
@@ -7595,7 +7836,7 @@
                     <a:p>
                       <a:pPr algn="ctr"/>
                       <a:r>
-                        <a:rPr lang="en-IN" dirty="0"/>
+                        <a:rPr lang="en-IN"/>
                         <a:t>100</a:t>
                       </a:r>
                     </a:p>
@@ -7619,7 +7860,7 @@
                     <a:p>
                       <a:pPr algn="ctr"/>
                       <a:r>
-                        <a:rPr lang="en-IN" dirty="0"/>
+                        <a:rPr lang="en-IN"/>
                         <a:t>24</a:t>
                       </a:r>
                     </a:p>
@@ -7633,7 +7874,7 @@
                     <a:p>
                       <a:pPr algn="ctr"/>
                       <a:r>
-                        <a:rPr lang="en-IN" dirty="0"/>
+                        <a:rPr lang="en-IN"/>
                         <a:t>34</a:t>
                       </a:r>
                     </a:p>
@@ -7647,7 +7888,7 @@
                     <a:p>
                       <a:pPr algn="ctr"/>
                       <a:r>
-                        <a:rPr lang="en-IN" dirty="0"/>
+                        <a:rPr lang="en-IN"/>
                         <a:t>53</a:t>
                       </a:r>
                     </a:p>
@@ -7668,10 +7909,10 @@
                     <a:p>
                       <a:pPr algn="ctr"/>
                       <a:r>
-                        <a:rPr lang="en-US" dirty="0"/>
+                        <a:rPr lang="en-US"/>
                         <a:t>55</a:t>
                       </a:r>
-                      <a:endParaRPr lang="en-IN" dirty="0"/>
+                      <a:endParaRPr lang="en-IN"/>
                     </a:p>
                   </a:txBody>
                   <a:tcPr/>
@@ -7683,10 +7924,10 @@
                     <a:p>
                       <a:pPr algn="ctr"/>
                       <a:r>
-                        <a:rPr lang="en-US" dirty="0"/>
+                        <a:rPr lang="en-US"/>
                         <a:t>45</a:t>
                       </a:r>
-                      <a:endParaRPr lang="en-IN" dirty="0"/>
+                      <a:endParaRPr lang="en-IN"/>
                     </a:p>
                   </a:txBody>
                   <a:tcPr/>
@@ -7698,10 +7939,10 @@
                     <a:p>
                       <a:pPr algn="ctr"/>
                       <a:r>
-                        <a:rPr lang="en-US" dirty="0" err="1"/>
+                        <a:rPr lang="en-US" err="1"/>
                         <a:t>qqqwet</a:t>
                       </a:r>
-                      <a:endParaRPr lang="en-IN" dirty="0"/>
+                      <a:endParaRPr lang="en-IN"/>
                     </a:p>
                   </a:txBody>
                   <a:tcPr/>
@@ -7712,7 +7953,7 @@
                     <a:lstStyle/>
                     <a:p>
                       <a:pPr algn="ctr"/>
-                      <a:endParaRPr lang="en-IN" dirty="0"/>
+                      <a:endParaRPr lang="en-IN"/>
                     </a:p>
                   </a:txBody>
                   <a:tcPr/>
@@ -7723,7 +7964,7 @@
                     <a:lstStyle/>
                     <a:p>
                       <a:pPr algn="ctr"/>
-                      <a:endParaRPr lang="en-IN" dirty="0"/>
+                      <a:endParaRPr lang="en-IN"/>
                     </a:p>
                   </a:txBody>
                   <a:tcPr/>
@@ -7738,6 +7979,312 @@
           </a:graphicData>
         </a:graphic>
       </p:graphicFrame>
+      <p:sp>
+        <p:nvSpPr>
+          <p:cNvPr id="4" name="Shape01">
+            <a:extLst>
+              <a:ext uri="{FF2B5EF4-FFF2-40B4-BE49-F238E27FC236}">
+                <a16:creationId xmlns:a16="http://schemas.microsoft.com/office/drawing/2014/main" id="{3693A6A3-E2A6-FE4E-5729-75F6CA7C3D56}"/>
+              </a:ext>
+            </a:extLst>
+          </p:cNvPr>
+          <p:cNvSpPr/>
+          <p:nvPr/>
+        </p:nvSpPr>
+        <p:spPr>
+          <a:xfrm>
+            <a:off x="3043418" y="182301"/>
+            <a:ext cx="287274" cy="304800"/>
+          </a:xfrm>
+          <a:prstGeom prst="ellipse">
+            <a:avLst/>
+          </a:prstGeom>
+        </p:spPr>
+        <p:style>
+          <a:lnRef idx="2">
+            <a:schemeClr val="accent6">
+              <a:shade val="15000"/>
+            </a:schemeClr>
+          </a:lnRef>
+          <a:fillRef idx="1">
+            <a:schemeClr val="accent6"/>
+          </a:fillRef>
+          <a:effectRef idx="0">
+            <a:schemeClr val="accent6"/>
+          </a:effectRef>
+          <a:fontRef idx="minor">
+            <a:schemeClr val="lt1"/>
+          </a:fontRef>
+        </p:style>
+        <p:txBody>
+          <a:bodyPr lIns="91440" tIns="45720" rIns="91440" bIns="45720" rtlCol="0" anchor="ctr"/>
+          <a:lstStyle/>
+          <a:p>
+            <a:pPr algn="ctr"/>
+            <a:endParaRPr lang="en-IN" dirty="0">
+              <a:ea typeface="Calibri"/>
+              <a:cs typeface="Calibri"/>
+            </a:endParaRPr>
+          </a:p>
+        </p:txBody>
+      </p:sp>
+      <p:sp>
+        <p:nvSpPr>
+          <p:cNvPr id="8" name="Shape02">
+            <a:extLst>
+              <a:ext uri="{FF2B5EF4-FFF2-40B4-BE49-F238E27FC236}">
+                <a16:creationId xmlns:a16="http://schemas.microsoft.com/office/drawing/2014/main" id="{EAB81D09-6F97-AF14-0D2D-73C35EC0AB38}"/>
+              </a:ext>
+            </a:extLst>
+          </p:cNvPr>
+          <p:cNvSpPr/>
+          <p:nvPr/>
+        </p:nvSpPr>
+        <p:spPr>
+          <a:xfrm>
+            <a:off x="3727410" y="181457"/>
+            <a:ext cx="287274" cy="304800"/>
+          </a:xfrm>
+          <a:prstGeom prst="ellipse">
+            <a:avLst/>
+          </a:prstGeom>
+        </p:spPr>
+        <p:style>
+          <a:lnRef idx="2">
+            <a:schemeClr val="accent2">
+              <a:shade val="15000"/>
+            </a:schemeClr>
+          </a:lnRef>
+          <a:fillRef idx="1">
+            <a:schemeClr val="accent2"/>
+          </a:fillRef>
+          <a:effectRef idx="0">
+            <a:schemeClr val="accent2"/>
+          </a:effectRef>
+          <a:fontRef idx="minor">
+            <a:schemeClr val="lt1"/>
+          </a:fontRef>
+        </p:style>
+        <p:txBody>
+          <a:bodyPr lIns="91440" tIns="45720" rIns="91440" bIns="45720" rtlCol="0" anchor="ctr"/>
+          <a:lstStyle/>
+          <a:p>
+            <a:pPr algn="ctr"/>
+            <a:endParaRPr lang="en-IN" dirty="0">
+              <a:ea typeface="Calibri"/>
+              <a:cs typeface="Calibri"/>
+            </a:endParaRPr>
+          </a:p>
+        </p:txBody>
+      </p:sp>
+      <p:sp>
+        <p:nvSpPr>
+          <p:cNvPr id="10" name="Shape03">
+            <a:extLst>
+              <a:ext uri="{FF2B5EF4-FFF2-40B4-BE49-F238E27FC236}">
+                <a16:creationId xmlns:a16="http://schemas.microsoft.com/office/drawing/2014/main" id="{94BE44B0-3A2D-FC89-DB70-1072E5444FE9}"/>
+              </a:ext>
+            </a:extLst>
+          </p:cNvPr>
+          <p:cNvSpPr/>
+          <p:nvPr/>
+        </p:nvSpPr>
+        <p:spPr>
+          <a:xfrm>
+            <a:off x="4313663" y="178564"/>
+            <a:ext cx="287274" cy="304800"/>
+          </a:xfrm>
+          <a:prstGeom prst="ellipse">
+            <a:avLst/>
+          </a:prstGeom>
+          <a:solidFill>
+            <a:srgbClr val="00B0F0"/>
+          </a:solidFill>
+        </p:spPr>
+        <p:style>
+          <a:lnRef idx="2">
+            <a:schemeClr val="accent6">
+              <a:shade val="15000"/>
+            </a:schemeClr>
+          </a:lnRef>
+          <a:fillRef idx="1">
+            <a:schemeClr val="accent6"/>
+          </a:fillRef>
+          <a:effectRef idx="0">
+            <a:schemeClr val="accent6"/>
+          </a:effectRef>
+          <a:fontRef idx="minor">
+            <a:schemeClr val="lt1"/>
+          </a:fontRef>
+        </p:style>
+        <p:txBody>
+          <a:bodyPr lIns="91440" tIns="45720" rIns="91440" bIns="45720" rtlCol="0" anchor="ctr"/>
+          <a:lstStyle/>
+          <a:p>
+            <a:pPr algn="ctr"/>
+            <a:endParaRPr lang="en-IN" dirty="0">
+              <a:ea typeface="Calibri"/>
+              <a:cs typeface="Calibri"/>
+            </a:endParaRPr>
+          </a:p>
+        </p:txBody>
+      </p:sp>
+      <p:sp>
+        <p:nvSpPr>
+          <p:cNvPr id="6" name="Shape04">
+            <a:extLst>
+              <a:ext uri="{FF2B5EF4-FFF2-40B4-BE49-F238E27FC236}">
+                <a16:creationId xmlns:a16="http://schemas.microsoft.com/office/drawing/2014/main" id="{92B0CC66-1A22-3704-4B85-F2E218CC1DB7}"/>
+              </a:ext>
+            </a:extLst>
+          </p:cNvPr>
+          <p:cNvSpPr/>
+          <p:nvPr/>
+        </p:nvSpPr>
+        <p:spPr>
+          <a:xfrm>
+            <a:off x="4873105" y="178563"/>
+            <a:ext cx="287274" cy="304800"/>
+          </a:xfrm>
+          <a:prstGeom prst="ellipse">
+            <a:avLst/>
+          </a:prstGeom>
+          <a:solidFill>
+            <a:srgbClr val="FFC000"/>
+          </a:solidFill>
+        </p:spPr>
+        <p:style>
+          <a:lnRef idx="2">
+            <a:schemeClr val="accent6">
+              <a:shade val="15000"/>
+            </a:schemeClr>
+          </a:lnRef>
+          <a:fillRef idx="1">
+            <a:schemeClr val="accent6"/>
+          </a:fillRef>
+          <a:effectRef idx="0">
+            <a:schemeClr val="accent6"/>
+          </a:effectRef>
+          <a:fontRef idx="minor">
+            <a:schemeClr val="lt1"/>
+          </a:fontRef>
+        </p:style>
+        <p:txBody>
+          <a:bodyPr lIns="91440" tIns="45720" rIns="91440" bIns="45720" rtlCol="0" anchor="ctr"/>
+          <a:lstStyle/>
+          <a:p>
+            <a:pPr algn="ctr"/>
+            <a:endParaRPr lang="en-IN" dirty="0">
+              <a:ea typeface="Calibri"/>
+              <a:cs typeface="Calibri"/>
+            </a:endParaRPr>
+          </a:p>
+        </p:txBody>
+      </p:sp>
+      <p:sp>
+        <p:nvSpPr>
+          <p:cNvPr id="9" name="Shape05">
+            <a:extLst>
+              <a:ext uri="{FF2B5EF4-FFF2-40B4-BE49-F238E27FC236}">
+                <a16:creationId xmlns:a16="http://schemas.microsoft.com/office/drawing/2014/main" id="{DEEA9499-0AAE-C967-31EB-0E066BD48ABC}"/>
+              </a:ext>
+            </a:extLst>
+          </p:cNvPr>
+          <p:cNvSpPr/>
+          <p:nvPr/>
+        </p:nvSpPr>
+        <p:spPr>
+          <a:xfrm>
+            <a:off x="5403612" y="178564"/>
+            <a:ext cx="287274" cy="304800"/>
+          </a:xfrm>
+          <a:prstGeom prst="ellipse">
+            <a:avLst/>
+          </a:prstGeom>
+          <a:solidFill>
+            <a:srgbClr val="7030A0"/>
+          </a:solidFill>
+        </p:spPr>
+        <p:style>
+          <a:lnRef idx="2">
+            <a:schemeClr val="accent6">
+              <a:shade val="15000"/>
+            </a:schemeClr>
+          </a:lnRef>
+          <a:fillRef idx="1">
+            <a:schemeClr val="accent6"/>
+          </a:fillRef>
+          <a:effectRef idx="0">
+            <a:schemeClr val="accent6"/>
+          </a:effectRef>
+          <a:fontRef idx="minor">
+            <a:schemeClr val="lt1"/>
+          </a:fontRef>
+        </p:style>
+        <p:txBody>
+          <a:bodyPr lIns="91440" tIns="45720" rIns="91440" bIns="45720" rtlCol="0" anchor="ctr"/>
+          <a:lstStyle/>
+          <a:p>
+            <a:pPr algn="ctr"/>
+            <a:endParaRPr lang="en-IN" dirty="0">
+              <a:ea typeface="Calibri"/>
+              <a:cs typeface="Calibri"/>
+            </a:endParaRPr>
+          </a:p>
+        </p:txBody>
+      </p:sp>
+      <p:sp>
+        <p:nvSpPr>
+          <p:cNvPr id="11" name="Shape06">
+            <a:extLst>
+              <a:ext uri="{FF2B5EF4-FFF2-40B4-BE49-F238E27FC236}">
+                <a16:creationId xmlns:a16="http://schemas.microsoft.com/office/drawing/2014/main" id="{BB6AB5BE-5F58-2384-C0AA-46EADE997667}"/>
+              </a:ext>
+            </a:extLst>
+          </p:cNvPr>
+          <p:cNvSpPr/>
+          <p:nvPr/>
+        </p:nvSpPr>
+        <p:spPr>
+          <a:xfrm>
+            <a:off x="5953409" y="178563"/>
+            <a:ext cx="287274" cy="304800"/>
+          </a:xfrm>
+          <a:prstGeom prst="ellipse">
+            <a:avLst/>
+          </a:prstGeom>
+          <a:solidFill>
+            <a:srgbClr val="002060"/>
+          </a:solidFill>
+        </p:spPr>
+        <p:style>
+          <a:lnRef idx="2">
+            <a:schemeClr val="accent6">
+              <a:shade val="15000"/>
+            </a:schemeClr>
+          </a:lnRef>
+          <a:fillRef idx="1">
+            <a:schemeClr val="accent6"/>
+          </a:fillRef>
+          <a:effectRef idx="0">
+            <a:schemeClr val="accent6"/>
+          </a:effectRef>
+          <a:fontRef idx="minor">
+            <a:schemeClr val="lt1"/>
+          </a:fontRef>
+        </p:style>
+        <p:txBody>
+          <a:bodyPr lIns="91440" tIns="45720" rIns="91440" bIns="45720" rtlCol="0" anchor="ctr"/>
+          <a:lstStyle/>
+          <a:p>
+            <a:pPr algn="ctr"/>
+            <a:endParaRPr lang="en-IN" dirty="0">
+              <a:ea typeface="Calibri"/>
+              <a:cs typeface="Calibri"/>
+            </a:endParaRPr>
+          </a:p>
+        </p:txBody>
+      </p:sp>
     </p:spTree>
     <p:extLst>
       <p:ext uri="{BB962C8B-B14F-4D97-AF65-F5344CB8AC3E}">
@@ -7834,7 +8381,7 @@
           <a:lstStyle/>
           <a:p>
             <a:r>
-              <a:rPr lang="en-US" dirty="0">
+              <a:rPr lang="en-US">
                 <a:latin typeface="Adobe Garamond Pro Bold" panose="02020702060506020403" pitchFamily="18" charset="0"/>
               </a:rPr>
               <a:t>Series 1</a:t>
@@ -7871,7 +8418,7 @@
           <a:lstStyle/>
           <a:p>
             <a:r>
-              <a:rPr lang="en-US" sz="3200" dirty="0"/>
+              <a:rPr lang="en-US" sz="3200"/>
               <a:t>Series 2</a:t>
             </a:r>
           </a:p>
@@ -7906,7 +8453,7 @@
           <a:lstStyle/>
           <a:p>
             <a:r>
-              <a:rPr lang="en-US" dirty="0"/>
+              <a:rPr lang="en-US"/>
               <a:t>Series 3</a:t>
             </a:r>
           </a:p>
@@ -7941,11 +8488,11 @@
           <a:lstStyle/>
           <a:p>
             <a:r>
-              <a:rPr lang="en-US" sz="1100" dirty="0"/>
+              <a:rPr lang="en-US" sz="1100"/>
               <a:t>Series</a:t>
             </a:r>
             <a:r>
-              <a:rPr lang="en-US" dirty="0"/>
+              <a:rPr lang="en-US"/>
               <a:t> 4</a:t>
             </a:r>
           </a:p>
@@ -8009,21 +8556,21 @@
           <a:lstStyle/>
           <a:p>
             <a:r>
-              <a:rPr lang="en-US" dirty="0">
+              <a:rPr lang="en-US">
                 <a:latin typeface="Adobe Fan Heiti Std B" panose="020B0700000000000000" pitchFamily="34" charset="-128"/>
                 <a:ea typeface="Adobe Fan Heiti Std B" panose="020B0700000000000000" pitchFamily="34" charset="-128"/>
               </a:rPr>
               <a:t>1</a:t>
             </a:r>
             <a:r>
-              <a:rPr lang="en-US" baseline="30000" dirty="0">
+              <a:rPr lang="en-US" baseline="30000">
                 <a:latin typeface="Adobe Fan Heiti Std B" panose="020B0700000000000000" pitchFamily="34" charset="-128"/>
                 <a:ea typeface="Adobe Fan Heiti Std B" panose="020B0700000000000000" pitchFamily="34" charset="-128"/>
               </a:rPr>
               <a:t>st</a:t>
             </a:r>
             <a:r>
-              <a:rPr lang="en-US" dirty="0">
+              <a:rPr lang="en-US">
                 <a:latin typeface="Adobe Fan Heiti Std B" panose="020B0700000000000000" pitchFamily="34" charset="-128"/>
                 <a:ea typeface="Adobe Fan Heiti Std B" panose="020B0700000000000000" pitchFamily="34" charset="-128"/>
               </a:rPr>
@@ -8032,19 +8579,19 @@
           </a:p>
           <a:p>
             <a:r>
-              <a:rPr lang="en-US" dirty="0">
+              <a:rPr lang="en-US">
                 <a:latin typeface="Adobe Garamond Pro Bold" panose="02020702060506020403" pitchFamily="18" charset="0"/>
               </a:rPr>
               <a:t>2</a:t>
             </a:r>
             <a:r>
-              <a:rPr lang="en-US" baseline="30000" dirty="0">
+              <a:rPr lang="en-US" baseline="30000">
                 <a:latin typeface="Adobe Garamond Pro Bold" panose="02020702060506020403" pitchFamily="18" charset="0"/>
               </a:rPr>
               <a:t>nd</a:t>
             </a:r>
             <a:r>
-              <a:rPr lang="en-US" dirty="0">
+              <a:rPr lang="en-US">
                 <a:latin typeface="Adobe Garamond Pro Bold" panose="02020702060506020403" pitchFamily="18" charset="0"/>
               </a:rPr>
               <a:t> item</a:t>
@@ -8052,18 +8599,18 @@
           </a:p>
           <a:p>
             <a:r>
-              <a:rPr lang="en-US" sz="1600" dirty="0"/>
+              <a:rPr lang="en-US" sz="1600"/>
               <a:t>3</a:t>
             </a:r>
             <a:r>
-              <a:rPr lang="en-US" sz="1600" baseline="30000" dirty="0"/>
+              <a:rPr lang="en-US" sz="1600" baseline="30000"/>
               <a:t>rd</a:t>
             </a:r>
             <a:r>
-              <a:rPr lang="en-US" sz="1600" dirty="0"/>
+              <a:rPr lang="en-US" sz="1600"/>
               <a:t> item</a:t>
             </a:r>
-            <a:endParaRPr lang="en-IN" sz="1600" dirty="0"/>
+            <a:endParaRPr lang="en-IN" sz="1600"/>
           </a:p>
         </p:txBody>
       </p:sp>

</xml_diff>

<commit_message>
feat: implement core templating engine with support for table and hyperlink management along with sample template files.
</commit_message>
<xml_diff>
--- a/templates/sample.pptx
+++ b/templates/sample.pptx
@@ -125,6 +125,9 @@
           </p14:sldIdLst>
         </p14:section>
       </p14:sectionLst>
+    </p:ext>
+    <p:ext uri="{EFAFB233-063F-42B5-8137-9DF3F51BA10A}">
+      <p15:sldGuideLst xmlns:p15="http://schemas.microsoft.com/office/powerpoint/2012/main"/>
     </p:ext>
   </p:extLst>
 </p:presentation>
@@ -3842,7 +3845,7 @@
           <a:p>
             <a:fld id="{0490EA95-AFA9-47FA-B067-612933D1D62E}" type="datetimeFigureOut">
               <a:rPr lang="en-IN" smtClean="0"/>
-              <a:t>18-06-2026</a:t>
+              <a:t>22-06-2026</a:t>
             </a:fld>
             <a:endParaRPr lang="en-IN"/>
           </a:p>
@@ -4042,7 +4045,7 @@
           <a:p>
             <a:fld id="{0490EA95-AFA9-47FA-B067-612933D1D62E}" type="datetimeFigureOut">
               <a:rPr lang="en-IN" smtClean="0"/>
-              <a:t>18-06-2026</a:t>
+              <a:t>22-06-2026</a:t>
             </a:fld>
             <a:endParaRPr lang="en-IN"/>
           </a:p>
@@ -4252,7 +4255,7 @@
           <a:p>
             <a:fld id="{0490EA95-AFA9-47FA-B067-612933D1D62E}" type="datetimeFigureOut">
               <a:rPr lang="en-IN" smtClean="0"/>
-              <a:t>18-06-2026</a:t>
+              <a:t>22-06-2026</a:t>
             </a:fld>
             <a:endParaRPr lang="en-IN"/>
           </a:p>
@@ -4452,7 +4455,7 @@
           <a:p>
             <a:fld id="{0490EA95-AFA9-47FA-B067-612933D1D62E}" type="datetimeFigureOut">
               <a:rPr lang="en-IN" smtClean="0"/>
-              <a:t>18-06-2026</a:t>
+              <a:t>22-06-2026</a:t>
             </a:fld>
             <a:endParaRPr lang="en-IN"/>
           </a:p>
@@ -4728,7 +4731,7 @@
           <a:p>
             <a:fld id="{0490EA95-AFA9-47FA-B067-612933D1D62E}" type="datetimeFigureOut">
               <a:rPr lang="en-IN" smtClean="0"/>
-              <a:t>18-06-2026</a:t>
+              <a:t>22-06-2026</a:t>
             </a:fld>
             <a:endParaRPr lang="en-IN"/>
           </a:p>
@@ -4996,7 +4999,7 @@
           <a:p>
             <a:fld id="{0490EA95-AFA9-47FA-B067-612933D1D62E}" type="datetimeFigureOut">
               <a:rPr lang="en-IN" smtClean="0"/>
-              <a:t>18-06-2026</a:t>
+              <a:t>22-06-2026</a:t>
             </a:fld>
             <a:endParaRPr lang="en-IN"/>
           </a:p>
@@ -5411,7 +5414,7 @@
           <a:p>
             <a:fld id="{0490EA95-AFA9-47FA-B067-612933D1D62E}" type="datetimeFigureOut">
               <a:rPr lang="en-IN" smtClean="0"/>
-              <a:t>18-06-2026</a:t>
+              <a:t>22-06-2026</a:t>
             </a:fld>
             <a:endParaRPr lang="en-IN"/>
           </a:p>
@@ -5553,7 +5556,7 @@
           <a:p>
             <a:fld id="{0490EA95-AFA9-47FA-B067-612933D1D62E}" type="datetimeFigureOut">
               <a:rPr lang="en-IN" smtClean="0"/>
-              <a:t>18-06-2026</a:t>
+              <a:t>22-06-2026</a:t>
             </a:fld>
             <a:endParaRPr lang="en-IN"/>
           </a:p>
@@ -5666,7 +5669,7 @@
           <a:p>
             <a:fld id="{0490EA95-AFA9-47FA-B067-612933D1D62E}" type="datetimeFigureOut">
               <a:rPr lang="en-IN" smtClean="0"/>
-              <a:t>18-06-2026</a:t>
+              <a:t>22-06-2026</a:t>
             </a:fld>
             <a:endParaRPr lang="en-IN"/>
           </a:p>
@@ -5979,7 +5982,7 @@
           <a:p>
             <a:fld id="{0490EA95-AFA9-47FA-B067-612933D1D62E}" type="datetimeFigureOut">
               <a:rPr lang="en-IN" smtClean="0"/>
-              <a:t>18-06-2026</a:t>
+              <a:t>22-06-2026</a:t>
             </a:fld>
             <a:endParaRPr lang="en-IN"/>
           </a:p>
@@ -6268,7 +6271,7 @@
           <a:p>
             <a:fld id="{0490EA95-AFA9-47FA-B067-612933D1D62E}" type="datetimeFigureOut">
               <a:rPr lang="en-IN" smtClean="0"/>
-              <a:t>18-06-2026</a:t>
+              <a:t>22-06-2026</a:t>
             </a:fld>
             <a:endParaRPr lang="en-IN"/>
           </a:p>
@@ -6511,7 +6514,7 @@
           <a:p>
             <a:fld id="{0490EA95-AFA9-47FA-B067-612933D1D62E}" type="datetimeFigureOut">
               <a:rPr lang="en-IN" smtClean="0"/>
-              <a:t>18-06-2026</a:t>
+              <a:t>22-06-2026</a:t>
             </a:fld>
             <a:endParaRPr lang="en-IN"/>
           </a:p>
@@ -7218,14 +7221,14 @@
             <p:ph idx="1"/>
             <p:extLst>
               <p:ext uri="{D42A27DB-BD31-4B8C-83A1-F6EECF244321}">
-                <p14:modId xmlns:p14="http://schemas.microsoft.com/office/powerpoint/2010/main" val="2181067659"/>
+                <p14:modId xmlns:p14="http://schemas.microsoft.com/office/powerpoint/2010/main" val="3682244565"/>
               </p:ext>
             </p:extLst>
           </p:nvPr>
         </p:nvGraphicFramePr>
         <p:xfrm>
           <a:off x="838200" y="732950"/>
-          <a:ext cx="10515600" cy="2343688"/>
+          <a:ext cx="10515600" cy="1012799"/>
         </p:xfrm>
         <a:graphic>
           <a:graphicData uri="http://schemas.openxmlformats.org/drawingml/2006/table">
@@ -7285,7 +7288,7 @@
                     <a:p>
                       <a:pPr algn="ctr"/>
                       <a:r>
-                        <a:rPr lang="en-IN"/>
+                        <a:rPr lang="en-IN" dirty="0"/>
                         <a:t>A</a:t>
                       </a:r>
                     </a:p>
@@ -7369,7 +7372,7 @@
                   </a:ext>
                 </a:extLst>
               </a:tr>
-              <a:tr h="657616">
+              <a:tr h="641959">
                 <a:tc>
                   <a:txBody>
                     <a:bodyPr/>
@@ -7377,9 +7380,10 @@
                     <a:p>
                       <a:pPr algn="ctr"/>
                       <a:r>
-                        <a:rPr lang="en-IN"/>
+                        <a:rPr lang="en-US" dirty="0"/>
                         <a:t>100</a:t>
                       </a:r>
+                      <a:endParaRPr lang="en-IN" dirty="0"/>
                     </a:p>
                   </a:txBody>
                   <a:tcPr anchor="ctr"/>
@@ -7405,7 +7409,7 @@
                     <a:p>
                       <a:pPr algn="ctr"/>
                       <a:r>
-                        <a:rPr lang="en-IN"/>
+                        <a:rPr lang="en-IN" dirty="0"/>
                         <a:t>24</a:t>
                       </a:r>
                     </a:p>
@@ -7433,7 +7437,7 @@
                     <a:p>
                       <a:pPr algn="ctr"/>
                       <a:r>
-                        <a:rPr lang="en-IN"/>
+                        <a:rPr lang="en-IN" dirty="0"/>
                         <a:t>30</a:t>
                       </a:r>
                     </a:p>
@@ -7447,10 +7451,10 @@
                     <a:p>
                       <a:pPr algn="ctr"/>
                       <a:r>
-                        <a:rPr lang="en-US"/>
+                        <a:rPr lang="en-US" dirty="0"/>
                         <a:t>S</a:t>
                       </a:r>
-                      <a:endParaRPr lang="en-IN"/>
+                      <a:endParaRPr lang="en-IN" dirty="0"/>
                     </a:p>
                   </a:txBody>
                   <a:tcPr anchor="ctr"/>
@@ -7458,194 +7462,6 @@
                 <a:extLst>
                   <a:ext uri="{0D108BD9-81ED-4DB2-BD59-A6C34878D82A}">
                     <a16:rowId xmlns:a16="http://schemas.microsoft.com/office/drawing/2014/main" val="2255589700"/>
-                  </a:ext>
-                </a:extLst>
-              </a:tr>
-              <a:tr h="626301">
-                <a:tc>
-                  <a:txBody>
-                    <a:bodyPr/>
-                    <a:lstStyle/>
-                    <a:p>
-                      <a:pPr algn="ctr"/>
-                      <a:r>
-                        <a:rPr lang="en-IN"/>
-                        <a:t>100</a:t>
-                      </a:r>
-                    </a:p>
-                  </a:txBody>
-                  <a:tcPr anchor="ctr"/>
-                </a:tc>
-                <a:tc>
-                  <a:txBody>
-                    <a:bodyPr/>
-                    <a:lstStyle/>
-                    <a:p>
-                      <a:pPr algn="ctr"/>
-                      <a:r>
-                        <a:rPr lang="en-IN"/>
-                        <a:t>23</a:t>
-                      </a:r>
-                    </a:p>
-                  </a:txBody>
-                  <a:tcPr anchor="ctr"/>
-                </a:tc>
-                <a:tc>
-                  <a:txBody>
-                    <a:bodyPr/>
-                    <a:lstStyle/>
-                    <a:p>
-                      <a:pPr algn="ctr"/>
-                      <a:r>
-                        <a:rPr lang="en-IN"/>
-                        <a:t>24</a:t>
-                      </a:r>
-                    </a:p>
-                  </a:txBody>
-                  <a:tcPr anchor="ctr"/>
-                </a:tc>
-                <a:tc>
-                  <a:txBody>
-                    <a:bodyPr/>
-                    <a:lstStyle/>
-                    <a:p>
-                      <a:pPr algn="ctr"/>
-                      <a:r>
-                        <a:rPr lang="en-IN"/>
-                        <a:t>34</a:t>
-                      </a:r>
-                    </a:p>
-                  </a:txBody>
-                  <a:tcPr anchor="ctr"/>
-                </a:tc>
-                <a:tc>
-                  <a:txBody>
-                    <a:bodyPr/>
-                    <a:lstStyle/>
-                    <a:p>
-                      <a:pPr algn="ctr"/>
-                      <a:r>
-                        <a:rPr lang="en-US"/>
-                        <a:t>5</a:t>
-                      </a:r>
-                      <a:r>
-                        <a:rPr lang="en-IN"/>
-                        <a:t>0</a:t>
-                      </a:r>
-                    </a:p>
-                  </a:txBody>
-                  <a:tcPr anchor="ctr"/>
-                </a:tc>
-                <a:tc>
-                  <a:txBody>
-                    <a:bodyPr/>
-                    <a:lstStyle/>
-                    <a:p>
-                      <a:pPr algn="ctr"/>
-                      <a:r>
-                        <a:rPr lang="en-US"/>
-                        <a:t>F</a:t>
-                      </a:r>
-                      <a:endParaRPr lang="en-IN"/>
-                    </a:p>
-                  </a:txBody>
-                  <a:tcPr anchor="ctr"/>
-                </a:tc>
-                <a:extLst>
-                  <a:ext uri="{0D108BD9-81ED-4DB2-BD59-A6C34878D82A}">
-                    <a16:rowId xmlns:a16="http://schemas.microsoft.com/office/drawing/2014/main" val="3331277678"/>
-                  </a:ext>
-                </a:extLst>
-              </a:tr>
-              <a:tr h="688931">
-                <a:tc>
-                  <a:txBody>
-                    <a:bodyPr/>
-                    <a:lstStyle/>
-                    <a:p>
-                      <a:pPr algn="ctr"/>
-                      <a:r>
-                        <a:rPr lang="en-IN"/>
-                        <a:t>100</a:t>
-                      </a:r>
-                    </a:p>
-                  </a:txBody>
-                  <a:tcPr anchor="ctr"/>
-                </a:tc>
-                <a:tc>
-                  <a:txBody>
-                    <a:bodyPr/>
-                    <a:lstStyle/>
-                    <a:p>
-                      <a:pPr algn="ctr"/>
-                      <a:r>
-                        <a:rPr lang="en-IN"/>
-                        <a:t>23</a:t>
-                      </a:r>
-                    </a:p>
-                  </a:txBody>
-                  <a:tcPr anchor="ctr"/>
-                </a:tc>
-                <a:tc>
-                  <a:txBody>
-                    <a:bodyPr/>
-                    <a:lstStyle/>
-                    <a:p>
-                      <a:pPr algn="ctr"/>
-                      <a:r>
-                        <a:rPr lang="en-IN"/>
-                        <a:t>24</a:t>
-                      </a:r>
-                    </a:p>
-                  </a:txBody>
-                  <a:tcPr anchor="ctr"/>
-                </a:tc>
-                <a:tc>
-                  <a:txBody>
-                    <a:bodyPr/>
-                    <a:lstStyle/>
-                    <a:p>
-                      <a:pPr algn="ctr"/>
-                      <a:r>
-                        <a:rPr lang="en-IN"/>
-                        <a:t>34</a:t>
-                      </a:r>
-                    </a:p>
-                  </a:txBody>
-                  <a:tcPr anchor="ctr"/>
-                </a:tc>
-                <a:tc>
-                  <a:txBody>
-                    <a:bodyPr/>
-                    <a:lstStyle/>
-                    <a:p>
-                      <a:pPr algn="ctr"/>
-                      <a:r>
-                        <a:rPr lang="en-IN"/>
-                        <a:t>80</a:t>
-                      </a:r>
-                    </a:p>
-                  </a:txBody>
-                  <a:tcPr anchor="ctr"/>
-                </a:tc>
-                <a:tc>
-                  <a:txBody>
-                    <a:bodyPr/>
-                    <a:lstStyle/>
-                    <a:p>
-                      <a:pPr algn="ctr"/>
-                      <a:r>
-                        <a:rPr lang="en-US"/>
-                        <a:t>S</a:t>
-                      </a:r>
-                      <a:endParaRPr lang="en-IN"/>
-                    </a:p>
-                  </a:txBody>
-                  <a:tcPr anchor="ctr"/>
-                </a:tc>
-                <a:extLst>
-                  <a:ext uri="{0D108BD9-81ED-4DB2-BD59-A6C34878D82A}">
-                    <a16:rowId xmlns:a16="http://schemas.microsoft.com/office/drawing/2014/main" val="2673184772"/>
                   </a:ext>
                 </a:extLst>
               </a:tr>
@@ -7836,7 +7652,7 @@
                     <a:p>
                       <a:pPr algn="ctr"/>
                       <a:r>
-                        <a:rPr lang="en-IN"/>
+                        <a:rPr lang="en-IN" dirty="0"/>
                         <a:t>100</a:t>
                       </a:r>
                     </a:p>
@@ -7909,10 +7725,10 @@
                     <a:p>
                       <a:pPr algn="ctr"/>
                       <a:r>
-                        <a:rPr lang="en-US"/>
+                        <a:rPr lang="en-US" dirty="0"/>
                         <a:t>55</a:t>
                       </a:r>
-                      <a:endParaRPr lang="en-IN"/>
+                      <a:endParaRPr lang="en-IN" dirty="0"/>
                     </a:p>
                   </a:txBody>
                   <a:tcPr/>
@@ -7964,7 +7780,7 @@
                     <a:lstStyle/>
                     <a:p>
                       <a:pPr algn="ctr"/>
-                      <a:endParaRPr lang="en-IN"/>
+                      <a:endParaRPr lang="en-IN" dirty="0"/>
                     </a:p>
                   </a:txBody>
                   <a:tcPr/>

</xml_diff>

<commit_message>
feat: add sample template files and basic usage example script
</commit_message>
<xml_diff>
--- a/templates/sample.pptx
+++ b/templates/sample.pptx
@@ -10,6 +10,7 @@
     <p:sldId id="258" r:id="rId4"/>
     <p:sldId id="259" r:id="rId5"/>
     <p:sldId id="260" r:id="rId6"/>
+    <p:sldId id="261" r:id="rId7"/>
   </p:sldIdLst>
   <p:sldSz cx="12192000" cy="6858000"/>
   <p:notesSz cx="6858000" cy="9144000"/>
@@ -122,6 +123,7 @@
             <p14:sldId id="258"/>
             <p14:sldId id="259"/>
             <p14:sldId id="260"/>
+            <p14:sldId id="261"/>
           </p14:sldIdLst>
         </p14:section>
       </p14:sectionLst>
@@ -8443,6 +8445,352 @@
 </p:sld>
 </file>
 
+<file path=ppt/slides/slide6.xml><?xml version="1.0" encoding="utf-8"?>
+<p:sld xmlns:a="http://schemas.openxmlformats.org/drawingml/2006/main" xmlns:r="http://schemas.openxmlformats.org/officeDocument/2006/relationships" xmlns:p="http://schemas.openxmlformats.org/presentationml/2006/main">
+  <p:cSld>
+    <p:spTree>
+      <p:nvGrpSpPr>
+        <p:cNvPr id="1" name=""/>
+        <p:cNvGrpSpPr/>
+        <p:nvPr/>
+      </p:nvGrpSpPr>
+      <p:grpSpPr>
+        <a:xfrm>
+          <a:off x="0" y="0"/>
+          <a:ext cx="0" cy="0"/>
+          <a:chOff x="0" y="0"/>
+          <a:chExt cx="0" cy="0"/>
+        </a:xfrm>
+      </p:grpSpPr>
+      <p:graphicFrame>
+        <p:nvGraphicFramePr>
+          <p:cNvPr id="4" name="Table">
+            <a:extLst>
+              <a:ext uri="{FF2B5EF4-FFF2-40B4-BE49-F238E27FC236}">
+                <a16:creationId xmlns:a16="http://schemas.microsoft.com/office/drawing/2014/main" id="{FE7BC075-9F6E-28B2-59E8-8F26920BE7E2}"/>
+              </a:ext>
+            </a:extLst>
+          </p:cNvPr>
+          <p:cNvGraphicFramePr>
+            <a:graphicFrameLocks/>
+          </p:cNvGraphicFramePr>
+          <p:nvPr>
+            <p:extLst>
+              <p:ext uri="{D42A27DB-BD31-4B8C-83A1-F6EECF244321}">
+                <p14:modId xmlns:p14="http://schemas.microsoft.com/office/powerpoint/2010/main" val="1590628668"/>
+              </p:ext>
+            </p:extLst>
+          </p:nvPr>
+        </p:nvGraphicFramePr>
+        <p:xfrm>
+          <a:off x="838199" y="573206"/>
+          <a:ext cx="10789695" cy="736600"/>
+        </p:xfrm>
+        <a:graphic>
+          <a:graphicData uri="http://schemas.openxmlformats.org/drawingml/2006/table">
+            <a:tbl>
+              <a:tblPr firstRow="1" bandRow="1">
+                <a:tableStyleId>{5C22544A-7EE6-4342-B048-85BDC9FD1C3A}</a:tableStyleId>
+              </a:tblPr>
+              <a:tblGrid>
+                <a:gridCol w="1541385">
+                  <a:extLst>
+                    <a:ext uri="{9D8B030D-6E8A-4147-A177-3AD203B41FA5}">
+                      <a16:colId xmlns:a16="http://schemas.microsoft.com/office/drawing/2014/main" val="2779847418"/>
+                    </a:ext>
+                  </a:extLst>
+                </a:gridCol>
+                <a:gridCol w="1541385">
+                  <a:extLst>
+                    <a:ext uri="{9D8B030D-6E8A-4147-A177-3AD203B41FA5}">
+                      <a16:colId xmlns:a16="http://schemas.microsoft.com/office/drawing/2014/main" val="1632793384"/>
+                    </a:ext>
+                  </a:extLst>
+                </a:gridCol>
+                <a:gridCol w="1541385">
+                  <a:extLst>
+                    <a:ext uri="{9D8B030D-6E8A-4147-A177-3AD203B41FA5}">
+                      <a16:colId xmlns:a16="http://schemas.microsoft.com/office/drawing/2014/main" val="3759091533"/>
+                    </a:ext>
+                  </a:extLst>
+                </a:gridCol>
+                <a:gridCol w="1541385">
+                  <a:extLst>
+                    <a:ext uri="{9D8B030D-6E8A-4147-A177-3AD203B41FA5}">
+                      <a16:colId xmlns:a16="http://schemas.microsoft.com/office/drawing/2014/main" val="3854161084"/>
+                    </a:ext>
+                  </a:extLst>
+                </a:gridCol>
+                <a:gridCol w="1541385">
+                  <a:extLst>
+                    <a:ext uri="{9D8B030D-6E8A-4147-A177-3AD203B41FA5}">
+                      <a16:colId xmlns:a16="http://schemas.microsoft.com/office/drawing/2014/main" val="2580032536"/>
+                    </a:ext>
+                  </a:extLst>
+                </a:gridCol>
+                <a:gridCol w="1541385">
+                  <a:extLst>
+                    <a:ext uri="{9D8B030D-6E8A-4147-A177-3AD203B41FA5}">
+                      <a16:colId xmlns:a16="http://schemas.microsoft.com/office/drawing/2014/main" val="3625072384"/>
+                    </a:ext>
+                  </a:extLst>
+                </a:gridCol>
+                <a:gridCol w="1541385">
+                  <a:extLst>
+                    <a:ext uri="{9D8B030D-6E8A-4147-A177-3AD203B41FA5}">
+                      <a16:colId xmlns:a16="http://schemas.microsoft.com/office/drawing/2014/main" val="1242086109"/>
+                    </a:ext>
+                  </a:extLst>
+                </a:gridCol>
+              </a:tblGrid>
+              <a:tr h="286828">
+                <a:tc gridSpan="2">
+                  <a:txBody>
+                    <a:bodyPr/>
+                    <a:lstStyle/>
+                    <a:p>
+                      <a:r>
+                        <a:rPr lang="en-US" dirty="0"/>
+                        <a:t>Team</a:t>
+                      </a:r>
+                      <a:endParaRPr lang="en-IN" dirty="0"/>
+                    </a:p>
+                  </a:txBody>
+                  <a:tcPr anchor="ctr"/>
+                </a:tc>
+                <a:tc hMerge="1">
+                  <a:txBody>
+                    <a:bodyPr/>
+                    <a:lstStyle/>
+                    <a:p>
+                      <a:endParaRPr lang="en-IN" dirty="0"/>
+                    </a:p>
+                  </a:txBody>
+                  <a:tcPr/>
+                </a:tc>
+                <a:tc>
+                  <a:txBody>
+                    <a:bodyPr/>
+                    <a:lstStyle/>
+                    <a:p>
+                      <a:r>
+                        <a:rPr lang="en-US" dirty="0"/>
+                        <a:t>Role</a:t>
+                      </a:r>
+                      <a:endParaRPr lang="en-IN" dirty="0"/>
+                    </a:p>
+                  </a:txBody>
+                  <a:tcPr anchor="ctr"/>
+                </a:tc>
+                <a:tc>
+                  <a:txBody>
+                    <a:bodyPr/>
+                    <a:lstStyle/>
+                    <a:p>
+                      <a:r>
+                        <a:rPr lang="en-US" dirty="0"/>
+                        <a:t>Description</a:t>
+                      </a:r>
+                      <a:endParaRPr lang="en-IN" dirty="0"/>
+                    </a:p>
+                  </a:txBody>
+                  <a:tcPr anchor="ctr"/>
+                </a:tc>
+                <a:tc>
+                  <a:txBody>
+                    <a:bodyPr/>
+                    <a:lstStyle/>
+                    <a:p>
+                      <a:r>
+                        <a:rPr lang="en-US" dirty="0"/>
+                        <a:t>Value</a:t>
+                      </a:r>
+                      <a:endParaRPr lang="en-IN" dirty="0"/>
+                    </a:p>
+                  </a:txBody>
+                  <a:tcPr anchor="ctr"/>
+                </a:tc>
+                <a:tc gridSpan="2">
+                  <a:txBody>
+                    <a:bodyPr/>
+                    <a:lstStyle/>
+                    <a:p>
+                      <a:pPr algn="ctr"/>
+                      <a:r>
+                        <a:rPr lang="en-US" dirty="0"/>
+                        <a:t>Point</a:t>
+                      </a:r>
+                      <a:endParaRPr lang="en-IN" dirty="0"/>
+                    </a:p>
+                  </a:txBody>
+                  <a:tcPr anchor="ctr"/>
+                </a:tc>
+                <a:tc hMerge="1">
+                  <a:txBody>
+                    <a:bodyPr/>
+                    <a:lstStyle/>
+                    <a:p>
+                      <a:endParaRPr lang="en-IN" dirty="0"/>
+                    </a:p>
+                  </a:txBody>
+                  <a:tcPr/>
+                </a:tc>
+                <a:extLst>
+                  <a:ext uri="{0D108BD9-81ED-4DB2-BD59-A6C34878D82A}">
+                    <a16:rowId xmlns:a16="http://schemas.microsoft.com/office/drawing/2014/main" val="1009083968"/>
+                  </a:ext>
+                </a:extLst>
+              </a:tr>
+              <a:tr h="370840">
+                <a:tc>
+                  <a:txBody>
+                    <a:bodyPr/>
+                    <a:lstStyle/>
+                    <a:p>
+                      <a:r>
+                        <a:rPr lang="en-US" dirty="0">
+                          <a:latin typeface="Algerian" panose="04020705040A02060702" pitchFamily="82" charset="0"/>
+                        </a:rPr>
+                        <a:t>S</a:t>
+                      </a:r>
+                      <a:endParaRPr lang="en-IN" dirty="0">
+                        <a:latin typeface="Algerian" panose="04020705040A02060702" pitchFamily="82" charset="0"/>
+                      </a:endParaRPr>
+                    </a:p>
+                  </a:txBody>
+                  <a:tcPr anchor="ctr"/>
+                </a:tc>
+                <a:tc>
+                  <a:txBody>
+                    <a:bodyPr/>
+                    <a:lstStyle/>
+                    <a:p>
+                      <a:r>
+                        <a:rPr lang="en-US" dirty="0">
+                          <a:latin typeface="Algerian" panose="04020705040A02060702" pitchFamily="82" charset="0"/>
+                        </a:rPr>
+                        <a:t>x</a:t>
+                      </a:r>
+                      <a:endParaRPr lang="en-IN" dirty="0">
+                        <a:latin typeface="Algerian" panose="04020705040A02060702" pitchFamily="82" charset="0"/>
+                      </a:endParaRPr>
+                    </a:p>
+                  </a:txBody>
+                  <a:tcPr anchor="ctr"/>
+                </a:tc>
+                <a:tc>
+                  <a:txBody>
+                    <a:bodyPr/>
+                    <a:lstStyle/>
+                    <a:p>
+                      <a:r>
+                        <a:rPr lang="en-US" dirty="0">
+                          <a:latin typeface="Algerian" panose="04020705040A02060702" pitchFamily="82" charset="0"/>
+                        </a:rPr>
+                        <a:t>z</a:t>
+                      </a:r>
+                      <a:endParaRPr lang="en-IN" dirty="0">
+                        <a:latin typeface="Algerian" panose="04020705040A02060702" pitchFamily="82" charset="0"/>
+                      </a:endParaRPr>
+                    </a:p>
+                  </a:txBody>
+                  <a:tcPr anchor="ctr"/>
+                </a:tc>
+                <a:tc>
+                  <a:txBody>
+                    <a:bodyPr/>
+                    <a:lstStyle/>
+                    <a:p>
+                      <a:r>
+                        <a:rPr lang="en-US" sz="1050" dirty="0">
+                          <a:latin typeface="Algerian" panose="04020705040A02060702" pitchFamily="82" charset="0"/>
+                        </a:rPr>
+                        <a:t>d</a:t>
+                      </a:r>
+                      <a:endParaRPr lang="en-IN" sz="1050" dirty="0">
+                        <a:latin typeface="Algerian" panose="04020705040A02060702" pitchFamily="82" charset="0"/>
+                      </a:endParaRPr>
+                    </a:p>
+                  </a:txBody>
+                  <a:tcPr anchor="ctr"/>
+                </a:tc>
+                <a:tc>
+                  <a:txBody>
+                    <a:bodyPr/>
+                    <a:lstStyle/>
+                    <a:p>
+                      <a:r>
+                        <a:rPr lang="en-US" dirty="0">
+                          <a:latin typeface="Algerian" panose="04020705040A02060702" pitchFamily="82" charset="0"/>
+                        </a:rPr>
+                        <a:t>a</a:t>
+                      </a:r>
+                      <a:endParaRPr lang="en-IN" dirty="0">
+                        <a:latin typeface="Algerian" panose="04020705040A02060702" pitchFamily="82" charset="0"/>
+                      </a:endParaRPr>
+                    </a:p>
+                  </a:txBody>
+                  <a:tcPr anchor="ctr"/>
+                </a:tc>
+                <a:tc>
+                  <a:txBody>
+                    <a:bodyPr/>
+                    <a:lstStyle/>
+                    <a:p>
+                      <a:r>
+                        <a:rPr lang="en-US" dirty="0">
+                          <a:latin typeface="Algerian" panose="04020705040A02060702" pitchFamily="82" charset="0"/>
+                        </a:rPr>
+                        <a:t>V</a:t>
+                      </a:r>
+                      <a:endParaRPr lang="en-IN" dirty="0">
+                        <a:latin typeface="Algerian" panose="04020705040A02060702" pitchFamily="82" charset="0"/>
+                      </a:endParaRPr>
+                    </a:p>
+                  </a:txBody>
+                  <a:tcPr anchor="ctr"/>
+                </a:tc>
+                <a:tc>
+                  <a:txBody>
+                    <a:bodyPr/>
+                    <a:lstStyle/>
+                    <a:p>
+                      <a:r>
+                        <a:rPr lang="en-US" dirty="0">
+                          <a:latin typeface="Algerian" panose="04020705040A02060702" pitchFamily="82" charset="0"/>
+                        </a:rPr>
+                        <a:t>V</a:t>
+                      </a:r>
+                      <a:endParaRPr lang="en-IN" dirty="0">
+                        <a:latin typeface="Algerian" panose="04020705040A02060702" pitchFamily="82" charset="0"/>
+                      </a:endParaRPr>
+                    </a:p>
+                  </a:txBody>
+                  <a:tcPr anchor="ctr"/>
+                </a:tc>
+                <a:extLst>
+                  <a:ext uri="{0D108BD9-81ED-4DB2-BD59-A6C34878D82A}">
+                    <a16:rowId xmlns:a16="http://schemas.microsoft.com/office/drawing/2014/main" val="3519732806"/>
+                  </a:ext>
+                </a:extLst>
+              </a:tr>
+            </a:tbl>
+          </a:graphicData>
+        </a:graphic>
+      </p:graphicFrame>
+    </p:spTree>
+    <p:extLst>
+      <p:ext uri="{BB962C8B-B14F-4D97-AF65-F5344CB8AC3E}">
+        <p14:creationId xmlns:p14="http://schemas.microsoft.com/office/powerpoint/2010/main" val="4217125532"/>
+      </p:ext>
+    </p:extLst>
+  </p:cSld>
+  <p:clrMapOvr>
+    <a:masterClrMapping/>
+  </p:clrMapOvr>
+</p:sld>
+</file>
+
 <file path=ppt/theme/theme1.xml><?xml version="1.0" encoding="utf-8"?>
 <a:theme xmlns:a="http://schemas.openxmlformats.org/drawingml/2006/main" name="Office Theme">
   <a:themeElements>

</xml_diff>

<commit_message>
feat: implement TableManager, core PPTX templater logic, and add sample slide assets
</commit_message>
<xml_diff>
--- a/templates/sample.pptx
+++ b/templates/sample.pptx
@@ -3847,7 +3847,7 @@
           <a:p>
             <a:fld id="{0490EA95-AFA9-47FA-B067-612933D1D62E}" type="datetimeFigureOut">
               <a:rPr lang="en-IN" smtClean="0"/>
-              <a:t>22-06-2026</a:t>
+              <a:t>23-06-2026</a:t>
             </a:fld>
             <a:endParaRPr lang="en-IN"/>
           </a:p>
@@ -4047,7 +4047,7 @@
           <a:p>
             <a:fld id="{0490EA95-AFA9-47FA-B067-612933D1D62E}" type="datetimeFigureOut">
               <a:rPr lang="en-IN" smtClean="0"/>
-              <a:t>22-06-2026</a:t>
+              <a:t>23-06-2026</a:t>
             </a:fld>
             <a:endParaRPr lang="en-IN"/>
           </a:p>
@@ -4257,7 +4257,7 @@
           <a:p>
             <a:fld id="{0490EA95-AFA9-47FA-B067-612933D1D62E}" type="datetimeFigureOut">
               <a:rPr lang="en-IN" smtClean="0"/>
-              <a:t>22-06-2026</a:t>
+              <a:t>23-06-2026</a:t>
             </a:fld>
             <a:endParaRPr lang="en-IN"/>
           </a:p>
@@ -4457,7 +4457,7 @@
           <a:p>
             <a:fld id="{0490EA95-AFA9-47FA-B067-612933D1D62E}" type="datetimeFigureOut">
               <a:rPr lang="en-IN" smtClean="0"/>
-              <a:t>22-06-2026</a:t>
+              <a:t>23-06-2026</a:t>
             </a:fld>
             <a:endParaRPr lang="en-IN"/>
           </a:p>
@@ -4733,7 +4733,7 @@
           <a:p>
             <a:fld id="{0490EA95-AFA9-47FA-B067-612933D1D62E}" type="datetimeFigureOut">
               <a:rPr lang="en-IN" smtClean="0"/>
-              <a:t>22-06-2026</a:t>
+              <a:t>23-06-2026</a:t>
             </a:fld>
             <a:endParaRPr lang="en-IN"/>
           </a:p>
@@ -5001,7 +5001,7 @@
           <a:p>
             <a:fld id="{0490EA95-AFA9-47FA-B067-612933D1D62E}" type="datetimeFigureOut">
               <a:rPr lang="en-IN" smtClean="0"/>
-              <a:t>22-06-2026</a:t>
+              <a:t>23-06-2026</a:t>
             </a:fld>
             <a:endParaRPr lang="en-IN"/>
           </a:p>
@@ -5416,7 +5416,7 @@
           <a:p>
             <a:fld id="{0490EA95-AFA9-47FA-B067-612933D1D62E}" type="datetimeFigureOut">
               <a:rPr lang="en-IN" smtClean="0"/>
-              <a:t>22-06-2026</a:t>
+              <a:t>23-06-2026</a:t>
             </a:fld>
             <a:endParaRPr lang="en-IN"/>
           </a:p>
@@ -5558,7 +5558,7 @@
           <a:p>
             <a:fld id="{0490EA95-AFA9-47FA-B067-612933D1D62E}" type="datetimeFigureOut">
               <a:rPr lang="en-IN" smtClean="0"/>
-              <a:t>22-06-2026</a:t>
+              <a:t>23-06-2026</a:t>
             </a:fld>
             <a:endParaRPr lang="en-IN"/>
           </a:p>
@@ -5671,7 +5671,7 @@
           <a:p>
             <a:fld id="{0490EA95-AFA9-47FA-B067-612933D1D62E}" type="datetimeFigureOut">
               <a:rPr lang="en-IN" smtClean="0"/>
-              <a:t>22-06-2026</a:t>
+              <a:t>23-06-2026</a:t>
             </a:fld>
             <a:endParaRPr lang="en-IN"/>
           </a:p>
@@ -5984,7 +5984,7 @@
           <a:p>
             <a:fld id="{0490EA95-AFA9-47FA-B067-612933D1D62E}" type="datetimeFigureOut">
               <a:rPr lang="en-IN" smtClean="0"/>
-              <a:t>22-06-2026</a:t>
+              <a:t>23-06-2026</a:t>
             </a:fld>
             <a:endParaRPr lang="en-IN"/>
           </a:p>
@@ -6273,7 +6273,7 @@
           <a:p>
             <a:fld id="{0490EA95-AFA9-47FA-B067-612933D1D62E}" type="datetimeFigureOut">
               <a:rPr lang="en-IN" smtClean="0"/>
-              <a:t>22-06-2026</a:t>
+              <a:t>23-06-2026</a:t>
             </a:fld>
             <a:endParaRPr lang="en-IN"/>
           </a:p>
@@ -6516,7 +6516,7 @@
           <a:p>
             <a:fld id="{0490EA95-AFA9-47FA-B067-612933D1D62E}" type="datetimeFigureOut">
               <a:rPr lang="en-IN" smtClean="0"/>
-              <a:t>22-06-2026</a:t>
+              <a:t>23-06-2026</a:t>
             </a:fld>
             <a:endParaRPr lang="en-IN"/>
           </a:p>
@@ -8477,14 +8477,14 @@
           <p:nvPr>
             <p:extLst>
               <p:ext uri="{D42A27DB-BD31-4B8C-83A1-F6EECF244321}">
-                <p14:modId xmlns:p14="http://schemas.microsoft.com/office/powerpoint/2010/main" val="1590628668"/>
+                <p14:modId xmlns:p14="http://schemas.microsoft.com/office/powerpoint/2010/main" val="3500558840"/>
               </p:ext>
             </p:extLst>
           </p:nvPr>
         </p:nvGraphicFramePr>
         <p:xfrm>
           <a:off x="838199" y="573206"/>
-          <a:ext cx="10789695" cy="736600"/>
+          <a:ext cx="10789696" cy="736600"/>
         </p:xfrm>
         <a:graphic>
           <a:graphicData uri="http://schemas.openxmlformats.org/drawingml/2006/table">
@@ -8493,49 +8493,56 @@
                 <a:tableStyleId>{5C22544A-7EE6-4342-B048-85BDC9FD1C3A}</a:tableStyleId>
               </a:tblPr>
               <a:tblGrid>
-                <a:gridCol w="1541385">
+                <a:gridCol w="1348712">
                   <a:extLst>
                     <a:ext uri="{9D8B030D-6E8A-4147-A177-3AD203B41FA5}">
                       <a16:colId xmlns:a16="http://schemas.microsoft.com/office/drawing/2014/main" val="2779847418"/>
                     </a:ext>
                   </a:extLst>
                 </a:gridCol>
-                <a:gridCol w="1541385">
+                <a:gridCol w="1348712">
                   <a:extLst>
                     <a:ext uri="{9D8B030D-6E8A-4147-A177-3AD203B41FA5}">
                       <a16:colId xmlns:a16="http://schemas.microsoft.com/office/drawing/2014/main" val="1632793384"/>
                     </a:ext>
                   </a:extLst>
                 </a:gridCol>
-                <a:gridCol w="1541385">
+                <a:gridCol w="1348712">
+                  <a:extLst>
+                    <a:ext uri="{9D8B030D-6E8A-4147-A177-3AD203B41FA5}">
+                      <a16:colId xmlns:a16="http://schemas.microsoft.com/office/drawing/2014/main" val="2032430761"/>
+                    </a:ext>
+                  </a:extLst>
+                </a:gridCol>
+                <a:gridCol w="1348712">
                   <a:extLst>
                     <a:ext uri="{9D8B030D-6E8A-4147-A177-3AD203B41FA5}">
                       <a16:colId xmlns:a16="http://schemas.microsoft.com/office/drawing/2014/main" val="3759091533"/>
                     </a:ext>
                   </a:extLst>
                 </a:gridCol>
-                <a:gridCol w="1541385">
+                <a:gridCol w="1348712">
                   <a:extLst>
                     <a:ext uri="{9D8B030D-6E8A-4147-A177-3AD203B41FA5}">
                       <a16:colId xmlns:a16="http://schemas.microsoft.com/office/drawing/2014/main" val="3854161084"/>
                     </a:ext>
                   </a:extLst>
                 </a:gridCol>
-                <a:gridCol w="1541385">
+                <a:gridCol w="1348712">
                   <a:extLst>
                     <a:ext uri="{9D8B030D-6E8A-4147-A177-3AD203B41FA5}">
                       <a16:colId xmlns:a16="http://schemas.microsoft.com/office/drawing/2014/main" val="2580032536"/>
                     </a:ext>
                   </a:extLst>
                 </a:gridCol>
-                <a:gridCol w="1541385">
+                <a:gridCol w="1348712">
                   <a:extLst>
                     <a:ext uri="{9D8B030D-6E8A-4147-A177-3AD203B41FA5}">
                       <a16:colId xmlns:a16="http://schemas.microsoft.com/office/drawing/2014/main" val="3625072384"/>
                     </a:ext>
                   </a:extLst>
                 </a:gridCol>
-                <a:gridCol w="1541385">
+                <a:gridCol w="1348712">
                   <a:extLst>
                     <a:ext uri="{9D8B030D-6E8A-4147-A177-3AD203B41FA5}">
                       <a16:colId xmlns:a16="http://schemas.microsoft.com/office/drawing/2014/main" val="1242086109"/>
@@ -8567,6 +8574,20 @@
                     </a:p>
                   </a:txBody>
                   <a:tcPr/>
+                </a:tc>
+                <a:tc>
+                  <a:txBody>
+                    <a:bodyPr/>
+                    <a:lstStyle/>
+                    <a:p>
+                      <a:r>
+                        <a:rPr lang="en-US" dirty="0"/>
+                        <a:t>Name</a:t>
+                      </a:r>
+                      <a:endParaRPr lang="en-IN" dirty="0"/>
+                    </a:p>
+                  </a:txBody>
+                  <a:tcPr anchor="ctr"/>
                 </a:tc>
                 <a:tc>
                   <a:txBody>
@@ -8687,6 +8708,24 @@
                         <a:rPr lang="en-US" dirty="0">
                           <a:latin typeface="Algerian" panose="04020705040A02060702" pitchFamily="82" charset="0"/>
                         </a:rPr>
+                        <a:t>A</a:t>
+                      </a:r>
+                      <a:endParaRPr lang="en-IN" dirty="0">
+                        <a:latin typeface="Algerian" panose="04020705040A02060702" pitchFamily="82" charset="0"/>
+                      </a:endParaRPr>
+                    </a:p>
+                  </a:txBody>
+                  <a:tcPr anchor="ctr"/>
+                </a:tc>
+                <a:tc>
+                  <a:txBody>
+                    <a:bodyPr/>
+                    <a:lstStyle/>
+                    <a:p>
+                      <a:r>
+                        <a:rPr lang="en-US" dirty="0">
+                          <a:latin typeface="Algerian" panose="04020705040A02060702" pitchFamily="82" charset="0"/>
+                        </a:rPr>
                         <a:t>z</a:t>
                       </a:r>
                       <a:endParaRPr lang="en-IN" dirty="0">
@@ -8702,12 +8741,12 @@
                     <a:lstStyle/>
                     <a:p>
                       <a:r>
-                        <a:rPr lang="en-US" sz="1050" dirty="0">
+                        <a:rPr lang="en-US" sz="1800" dirty="0">
                           <a:latin typeface="Algerian" panose="04020705040A02060702" pitchFamily="82" charset="0"/>
                         </a:rPr>
                         <a:t>d</a:t>
                       </a:r>
-                      <a:endParaRPr lang="en-IN" sz="1050" dirty="0">
+                      <a:endParaRPr lang="en-IN" sz="1800" dirty="0">
                         <a:latin typeface="Algerian" panose="04020705040A02060702" pitchFamily="82" charset="0"/>
                       </a:endParaRPr>
                     </a:p>
@@ -8778,6 +8817,130 @@
           </a:graphicData>
         </a:graphic>
       </p:graphicFrame>
+      <p:sp>
+        <p:nvSpPr>
+          <p:cNvPr id="2" name="Team A Logo">
+            <a:extLst>
+              <a:ext uri="{FF2B5EF4-FFF2-40B4-BE49-F238E27FC236}">
+                <a16:creationId xmlns:a16="http://schemas.microsoft.com/office/drawing/2014/main" id="{40CE57F1-956F-4695-F427-6DECEE6DFC90}"/>
+              </a:ext>
+            </a:extLst>
+          </p:cNvPr>
+          <p:cNvSpPr/>
+          <p:nvPr/>
+        </p:nvSpPr>
+        <p:spPr>
+          <a:xfrm>
+            <a:off x="-358439" y="2082600"/>
+            <a:ext cx="716878" cy="814509"/>
+          </a:xfrm>
+          <a:prstGeom prst="rect">
+            <a:avLst/>
+          </a:prstGeom>
+          <a:blipFill dpi="0" rotWithShape="1">
+            <a:blip r:embed="rId2">
+              <a:extLst>
+                <a:ext uri="{28A0092B-C50C-407E-A947-70E740481C1C}">
+                  <a14:useLocalDpi xmlns:a14="http://schemas.microsoft.com/office/drawing/2010/main" val="0"/>
+                </a:ext>
+              </a:extLst>
+            </a:blip>
+            <a:srcRect/>
+            <a:stretch>
+              <a:fillRect/>
+            </a:stretch>
+          </a:blipFill>
+          <a:ln>
+            <a:noFill/>
+          </a:ln>
+        </p:spPr>
+        <p:style>
+          <a:lnRef idx="2">
+            <a:schemeClr val="accent1">
+              <a:shade val="15000"/>
+            </a:schemeClr>
+          </a:lnRef>
+          <a:fillRef idx="1">
+            <a:schemeClr val="accent1"/>
+          </a:fillRef>
+          <a:effectRef idx="0">
+            <a:schemeClr val="accent1"/>
+          </a:effectRef>
+          <a:fontRef idx="minor">
+            <a:schemeClr val="lt1"/>
+          </a:fontRef>
+        </p:style>
+        <p:txBody>
+          <a:bodyPr rtlCol="0" anchor="ctr"/>
+          <a:lstStyle/>
+          <a:p>
+            <a:pPr algn="ctr"/>
+            <a:endParaRPr lang="en-IN"/>
+          </a:p>
+        </p:txBody>
+      </p:sp>
+      <p:sp>
+        <p:nvSpPr>
+          <p:cNvPr id="3" name="Team B Logo">
+            <a:extLst>
+              <a:ext uri="{FF2B5EF4-FFF2-40B4-BE49-F238E27FC236}">
+                <a16:creationId xmlns:a16="http://schemas.microsoft.com/office/drawing/2014/main" id="{42DD75CE-B87B-A2AB-E9D6-A94D891FA961}"/>
+              </a:ext>
+            </a:extLst>
+          </p:cNvPr>
+          <p:cNvSpPr/>
+          <p:nvPr/>
+        </p:nvSpPr>
+        <p:spPr>
+          <a:xfrm>
+            <a:off x="-420986" y="3241443"/>
+            <a:ext cx="841972" cy="814509"/>
+          </a:xfrm>
+          <a:prstGeom prst="rect">
+            <a:avLst/>
+          </a:prstGeom>
+          <a:blipFill dpi="0" rotWithShape="1">
+            <a:blip r:embed="rId3">
+              <a:extLst>
+                <a:ext uri="{28A0092B-C50C-407E-A947-70E740481C1C}">
+                  <a14:useLocalDpi xmlns:a14="http://schemas.microsoft.com/office/drawing/2010/main" val="0"/>
+                </a:ext>
+              </a:extLst>
+            </a:blip>
+            <a:srcRect/>
+            <a:stretch>
+              <a:fillRect/>
+            </a:stretch>
+          </a:blipFill>
+          <a:ln>
+            <a:noFill/>
+          </a:ln>
+        </p:spPr>
+        <p:style>
+          <a:lnRef idx="2">
+            <a:schemeClr val="accent1">
+              <a:shade val="15000"/>
+            </a:schemeClr>
+          </a:lnRef>
+          <a:fillRef idx="1">
+            <a:schemeClr val="accent1"/>
+          </a:fillRef>
+          <a:effectRef idx="0">
+            <a:schemeClr val="accent1"/>
+          </a:effectRef>
+          <a:fontRef idx="minor">
+            <a:schemeClr val="lt1"/>
+          </a:fontRef>
+        </p:style>
+        <p:txBody>
+          <a:bodyPr rtlCol="0" anchor="ctr"/>
+          <a:lstStyle/>
+          <a:p>
+            <a:pPr algn="ctr"/>
+            <a:endParaRPr lang="en-IN"/>
+          </a:p>
+        </p:txBody>
+      </p:sp>
     </p:spTree>
     <p:extLst>
       <p:ext uri="{BB962C8B-B14F-4D97-AF65-F5344CB8AC3E}">

</xml_diff>

<commit_message>
feat: add SlideManager and integration test for slide synchronization with sample templates
</commit_message>
<xml_diff>
--- a/templates/sample.pptx
+++ b/templates/sample.pptx
@@ -4,6 +4,9 @@
   <p:sldMasterIdLst>
     <p:sldMasterId id="2147483648" r:id="rId1"/>
   </p:sldMasterIdLst>
+  <p:notesMasterIdLst>
+    <p:notesMasterId r:id="rId8"/>
+  </p:notesMasterIdLst>
   <p:sldIdLst>
     <p:sldId id="256" r:id="rId2"/>
     <p:sldId id="257" r:id="rId3"/>
@@ -3698,6 +3701,356 @@
 </cs:chartStyle>
 </file>
 
+<file path=ppt/notesMasters/notesMaster1.xml><?xml version="1.0" encoding="utf-8"?>
+<p:notesMaster xmlns:a="http://schemas.openxmlformats.org/drawingml/2006/main" xmlns:r="http://schemas.openxmlformats.org/officeDocument/2006/relationships" xmlns:p="http://schemas.openxmlformats.org/presentationml/2006/main">
+  <p:cSld>
+    <p:bg>
+      <p:bgRef idx="1001">
+        <a:schemeClr val="bg1"/>
+      </p:bgRef>
+    </p:bg>
+    <p:spTree>
+      <p:nvGrpSpPr>
+        <p:cNvPr id="1" name=""/>
+        <p:cNvGrpSpPr/>
+        <p:nvPr/>
+      </p:nvGrpSpPr>
+      <p:grpSpPr>
+        <a:xfrm>
+          <a:off x="0" y="0"/>
+          <a:ext cx="0" cy="0"/>
+          <a:chOff x="0" y="0"/>
+          <a:chExt cx="0" cy="0"/>
+        </a:xfrm>
+      </p:grpSpPr>
+      <p:sp>
+        <p:nvSpPr>
+          <p:cNvPr id="2" name="Header Placeholder 1"/>
+          <p:cNvSpPr>
+            <a:spLocks noGrp="1"/>
+          </p:cNvSpPr>
+          <p:nvPr>
+            <p:ph type="hdr" sz="quarter"/>
+          </p:nvPr>
+        </p:nvSpPr>
+        <p:spPr>
+          <a:xfrm>
+            <a:off x="0" y="0"/>
+            <a:ext cx="2971800" cy="458788"/>
+          </a:xfrm>
+          <a:prstGeom prst="rect">
+            <a:avLst/>
+          </a:prstGeom>
+        </p:spPr>
+        <p:txBody>
+          <a:bodyPr vert="horz" lIns="91440" tIns="45720" rIns="91440" bIns="45720" rtlCol="0"/>
+          <a:lstStyle>
+            <a:lvl1pPr algn="l">
+              <a:defRPr sz="1200"/>
+            </a:lvl1pPr>
+          </a:lstStyle>
+          <a:p>
+            <a:endParaRPr lang="en-IN"/>
+          </a:p>
+        </p:txBody>
+      </p:sp>
+      <p:sp>
+        <p:nvSpPr>
+          <p:cNvPr id="3" name="Date Placeholder 2"/>
+          <p:cNvSpPr>
+            <a:spLocks noGrp="1"/>
+          </p:cNvSpPr>
+          <p:nvPr>
+            <p:ph type="dt" idx="1"/>
+          </p:nvPr>
+        </p:nvSpPr>
+        <p:spPr>
+          <a:xfrm>
+            <a:off x="3884613" y="0"/>
+            <a:ext cx="2971800" cy="458788"/>
+          </a:xfrm>
+          <a:prstGeom prst="rect">
+            <a:avLst/>
+          </a:prstGeom>
+        </p:spPr>
+        <p:txBody>
+          <a:bodyPr vert="horz" lIns="91440" tIns="45720" rIns="91440" bIns="45720" rtlCol="0"/>
+          <a:lstStyle>
+            <a:lvl1pPr algn="r">
+              <a:defRPr sz="1200"/>
+            </a:lvl1pPr>
+          </a:lstStyle>
+          <a:p>
+            <a:fld id="{8B1AF6D7-0F32-4F05-B21A-8AF0CB26F94C}" type="datetimeFigureOut">
+              <a:rPr lang="en-IN" smtClean="0"/>
+              <a:t>26-06-2026</a:t>
+            </a:fld>
+            <a:endParaRPr lang="en-IN"/>
+          </a:p>
+        </p:txBody>
+      </p:sp>
+      <p:sp>
+        <p:nvSpPr>
+          <p:cNvPr id="4" name="Slide Image Placeholder 3"/>
+          <p:cNvSpPr>
+            <a:spLocks noGrp="1" noRot="1" noChangeAspect="1"/>
+          </p:cNvSpPr>
+          <p:nvPr>
+            <p:ph type="sldImg" idx="2"/>
+          </p:nvPr>
+        </p:nvSpPr>
+        <p:spPr>
+          <a:xfrm>
+            <a:off x="685800" y="1143000"/>
+            <a:ext cx="5486400" cy="3086100"/>
+          </a:xfrm>
+          <a:prstGeom prst="rect">
+            <a:avLst/>
+          </a:prstGeom>
+          <a:noFill/>
+          <a:ln w="12700">
+            <a:solidFill>
+              <a:prstClr val="black"/>
+            </a:solidFill>
+          </a:ln>
+        </p:spPr>
+        <p:txBody>
+          <a:bodyPr vert="horz" lIns="91440" tIns="45720" rIns="91440" bIns="45720" rtlCol="0" anchor="ctr"/>
+          <a:lstStyle/>
+          <a:p>
+            <a:endParaRPr lang="en-IN"/>
+          </a:p>
+        </p:txBody>
+      </p:sp>
+      <p:sp>
+        <p:nvSpPr>
+          <p:cNvPr id="5" name="Notes Placeholder 4"/>
+          <p:cNvSpPr>
+            <a:spLocks noGrp="1"/>
+          </p:cNvSpPr>
+          <p:nvPr>
+            <p:ph type="body" sz="quarter" idx="3"/>
+          </p:nvPr>
+        </p:nvSpPr>
+        <p:spPr>
+          <a:xfrm>
+            <a:off x="685800" y="4400550"/>
+            <a:ext cx="5486400" cy="3600450"/>
+          </a:xfrm>
+          <a:prstGeom prst="rect">
+            <a:avLst/>
+          </a:prstGeom>
+        </p:spPr>
+        <p:txBody>
+          <a:bodyPr vert="horz" lIns="91440" tIns="45720" rIns="91440" bIns="45720" rtlCol="0"/>
+          <a:lstStyle/>
+          <a:p>
+            <a:pPr lvl="0"/>
+            <a:r>
+              <a:rPr lang="en-US"/>
+              <a:t>Click to edit Master text styles</a:t>
+            </a:r>
+          </a:p>
+          <a:p>
+            <a:pPr lvl="1"/>
+            <a:r>
+              <a:rPr lang="en-US"/>
+              <a:t>Second level</a:t>
+            </a:r>
+          </a:p>
+          <a:p>
+            <a:pPr lvl="2"/>
+            <a:r>
+              <a:rPr lang="en-US"/>
+              <a:t>Third level</a:t>
+            </a:r>
+          </a:p>
+          <a:p>
+            <a:pPr lvl="3"/>
+            <a:r>
+              <a:rPr lang="en-US"/>
+              <a:t>Fourth level</a:t>
+            </a:r>
+          </a:p>
+          <a:p>
+            <a:pPr lvl="4"/>
+            <a:r>
+              <a:rPr lang="en-US"/>
+              <a:t>Fifth level</a:t>
+            </a:r>
+            <a:endParaRPr lang="en-IN"/>
+          </a:p>
+        </p:txBody>
+      </p:sp>
+      <p:sp>
+        <p:nvSpPr>
+          <p:cNvPr id="6" name="Footer Placeholder 5"/>
+          <p:cNvSpPr>
+            <a:spLocks noGrp="1"/>
+          </p:cNvSpPr>
+          <p:nvPr>
+            <p:ph type="ftr" sz="quarter" idx="4"/>
+          </p:nvPr>
+        </p:nvSpPr>
+        <p:spPr>
+          <a:xfrm>
+            <a:off x="0" y="8685213"/>
+            <a:ext cx="2971800" cy="458787"/>
+          </a:xfrm>
+          <a:prstGeom prst="rect">
+            <a:avLst/>
+          </a:prstGeom>
+        </p:spPr>
+        <p:txBody>
+          <a:bodyPr vert="horz" lIns="91440" tIns="45720" rIns="91440" bIns="45720" rtlCol="0" anchor="b"/>
+          <a:lstStyle>
+            <a:lvl1pPr algn="l">
+              <a:defRPr sz="1200"/>
+            </a:lvl1pPr>
+          </a:lstStyle>
+          <a:p>
+            <a:endParaRPr lang="en-IN"/>
+          </a:p>
+        </p:txBody>
+      </p:sp>
+      <p:sp>
+        <p:nvSpPr>
+          <p:cNvPr id="7" name="Slide Number Placeholder 6"/>
+          <p:cNvSpPr>
+            <a:spLocks noGrp="1"/>
+          </p:cNvSpPr>
+          <p:nvPr>
+            <p:ph type="sldNum" sz="quarter" idx="5"/>
+          </p:nvPr>
+        </p:nvSpPr>
+        <p:spPr>
+          <a:xfrm>
+            <a:off x="3884613" y="8685213"/>
+            <a:ext cx="2971800" cy="458787"/>
+          </a:xfrm>
+          <a:prstGeom prst="rect">
+            <a:avLst/>
+          </a:prstGeom>
+        </p:spPr>
+        <p:txBody>
+          <a:bodyPr vert="horz" lIns="91440" tIns="45720" rIns="91440" bIns="45720" rtlCol="0" anchor="b"/>
+          <a:lstStyle>
+            <a:lvl1pPr algn="r">
+              <a:defRPr sz="1200"/>
+            </a:lvl1pPr>
+          </a:lstStyle>
+          <a:p>
+            <a:fld id="{F849BE13-E5DD-4ADC-A243-D0627F8BD02D}" type="slidenum">
+              <a:rPr lang="en-IN" smtClean="0"/>
+              <a:t>‹#›</a:t>
+            </a:fld>
+            <a:endParaRPr lang="en-IN"/>
+          </a:p>
+        </p:txBody>
+      </p:sp>
+    </p:spTree>
+    <p:extLst>
+      <p:ext uri="{BB962C8B-B14F-4D97-AF65-F5344CB8AC3E}">
+        <p14:creationId xmlns:p14="http://schemas.microsoft.com/office/powerpoint/2010/main" val="125510801"/>
+      </p:ext>
+    </p:extLst>
+  </p:cSld>
+  <p:clrMap bg1="lt1" tx1="dk1" bg2="lt2" tx2="dk2" accent1="accent1" accent2="accent2" accent3="accent3" accent4="accent4" accent5="accent5" accent6="accent6" hlink="hlink" folHlink="folHlink"/>
+  <p:notesStyle>
+    <a:lvl1pPr marL="0" algn="l" defTabSz="914400" rtl="0" eaLnBrk="1" latinLnBrk="0" hangingPunct="1">
+      <a:defRPr sz="1200" kern="1200">
+        <a:solidFill>
+          <a:schemeClr val="tx1"/>
+        </a:solidFill>
+        <a:latin typeface="+mn-lt"/>
+        <a:ea typeface="+mn-ea"/>
+        <a:cs typeface="+mn-cs"/>
+      </a:defRPr>
+    </a:lvl1pPr>
+    <a:lvl2pPr marL="457200" algn="l" defTabSz="914400" rtl="0" eaLnBrk="1" latinLnBrk="0" hangingPunct="1">
+      <a:defRPr sz="1200" kern="1200">
+        <a:solidFill>
+          <a:schemeClr val="tx1"/>
+        </a:solidFill>
+        <a:latin typeface="+mn-lt"/>
+        <a:ea typeface="+mn-ea"/>
+        <a:cs typeface="+mn-cs"/>
+      </a:defRPr>
+    </a:lvl2pPr>
+    <a:lvl3pPr marL="914400" algn="l" defTabSz="914400" rtl="0" eaLnBrk="1" latinLnBrk="0" hangingPunct="1">
+      <a:defRPr sz="1200" kern="1200">
+        <a:solidFill>
+          <a:schemeClr val="tx1"/>
+        </a:solidFill>
+        <a:latin typeface="+mn-lt"/>
+        <a:ea typeface="+mn-ea"/>
+        <a:cs typeface="+mn-cs"/>
+      </a:defRPr>
+    </a:lvl3pPr>
+    <a:lvl4pPr marL="1371600" algn="l" defTabSz="914400" rtl="0" eaLnBrk="1" latinLnBrk="0" hangingPunct="1">
+      <a:defRPr sz="1200" kern="1200">
+        <a:solidFill>
+          <a:schemeClr val="tx1"/>
+        </a:solidFill>
+        <a:latin typeface="+mn-lt"/>
+        <a:ea typeface="+mn-ea"/>
+        <a:cs typeface="+mn-cs"/>
+      </a:defRPr>
+    </a:lvl4pPr>
+    <a:lvl5pPr marL="1828800" algn="l" defTabSz="914400" rtl="0" eaLnBrk="1" latinLnBrk="0" hangingPunct="1">
+      <a:defRPr sz="1200" kern="1200">
+        <a:solidFill>
+          <a:schemeClr val="tx1"/>
+        </a:solidFill>
+        <a:latin typeface="+mn-lt"/>
+        <a:ea typeface="+mn-ea"/>
+        <a:cs typeface="+mn-cs"/>
+      </a:defRPr>
+    </a:lvl5pPr>
+    <a:lvl6pPr marL="2286000" algn="l" defTabSz="914400" rtl="0" eaLnBrk="1" latinLnBrk="0" hangingPunct="1">
+      <a:defRPr sz="1200" kern="1200">
+        <a:solidFill>
+          <a:schemeClr val="tx1"/>
+        </a:solidFill>
+        <a:latin typeface="+mn-lt"/>
+        <a:ea typeface="+mn-ea"/>
+        <a:cs typeface="+mn-cs"/>
+      </a:defRPr>
+    </a:lvl6pPr>
+    <a:lvl7pPr marL="2743200" algn="l" defTabSz="914400" rtl="0" eaLnBrk="1" latinLnBrk="0" hangingPunct="1">
+      <a:defRPr sz="1200" kern="1200">
+        <a:solidFill>
+          <a:schemeClr val="tx1"/>
+        </a:solidFill>
+        <a:latin typeface="+mn-lt"/>
+        <a:ea typeface="+mn-ea"/>
+        <a:cs typeface="+mn-cs"/>
+      </a:defRPr>
+    </a:lvl7pPr>
+    <a:lvl8pPr marL="3200400" algn="l" defTabSz="914400" rtl="0" eaLnBrk="1" latinLnBrk="0" hangingPunct="1">
+      <a:defRPr sz="1200" kern="1200">
+        <a:solidFill>
+          <a:schemeClr val="tx1"/>
+        </a:solidFill>
+        <a:latin typeface="+mn-lt"/>
+        <a:ea typeface="+mn-ea"/>
+        <a:cs typeface="+mn-cs"/>
+      </a:defRPr>
+    </a:lvl8pPr>
+    <a:lvl9pPr marL="3657600" algn="l" defTabSz="914400" rtl="0" eaLnBrk="1" latinLnBrk="0" hangingPunct="1">
+      <a:defRPr sz="1200" kern="1200">
+        <a:solidFill>
+          <a:schemeClr val="tx1"/>
+        </a:solidFill>
+        <a:latin typeface="+mn-lt"/>
+        <a:ea typeface="+mn-ea"/>
+        <a:cs typeface="+mn-cs"/>
+      </a:defRPr>
+    </a:lvl9pPr>
+  </p:notesStyle>
+</p:notesMaster>
+</file>
+
 <file path=ppt/slideLayouts/slideLayout1.xml><?xml version="1.0" encoding="utf-8"?>
 <p:sldLayout xmlns:a="http://schemas.openxmlformats.org/drawingml/2006/main" xmlns:r="http://schemas.openxmlformats.org/officeDocument/2006/relationships" xmlns:p="http://schemas.openxmlformats.org/presentationml/2006/main" type="title" preserve="1">
   <p:cSld name="Title Slide">
@@ -3847,7 +4200,7 @@
           <a:p>
             <a:fld id="{0490EA95-AFA9-47FA-B067-612933D1D62E}" type="datetimeFigureOut">
               <a:rPr lang="en-IN" smtClean="0"/>
-              <a:t>23-06-2026</a:t>
+              <a:t>26-06-2026</a:t>
             </a:fld>
             <a:endParaRPr lang="en-IN"/>
           </a:p>
@@ -4047,7 +4400,7 @@
           <a:p>
             <a:fld id="{0490EA95-AFA9-47FA-B067-612933D1D62E}" type="datetimeFigureOut">
               <a:rPr lang="en-IN" smtClean="0"/>
-              <a:t>23-06-2026</a:t>
+              <a:t>26-06-2026</a:t>
             </a:fld>
             <a:endParaRPr lang="en-IN"/>
           </a:p>
@@ -4257,7 +4610,7 @@
           <a:p>
             <a:fld id="{0490EA95-AFA9-47FA-B067-612933D1D62E}" type="datetimeFigureOut">
               <a:rPr lang="en-IN" smtClean="0"/>
-              <a:t>23-06-2026</a:t>
+              <a:t>26-06-2026</a:t>
             </a:fld>
             <a:endParaRPr lang="en-IN"/>
           </a:p>
@@ -4457,7 +4810,7 @@
           <a:p>
             <a:fld id="{0490EA95-AFA9-47FA-B067-612933D1D62E}" type="datetimeFigureOut">
               <a:rPr lang="en-IN" smtClean="0"/>
-              <a:t>23-06-2026</a:t>
+              <a:t>26-06-2026</a:t>
             </a:fld>
             <a:endParaRPr lang="en-IN"/>
           </a:p>
@@ -4733,7 +5086,7 @@
           <a:p>
             <a:fld id="{0490EA95-AFA9-47FA-B067-612933D1D62E}" type="datetimeFigureOut">
               <a:rPr lang="en-IN" smtClean="0"/>
-              <a:t>23-06-2026</a:t>
+              <a:t>26-06-2026</a:t>
             </a:fld>
             <a:endParaRPr lang="en-IN"/>
           </a:p>
@@ -5001,7 +5354,7 @@
           <a:p>
             <a:fld id="{0490EA95-AFA9-47FA-B067-612933D1D62E}" type="datetimeFigureOut">
               <a:rPr lang="en-IN" smtClean="0"/>
-              <a:t>23-06-2026</a:t>
+              <a:t>26-06-2026</a:t>
             </a:fld>
             <a:endParaRPr lang="en-IN"/>
           </a:p>
@@ -5416,7 +5769,7 @@
           <a:p>
             <a:fld id="{0490EA95-AFA9-47FA-B067-612933D1D62E}" type="datetimeFigureOut">
               <a:rPr lang="en-IN" smtClean="0"/>
-              <a:t>23-06-2026</a:t>
+              <a:t>26-06-2026</a:t>
             </a:fld>
             <a:endParaRPr lang="en-IN"/>
           </a:p>
@@ -5558,7 +5911,7 @@
           <a:p>
             <a:fld id="{0490EA95-AFA9-47FA-B067-612933D1D62E}" type="datetimeFigureOut">
               <a:rPr lang="en-IN" smtClean="0"/>
-              <a:t>23-06-2026</a:t>
+              <a:t>26-06-2026</a:t>
             </a:fld>
             <a:endParaRPr lang="en-IN"/>
           </a:p>
@@ -5671,7 +6024,7 @@
           <a:p>
             <a:fld id="{0490EA95-AFA9-47FA-B067-612933D1D62E}" type="datetimeFigureOut">
               <a:rPr lang="en-IN" smtClean="0"/>
-              <a:t>23-06-2026</a:t>
+              <a:t>26-06-2026</a:t>
             </a:fld>
             <a:endParaRPr lang="en-IN"/>
           </a:p>
@@ -5984,7 +6337,7 @@
           <a:p>
             <a:fld id="{0490EA95-AFA9-47FA-B067-612933D1D62E}" type="datetimeFigureOut">
               <a:rPr lang="en-IN" smtClean="0"/>
-              <a:t>23-06-2026</a:t>
+              <a:t>26-06-2026</a:t>
             </a:fld>
             <a:endParaRPr lang="en-IN"/>
           </a:p>
@@ -6273,7 +6626,7 @@
           <a:p>
             <a:fld id="{0490EA95-AFA9-47FA-B067-612933D1D62E}" type="datetimeFigureOut">
               <a:rPr lang="en-IN" smtClean="0"/>
-              <a:t>23-06-2026</a:t>
+              <a:t>26-06-2026</a:t>
             </a:fld>
             <a:endParaRPr lang="en-IN"/>
           </a:p>
@@ -6516,7 +6869,7 @@
           <a:p>
             <a:fld id="{0490EA95-AFA9-47FA-B067-612933D1D62E}" type="datetimeFigureOut">
               <a:rPr lang="en-IN" smtClean="0"/>
-              <a:t>23-06-2026</a:t>
+              <a:t>26-06-2026</a:t>
             </a:fld>
             <a:endParaRPr lang="en-IN"/>
           </a:p>
@@ -8941,6 +9294,113 @@
           </a:p>
         </p:txBody>
       </p:sp>
+      <p:grpSp>
+        <p:nvGrpSpPr>
+          <p:cNvPr id="12" name="Group 11">
+            <a:extLst>
+              <a:ext uri="{FF2B5EF4-FFF2-40B4-BE49-F238E27FC236}">
+                <a16:creationId xmlns:a16="http://schemas.microsoft.com/office/drawing/2014/main" id="{6E73F588-E744-219B-242D-94136B11BABD}"/>
+              </a:ext>
+            </a:extLst>
+          </p:cNvPr>
+          <p:cNvGrpSpPr/>
+          <p:nvPr/>
+        </p:nvGrpSpPr>
+        <p:grpSpPr>
+          <a:xfrm>
+            <a:off x="10092818" y="159766"/>
+            <a:ext cx="977638" cy="261610"/>
+            <a:chOff x="3759200" y="5085720"/>
+            <a:chExt cx="977638" cy="261610"/>
+          </a:xfrm>
+        </p:grpSpPr>
+        <p:sp>
+          <p:nvSpPr>
+            <p:cNvPr id="10" name="Rectangle 9">
+              <a:extLst>
+                <a:ext uri="{FF2B5EF4-FFF2-40B4-BE49-F238E27FC236}">
+                  <a16:creationId xmlns:a16="http://schemas.microsoft.com/office/drawing/2014/main" id="{6CC3860F-6365-EF4D-D168-C842F01149A9}"/>
+                </a:ext>
+              </a:extLst>
+            </p:cNvPr>
+            <p:cNvSpPr/>
+            <p:nvPr/>
+          </p:nvSpPr>
+          <p:spPr>
+            <a:xfrm>
+              <a:off x="3759200" y="5143500"/>
+              <a:ext cx="336550" cy="146050"/>
+            </a:xfrm>
+            <a:prstGeom prst="rect">
+              <a:avLst/>
+            </a:prstGeom>
+          </p:spPr>
+          <p:style>
+            <a:lnRef idx="2">
+              <a:schemeClr val="accent1">
+                <a:shade val="15000"/>
+              </a:schemeClr>
+            </a:lnRef>
+            <a:fillRef idx="1">
+              <a:schemeClr val="accent1"/>
+            </a:fillRef>
+            <a:effectRef idx="0">
+              <a:schemeClr val="accent1"/>
+            </a:effectRef>
+            <a:fontRef idx="minor">
+              <a:schemeClr val="lt1"/>
+            </a:fontRef>
+          </p:style>
+          <p:txBody>
+            <a:bodyPr rtlCol="0" anchor="ctr"/>
+            <a:lstStyle/>
+            <a:p>
+              <a:pPr algn="ctr"/>
+              <a:r>
+                <a:rPr lang="en-US" sz="800" dirty="0"/>
+                <a:t>CA</a:t>
+              </a:r>
+              <a:endParaRPr lang="en-IN" sz="800" dirty="0"/>
+            </a:p>
+          </p:txBody>
+        </p:sp>
+        <p:sp>
+          <p:nvSpPr>
+            <p:cNvPr id="11" name="TextBox 10">
+              <a:extLst>
+                <a:ext uri="{FF2B5EF4-FFF2-40B4-BE49-F238E27FC236}">
+                  <a16:creationId xmlns:a16="http://schemas.microsoft.com/office/drawing/2014/main" id="{E1149580-D805-5ABB-11D1-98485224CF6C}"/>
+                </a:ext>
+              </a:extLst>
+            </p:cNvPr>
+            <p:cNvSpPr txBox="1"/>
+            <p:nvPr/>
+          </p:nvSpPr>
+          <p:spPr>
+            <a:xfrm>
+              <a:off x="4140200" y="5085720"/>
+              <a:ext cx="596638" cy="261610"/>
+            </a:xfrm>
+            <a:prstGeom prst="rect">
+              <a:avLst/>
+            </a:prstGeom>
+            <a:noFill/>
+          </p:spPr>
+          <p:txBody>
+            <a:bodyPr wrap="none" rtlCol="0">
+              <a:spAutoFit/>
+            </a:bodyPr>
+            <a:lstStyle/>
+            <a:p>
+              <a:r>
+                <a:rPr lang="en-US" sz="1100" dirty="0"/>
+                <a:t>Testing</a:t>
+              </a:r>
+              <a:endParaRPr lang="en-IN" sz="1100" dirty="0"/>
+            </a:p>
+          </p:txBody>
+        </p:sp>
+      </p:grpSp>
     </p:spTree>
     <p:extLst>
       <p:ext uri="{BB962C8B-B14F-4D97-AF65-F5344CB8AC3E}">
@@ -9247,4 +9707,299 @@
     </a:ext>
   </a:extLst>
 </a:theme>
+</file>
+
+<file path=ppt/theme/theme2.xml><?xml version="1.0" encoding="utf-8"?>
+<a:theme xmlns:a="http://schemas.openxmlformats.org/drawingml/2006/main" name="Office Theme">
+  <a:themeElements>
+    <a:clrScheme name="Office">
+      <a:dk1>
+        <a:sysClr val="windowText" lastClr="000000"/>
+      </a:dk1>
+      <a:lt1>
+        <a:sysClr val="window" lastClr="FFFFFF"/>
+      </a:lt1>
+      <a:dk2>
+        <a:srgbClr val="44546A"/>
+      </a:dk2>
+      <a:lt2>
+        <a:srgbClr val="E7E6E6"/>
+      </a:lt2>
+      <a:accent1>
+        <a:srgbClr val="4472C4"/>
+      </a:accent1>
+      <a:accent2>
+        <a:srgbClr val="ED7D31"/>
+      </a:accent2>
+      <a:accent3>
+        <a:srgbClr val="A5A5A5"/>
+      </a:accent3>
+      <a:accent4>
+        <a:srgbClr val="FFC000"/>
+      </a:accent4>
+      <a:accent5>
+        <a:srgbClr val="5B9BD5"/>
+      </a:accent5>
+      <a:accent6>
+        <a:srgbClr val="70AD47"/>
+      </a:accent6>
+      <a:hlink>
+        <a:srgbClr val="0563C1"/>
+      </a:hlink>
+      <a:folHlink>
+        <a:srgbClr val="954F72"/>
+      </a:folHlink>
+    </a:clrScheme>
+    <a:fontScheme name="Office">
+      <a:majorFont>
+        <a:latin typeface="Calibri Light" panose="020F0302020204030204"/>
+        <a:ea typeface=""/>
+        <a:cs typeface=""/>
+        <a:font script="Jpan" typeface="游ゴシック Light"/>
+        <a:font script="Hang" typeface="맑은 고딕"/>
+        <a:font script="Hans" typeface="等线 Light"/>
+        <a:font script="Hant" typeface="新細明體"/>
+        <a:font script="Arab" typeface="Times New Roman"/>
+        <a:font script="Hebr" typeface="Times New Roman"/>
+        <a:font script="Thai" typeface="Angsana New"/>
+        <a:font script="Ethi" typeface="Nyala"/>
+        <a:font script="Beng" typeface="Vrinda"/>
+        <a:font script="Gujr" typeface="Shruti"/>
+        <a:font script="Khmr" typeface="MoolBoran"/>
+        <a:font script="Knda" typeface="Tunga"/>
+        <a:font script="Guru" typeface="Raavi"/>
+        <a:font script="Cans" typeface="Euphemia"/>
+        <a:font script="Cher" typeface="Plantagenet Cherokee"/>
+        <a:font script="Yiii" typeface="Microsoft Yi Baiti"/>
+        <a:font script="Tibt" typeface="Microsoft Himalaya"/>
+        <a:font script="Thaa" typeface="MV Boli"/>
+        <a:font script="Deva" typeface="Mangal"/>
+        <a:font script="Telu" typeface="Gautami"/>
+        <a:font script="Taml" typeface="Latha"/>
+        <a:font script="Syrc" typeface="Estrangelo Edessa"/>
+        <a:font script="Orya" typeface="Kalinga"/>
+        <a:font script="Mlym" typeface="Kartika"/>
+        <a:font script="Laoo" typeface="DokChampa"/>
+        <a:font script="Sinh" typeface="Iskoola Pota"/>
+        <a:font script="Mong" typeface="Mongolian Baiti"/>
+        <a:font script="Viet" typeface="Times New Roman"/>
+        <a:font script="Uigh" typeface="Microsoft Uighur"/>
+        <a:font script="Geor" typeface="Sylfaen"/>
+        <a:font script="Armn" typeface="Arial"/>
+        <a:font script="Bugi" typeface="Leelawadee UI"/>
+        <a:font script="Bopo" typeface="Microsoft JhengHei"/>
+        <a:font script="Java" typeface="Javanese Text"/>
+        <a:font script="Lisu" typeface="Segoe UI"/>
+        <a:font script="Mymr" typeface="Myanmar Text"/>
+        <a:font script="Nkoo" typeface="Ebrima"/>
+        <a:font script="Olck" typeface="Nirmala UI"/>
+        <a:font script="Osma" typeface="Ebrima"/>
+        <a:font script="Phag" typeface="Phagspa"/>
+        <a:font script="Syrn" typeface="Estrangelo Edessa"/>
+        <a:font script="Syrj" typeface="Estrangelo Edessa"/>
+        <a:font script="Syre" typeface="Estrangelo Edessa"/>
+        <a:font script="Sora" typeface="Nirmala UI"/>
+        <a:font script="Tale" typeface="Microsoft Tai Le"/>
+        <a:font script="Talu" typeface="Microsoft New Tai Lue"/>
+        <a:font script="Tfng" typeface="Ebrima"/>
+      </a:majorFont>
+      <a:minorFont>
+        <a:latin typeface="Calibri" panose="020F0502020204030204"/>
+        <a:ea typeface=""/>
+        <a:cs typeface=""/>
+        <a:font script="Jpan" typeface="游ゴシック"/>
+        <a:font script="Hang" typeface="맑은 고딕"/>
+        <a:font script="Hans" typeface="等线"/>
+        <a:font script="Hant" typeface="新細明體"/>
+        <a:font script="Arab" typeface="Arial"/>
+        <a:font script="Hebr" typeface="Arial"/>
+        <a:font script="Thai" typeface="Cordia New"/>
+        <a:font script="Ethi" typeface="Nyala"/>
+        <a:font script="Beng" typeface="Vrinda"/>
+        <a:font script="Gujr" typeface="Shruti"/>
+        <a:font script="Khmr" typeface="DaunPenh"/>
+        <a:font script="Knda" typeface="Tunga"/>
+        <a:font script="Guru" typeface="Raavi"/>
+        <a:font script="Cans" typeface="Euphemia"/>
+        <a:font script="Cher" typeface="Plantagenet Cherokee"/>
+        <a:font script="Yiii" typeface="Microsoft Yi Baiti"/>
+        <a:font script="Tibt" typeface="Microsoft Himalaya"/>
+        <a:font script="Thaa" typeface="MV Boli"/>
+        <a:font script="Deva" typeface="Mangal"/>
+        <a:font script="Telu" typeface="Gautami"/>
+        <a:font script="Taml" typeface="Latha"/>
+        <a:font script="Syrc" typeface="Estrangelo Edessa"/>
+        <a:font script="Orya" typeface="Kalinga"/>
+        <a:font script="Mlym" typeface="Kartika"/>
+        <a:font script="Laoo" typeface="DokChampa"/>
+        <a:font script="Sinh" typeface="Iskoola Pota"/>
+        <a:font script="Mong" typeface="Mongolian Baiti"/>
+        <a:font script="Viet" typeface="Arial"/>
+        <a:font script="Uigh" typeface="Microsoft Uighur"/>
+        <a:font script="Geor" typeface="Sylfaen"/>
+        <a:font script="Armn" typeface="Arial"/>
+        <a:font script="Bugi" typeface="Leelawadee UI"/>
+        <a:font script="Bopo" typeface="Microsoft JhengHei"/>
+        <a:font script="Java" typeface="Javanese Text"/>
+        <a:font script="Lisu" typeface="Segoe UI"/>
+        <a:font script="Mymr" typeface="Myanmar Text"/>
+        <a:font script="Nkoo" typeface="Ebrima"/>
+        <a:font script="Olck" typeface="Nirmala UI"/>
+        <a:font script="Osma" typeface="Ebrima"/>
+        <a:font script="Phag" typeface="Phagspa"/>
+        <a:font script="Syrn" typeface="Estrangelo Edessa"/>
+        <a:font script="Syrj" typeface="Estrangelo Edessa"/>
+        <a:font script="Syre" typeface="Estrangelo Edessa"/>
+        <a:font script="Sora" typeface="Nirmala UI"/>
+        <a:font script="Tale" typeface="Microsoft Tai Le"/>
+        <a:font script="Talu" typeface="Microsoft New Tai Lue"/>
+        <a:font script="Tfng" typeface="Ebrima"/>
+      </a:minorFont>
+    </a:fontScheme>
+    <a:fmtScheme name="Office">
+      <a:fillStyleLst>
+        <a:solidFill>
+          <a:schemeClr val="phClr"/>
+        </a:solidFill>
+        <a:gradFill rotWithShape="1">
+          <a:gsLst>
+            <a:gs pos="0">
+              <a:schemeClr val="phClr">
+                <a:lumMod val="110000"/>
+                <a:satMod val="105000"/>
+                <a:tint val="67000"/>
+              </a:schemeClr>
+            </a:gs>
+            <a:gs pos="50000">
+              <a:schemeClr val="phClr">
+                <a:lumMod val="105000"/>
+                <a:satMod val="103000"/>
+                <a:tint val="73000"/>
+              </a:schemeClr>
+            </a:gs>
+            <a:gs pos="100000">
+              <a:schemeClr val="phClr">
+                <a:lumMod val="105000"/>
+                <a:satMod val="109000"/>
+                <a:tint val="81000"/>
+              </a:schemeClr>
+            </a:gs>
+          </a:gsLst>
+          <a:lin ang="5400000" scaled="0"/>
+        </a:gradFill>
+        <a:gradFill rotWithShape="1">
+          <a:gsLst>
+            <a:gs pos="0">
+              <a:schemeClr val="phClr">
+                <a:satMod val="103000"/>
+                <a:lumMod val="102000"/>
+                <a:tint val="94000"/>
+              </a:schemeClr>
+            </a:gs>
+            <a:gs pos="50000">
+              <a:schemeClr val="phClr">
+                <a:satMod val="110000"/>
+                <a:lumMod val="100000"/>
+                <a:shade val="100000"/>
+              </a:schemeClr>
+            </a:gs>
+            <a:gs pos="100000">
+              <a:schemeClr val="phClr">
+                <a:lumMod val="99000"/>
+                <a:satMod val="120000"/>
+                <a:shade val="78000"/>
+              </a:schemeClr>
+            </a:gs>
+          </a:gsLst>
+          <a:lin ang="5400000" scaled="0"/>
+        </a:gradFill>
+      </a:fillStyleLst>
+      <a:lnStyleLst>
+        <a:ln w="6350" cap="flat" cmpd="sng" algn="ctr">
+          <a:solidFill>
+            <a:schemeClr val="phClr"/>
+          </a:solidFill>
+          <a:prstDash val="solid"/>
+          <a:miter lim="800000"/>
+        </a:ln>
+        <a:ln w="12700" cap="flat" cmpd="sng" algn="ctr">
+          <a:solidFill>
+            <a:schemeClr val="phClr"/>
+          </a:solidFill>
+          <a:prstDash val="solid"/>
+          <a:miter lim="800000"/>
+        </a:ln>
+        <a:ln w="19050" cap="flat" cmpd="sng" algn="ctr">
+          <a:solidFill>
+            <a:schemeClr val="phClr"/>
+          </a:solidFill>
+          <a:prstDash val="solid"/>
+          <a:miter lim="800000"/>
+        </a:ln>
+      </a:lnStyleLst>
+      <a:effectStyleLst>
+        <a:effectStyle>
+          <a:effectLst/>
+        </a:effectStyle>
+        <a:effectStyle>
+          <a:effectLst/>
+        </a:effectStyle>
+        <a:effectStyle>
+          <a:effectLst>
+            <a:outerShdw blurRad="57150" dist="19050" dir="5400000" algn="ctr" rotWithShape="0">
+              <a:srgbClr val="000000">
+                <a:alpha val="63000"/>
+              </a:srgbClr>
+            </a:outerShdw>
+          </a:effectLst>
+        </a:effectStyle>
+      </a:effectStyleLst>
+      <a:bgFillStyleLst>
+        <a:solidFill>
+          <a:schemeClr val="phClr"/>
+        </a:solidFill>
+        <a:solidFill>
+          <a:schemeClr val="phClr">
+            <a:tint val="95000"/>
+            <a:satMod val="170000"/>
+          </a:schemeClr>
+        </a:solidFill>
+        <a:gradFill rotWithShape="1">
+          <a:gsLst>
+            <a:gs pos="0">
+              <a:schemeClr val="phClr">
+                <a:tint val="93000"/>
+                <a:satMod val="150000"/>
+                <a:shade val="98000"/>
+                <a:lumMod val="102000"/>
+              </a:schemeClr>
+            </a:gs>
+            <a:gs pos="50000">
+              <a:schemeClr val="phClr">
+                <a:tint val="98000"/>
+                <a:satMod val="130000"/>
+                <a:shade val="90000"/>
+                <a:lumMod val="103000"/>
+              </a:schemeClr>
+            </a:gs>
+            <a:gs pos="100000">
+              <a:schemeClr val="phClr">
+                <a:shade val="63000"/>
+                <a:satMod val="120000"/>
+              </a:schemeClr>
+            </a:gs>
+          </a:gsLst>
+          <a:lin ang="5400000" scaled="0"/>
+        </a:gradFill>
+      </a:bgFillStyleLst>
+    </a:fmtScheme>
+  </a:themeElements>
+  <a:objectDefaults/>
+  <a:extraClrSchemeLst/>
+  <a:extLst>
+    <a:ext uri="{05A4C25C-085E-4340-85A3-A5531E510DB2}">
+      <thm15:themeFamily xmlns:thm15="http://schemas.microsoft.com/office/thememl/2012/main" name="Office Theme" id="{62F939B6-93AF-4DB8-9C6B-D6C7DFDC589F}" vid="{4A3C46E8-61CC-4603-A589-7422A47A8E4A}"/>
+    </a:ext>
+  </a:extLst>
+</a:theme>
 </file>
</xml_diff>